<commit_message>
docs: record verified build and scoring checks
</commit_message>
<xml_diff>
--- a/submission/GoWise-GeoAI-Hackathon-2026-Submission.pptx
+++ b/submission/GoWise-GeoAI-Hackathon-2026-Submission.pptx
@@ -2,17 +2,17 @@
 <file path=ppt/presentation.xml><?xml version="1.0" encoding="utf-8"?>
 <p:presentation xmlns:p="http://schemas.openxmlformats.org/presentationml/2006/main">
   <p:sldMasterIdLst>
-    <p:sldMasterId xmlns:r="http://schemas.openxmlformats.org/officeDocument/2006/relationships" id="2147483648" r:id="R9e626443a6ef481c"/>
+    <p:sldMasterId xmlns:r="http://schemas.openxmlformats.org/officeDocument/2006/relationships" id="2147483648" r:id="R3e683f53d35c40b1"/>
   </p:sldMasterIdLst>
   <p:notesMasterIdLst>
-    <p:notesMasterId xmlns:r="http://schemas.openxmlformats.org/officeDocument/2006/relationships" r:id="R50b56d99fbf14e43"/>
+    <p:notesMasterId xmlns:r="http://schemas.openxmlformats.org/officeDocument/2006/relationships" r:id="R6e847c3133ad4651"/>
   </p:notesMasterIdLst>
   <p:sldIdLst>
-    <p:sldId xmlns:r="http://schemas.openxmlformats.org/officeDocument/2006/relationships" id="256" r:id="R93215a3e691e43cb"/>
-    <p:sldId xmlns:r="http://schemas.openxmlformats.org/officeDocument/2006/relationships" id="257" r:id="R9dff5b15e57743b6"/>
-    <p:sldId xmlns:r="http://schemas.openxmlformats.org/officeDocument/2006/relationships" id="258" r:id="Ra44ab77357a04635"/>
-    <p:sldId xmlns:r="http://schemas.openxmlformats.org/officeDocument/2006/relationships" id="259" r:id="R9911a97a283c4a12"/>
-    <p:sldId xmlns:r="http://schemas.openxmlformats.org/officeDocument/2006/relationships" id="260" r:id="Ra513df459da74589"/>
+    <p:sldId xmlns:r="http://schemas.openxmlformats.org/officeDocument/2006/relationships" id="256" r:id="R41336f0e56de480f"/>
+    <p:sldId xmlns:r="http://schemas.openxmlformats.org/officeDocument/2006/relationships" id="257" r:id="R7c9a4fb3ea754c64"/>
+    <p:sldId xmlns:r="http://schemas.openxmlformats.org/officeDocument/2006/relationships" id="258" r:id="R3748f542d55b467f"/>
+    <p:sldId xmlns:r="http://schemas.openxmlformats.org/officeDocument/2006/relationships" id="259" r:id="R7a5501349b0a467e"/>
+    <p:sldId xmlns:r="http://schemas.openxmlformats.org/officeDocument/2006/relationships" id="260" r:id="R5778a9865a3945c6"/>
   </p:sldIdLst>
   <p:sldSz cx="12192000" cy="6858000"/>
   <p:notesSz cx="6858000" cy="9144000"/>
@@ -726,7 +726,7 @@
           <a:lstStyle xmlns:a="http://schemas.openxmlformats.org/drawingml/2006/main"/>
           <a:p xmlns:a="http://schemas.openxmlformats.org/drawingml/2006/main">
             <a:r>
-              <a:t>Status as of 24 October 2026. The React production build passed. Backend pytest could not run because pytest is not installed in this environment. The Hugging Face Gradio Space is deployed and exposes a JSON API, but the last inference attempt was blocked by ZeroGPU quota; no provider-backed recommendation is verified. The deployed Space does not expose the exact FastAPI /health and /api/recommendations routes. Verify the team's model repository card, licence, and from_pretrained loading. Competition requirements: https://geosysiot.in/geoai-hackathon/#guidelines.</a:t>
+              <a:t>Status as of 24 October 2026. The React production build passed and eight deterministic scoring tests passed. The full pytest suite did not complete in the Windows sandbox because an asyncio/socketpair path hung. The Hugging Face Gradio Space is deployed and exposes a JSON API, but the last inference attempt was blocked by ZeroGPU quota; no provider-backed recommendation is verified. The deployed Space does not expose the exact FastAPI /health and /api/recommendations routes. Verify the team's model repository card, licence, and from_pretrained loading. Competition requirements: https://geosysiot.in/geoai-hackathon/#guidelines.</a:t>
             </a:r>
           </a:p>
         </p:txBody>
@@ -773,7 +773,7 @@
           <p:cNvPr id="3" name="Title">
             <a:extLst xmlns:a="http://schemas.openxmlformats.org/drawingml/2006/main">
               <a:ext uri="{FF2B5EF4-FFF2-40B4-BE49-F238E27FC236}">
-                <a16:creationId xmlns:a16="http://schemas.microsoft.com/office/drawing/2014/main" id="{67CE7008-851F-4E51-BFF1-72E87DDCD5E2}"/>
+                <a16:creationId xmlns:a16="http://schemas.microsoft.com/office/drawing/2014/main" id="{A3B67EB1-B493-4ACB-9E45-57A587F80C01}"/>
               </a:ext>
             </a:extLst>
           </p:cNvPr>
@@ -1002,7 +1002,7 @@
           <p:cNvPr id="2" name="Subtitle">
             <a:extLst xmlns:a="http://schemas.openxmlformats.org/drawingml/2006/main">
               <a:ext uri="{FF2B5EF4-FFF2-40B4-BE49-F238E27FC236}">
-                <a16:creationId xmlns:a16="http://schemas.microsoft.com/office/drawing/2014/main" id="{A1308201-B8CA-4B06-A0EC-F9A66C3D2251}"/>
+                <a16:creationId xmlns:a16="http://schemas.microsoft.com/office/drawing/2014/main" id="{EDF01643-6436-443F-AB9B-F2AD9FA99D23}"/>
               </a:ext>
             </a:extLst>
           </p:cNvPr>
@@ -1248,7 +1248,7 @@
           <p:cNvPr id="2" name="Section title">
             <a:extLst xmlns:a="http://schemas.openxmlformats.org/drawingml/2006/main">
               <a:ext uri="{FF2B5EF4-FFF2-40B4-BE49-F238E27FC236}">
-                <a16:creationId xmlns:a16="http://schemas.microsoft.com/office/drawing/2014/main" id="{E51D0E36-21CC-4AD9-99E6-E03B7AC1BF67}"/>
+                <a16:creationId xmlns:a16="http://schemas.microsoft.com/office/drawing/2014/main" id="{4340B83A-3CF7-4942-AD0C-DB8DA07CC886}"/>
               </a:ext>
             </a:extLst>
           </p:cNvPr>
@@ -1494,7 +1494,7 @@
           <p:cNvPr id="3" name="Title">
             <a:extLst xmlns:a="http://schemas.openxmlformats.org/drawingml/2006/main">
               <a:ext uri="{FF2B5EF4-FFF2-40B4-BE49-F238E27FC236}">
-                <a16:creationId xmlns:a16="http://schemas.microsoft.com/office/drawing/2014/main" id="{F98C3F0A-F8C1-41CA-BCE9-A6AAA5A1B6BF}"/>
+                <a16:creationId xmlns:a16="http://schemas.microsoft.com/office/drawing/2014/main" id="{736FA4F0-D5B8-4836-B8BD-FC4CBED766E4}"/>
               </a:ext>
             </a:extLst>
           </p:cNvPr>
@@ -1723,7 +1723,7 @@
           <p:cNvPr id="2" name="Body">
             <a:extLst xmlns:a="http://schemas.openxmlformats.org/drawingml/2006/main">
               <a:ext uri="{FF2B5EF4-FFF2-40B4-BE49-F238E27FC236}">
-                <a16:creationId xmlns:a16="http://schemas.microsoft.com/office/drawing/2014/main" id="{1BE3357A-44A1-469D-88CC-D01AF5794572}"/>
+                <a16:creationId xmlns:a16="http://schemas.microsoft.com/office/drawing/2014/main" id="{88A6253B-46A7-42EB-A613-29F1F22C515F}"/>
               </a:ext>
             </a:extLst>
           </p:cNvPr>
@@ -1969,7 +1969,7 @@
           <p:cNvPr id="4" name="Title">
             <a:extLst xmlns:a="http://schemas.openxmlformats.org/drawingml/2006/main">
               <a:ext uri="{FF2B5EF4-FFF2-40B4-BE49-F238E27FC236}">
-                <a16:creationId xmlns:a16="http://schemas.microsoft.com/office/drawing/2014/main" id="{6684E6E1-1DD9-45D4-BFBC-66BEA12D33B0}"/>
+                <a16:creationId xmlns:a16="http://schemas.microsoft.com/office/drawing/2014/main" id="{69885D25-B854-4C54-920E-415737684DC2}"/>
               </a:ext>
             </a:extLst>
           </p:cNvPr>
@@ -2198,7 +2198,7 @@
           <p:cNvPr id="2" name="Left column">
             <a:extLst xmlns:a="http://schemas.openxmlformats.org/drawingml/2006/main">
               <a:ext uri="{FF2B5EF4-FFF2-40B4-BE49-F238E27FC236}">
-                <a16:creationId xmlns:a16="http://schemas.microsoft.com/office/drawing/2014/main" id="{4E740EE6-04CB-40A3-8118-35792EC6CA22}"/>
+                <a16:creationId xmlns:a16="http://schemas.microsoft.com/office/drawing/2014/main" id="{B860E214-5DE6-4D7E-9011-C094748AB2BA}"/>
               </a:ext>
             </a:extLst>
           </p:cNvPr>
@@ -2427,7 +2427,7 @@
           <p:cNvPr id="3" name="Right column">
             <a:extLst xmlns:a="http://schemas.openxmlformats.org/drawingml/2006/main">
               <a:ext uri="{FF2B5EF4-FFF2-40B4-BE49-F238E27FC236}">
-                <a16:creationId xmlns:a16="http://schemas.microsoft.com/office/drawing/2014/main" id="{A3A66D68-205C-4F14-B2E7-22B37799FE06}"/>
+                <a16:creationId xmlns:a16="http://schemas.microsoft.com/office/drawing/2014/main" id="{020E594B-9944-4615-AA7D-578038005E8E}"/>
               </a:ext>
             </a:extLst>
           </p:cNvPr>
@@ -2673,7 +2673,7 @@
           <p:cNvPr id="3" name="Title">
             <a:extLst xmlns:a="http://schemas.openxmlformats.org/drawingml/2006/main">
               <a:ext uri="{FF2B5EF4-FFF2-40B4-BE49-F238E27FC236}">
-                <a16:creationId xmlns:a16="http://schemas.microsoft.com/office/drawing/2014/main" id="{299D4450-8B28-4123-9D04-88EFA3E2B4EA}"/>
+                <a16:creationId xmlns:a16="http://schemas.microsoft.com/office/drawing/2014/main" id="{12E25E72-9BFA-4B9E-B2DA-8F8CDD6C334E}"/>
               </a:ext>
             </a:extLst>
           </p:cNvPr>
@@ -2902,7 +2902,7 @@
           <p:cNvPr id="2" name="Left column">
             <a:extLst xmlns:a="http://schemas.openxmlformats.org/drawingml/2006/main">
               <a:ext uri="{FF2B5EF4-FFF2-40B4-BE49-F238E27FC236}">
-                <a16:creationId xmlns:a16="http://schemas.microsoft.com/office/drawing/2014/main" id="{BC08B602-1379-40A7-9D90-782D2AC6A383}"/>
+                <a16:creationId xmlns:a16="http://schemas.microsoft.com/office/drawing/2014/main" id="{C9DB738E-64D3-429F-8C4E-38C6E709470A}"/>
               </a:ext>
             </a:extLst>
           </p:cNvPr>
@@ -3169,12 +3169,12 @@
   </p:cSld>
   <p:clrMap bg1="lt1" tx1="dk1" bg2="lt2" tx2="dk2" accent1="accent1" accent2="accent2" accent3="accent3" accent4="accent4" accent5="accent5" accent6="accent6" hlink="hlink" folHlink="folHlink"/>
   <p:sldLayoutIdLst>
-    <p:sldLayoutId xmlns:r="http://schemas.openxmlformats.org/officeDocument/2006/relationships" id="2147483649" r:id="R7ee36020d3274b4f"/>
-    <p:sldLayoutId xmlns:r="http://schemas.openxmlformats.org/officeDocument/2006/relationships" id="2147483650" r:id="Rfaec2cdc823c4a68"/>
-    <p:sldLayoutId xmlns:r="http://schemas.openxmlformats.org/officeDocument/2006/relationships" id="2147483651" r:id="Rdd394cbcf6214319"/>
-    <p:sldLayoutId xmlns:r="http://schemas.openxmlformats.org/officeDocument/2006/relationships" id="2147483652" r:id="R4fd58c6f12e64868"/>
-    <p:sldLayoutId xmlns:r="http://schemas.openxmlformats.org/officeDocument/2006/relationships" id="2147483653" r:id="Rabd3806cb5bb4762"/>
-    <p:sldLayoutId xmlns:r="http://schemas.openxmlformats.org/officeDocument/2006/relationships" id="2147483654" r:id="R0e7fcf51c62c444c"/>
+    <p:sldLayoutId xmlns:r="http://schemas.openxmlformats.org/officeDocument/2006/relationships" id="2147483649" r:id="Re5c59ceaf78349b9"/>
+    <p:sldLayoutId xmlns:r="http://schemas.openxmlformats.org/officeDocument/2006/relationships" id="2147483650" r:id="Rfde5812e99fb4b77"/>
+    <p:sldLayoutId xmlns:r="http://schemas.openxmlformats.org/officeDocument/2006/relationships" id="2147483651" r:id="Rbc1717fa84cc441b"/>
+    <p:sldLayoutId xmlns:r="http://schemas.openxmlformats.org/officeDocument/2006/relationships" id="2147483652" r:id="R91c3cfc37a17400b"/>
+    <p:sldLayoutId xmlns:r="http://schemas.openxmlformats.org/officeDocument/2006/relationships" id="2147483653" r:id="R462b36dff8724de0"/>
+    <p:sldLayoutId xmlns:r="http://schemas.openxmlformats.org/officeDocument/2006/relationships" id="2147483654" r:id="Rda65b22cd62240c2"/>
   </p:sldLayoutIdLst>
   <p:txStyles>
     <p:titleStyle>
@@ -3725,7 +3725,7 @@
           <p:cNvPr id="9" name="">
             <a:extLst xmlns:a="http://schemas.openxmlformats.org/drawingml/2006/main">
               <a:ext uri="{FF2B5EF4-FFF2-40B4-BE49-F238E27FC236}">
-                <a16:creationId xmlns:a16="http://schemas.microsoft.com/office/drawing/2014/main" id="{626CF582-3FDB-4292-A9E8-C477FE6F8E57}"/>
+                <a16:creationId xmlns:a16="http://schemas.microsoft.com/office/drawing/2014/main" id="{D344AADD-DCCA-45B4-80A7-03AA77BD6F25}"/>
               </a:ext>
             </a:extLst>
           </p:cNvPr>
@@ -3756,7 +3756,7 @@
           <p:cNvPr id="2" name="">
             <a:extLst xmlns:a="http://schemas.openxmlformats.org/drawingml/2006/main">
               <a:ext uri="{FF2B5EF4-FFF2-40B4-BE49-F238E27FC236}">
-                <a16:creationId xmlns:a16="http://schemas.microsoft.com/office/drawing/2014/main" id="{FE2F28A3-38B6-420C-A135-D4EA1C4DD202}"/>
+                <a16:creationId xmlns:a16="http://schemas.microsoft.com/office/drawing/2014/main" id="{311AC2C0-DC28-42B5-BCBD-5CC1649A118C}"/>
               </a:ext>
             </a:extLst>
           </p:cNvPr>
@@ -3877,7 +3877,7 @@
           <p:cNvPr id="3" name="">
             <a:extLst xmlns:a="http://schemas.openxmlformats.org/drawingml/2006/main">
               <a:ext uri="{FF2B5EF4-FFF2-40B4-BE49-F238E27FC236}">
-                <a16:creationId xmlns:a16="http://schemas.microsoft.com/office/drawing/2014/main" id="{87FBF442-B90B-44C4-B5C2-C522B7D0C04D}"/>
+                <a16:creationId xmlns:a16="http://schemas.microsoft.com/office/drawing/2014/main" id="{FA389887-69D2-4F96-9542-D54FB35FBC2A}"/>
               </a:ext>
             </a:extLst>
           </p:cNvPr>
@@ -4015,7 +4015,7 @@
           <p:cNvPr id="4" name="">
             <a:extLst xmlns:a="http://schemas.openxmlformats.org/drawingml/2006/main">
               <a:ext uri="{FF2B5EF4-FFF2-40B4-BE49-F238E27FC236}">
-                <a16:creationId xmlns:a16="http://schemas.microsoft.com/office/drawing/2014/main" id="{279A7F69-6AAB-4DDA-A11B-F766079C63B5}"/>
+                <a16:creationId xmlns:a16="http://schemas.microsoft.com/office/drawing/2014/main" id="{9BF80E47-E979-46B4-9B07-838948263083}"/>
               </a:ext>
             </a:extLst>
           </p:cNvPr>
@@ -4136,7 +4136,7 @@
           <p:cNvPr id="5" name="">
             <a:extLst xmlns:a="http://schemas.openxmlformats.org/drawingml/2006/main">
               <a:ext uri="{FF2B5EF4-FFF2-40B4-BE49-F238E27FC236}">
-                <a16:creationId xmlns:a16="http://schemas.microsoft.com/office/drawing/2014/main" id="{6AA46E3E-5E19-40D6-BC28-6933AD20F58E}"/>
+                <a16:creationId xmlns:a16="http://schemas.microsoft.com/office/drawing/2014/main" id="{9E592687-E481-48A1-BAD5-046AB1BE1292}"/>
               </a:ext>
             </a:extLst>
           </p:cNvPr>
@@ -4167,7 +4167,7 @@
           <p:cNvPr id="6" name="">
             <a:extLst xmlns:a="http://schemas.openxmlformats.org/drawingml/2006/main">
               <a:ext uri="{FF2B5EF4-FFF2-40B4-BE49-F238E27FC236}">
-                <a16:creationId xmlns:a16="http://schemas.microsoft.com/office/drawing/2014/main" id="{B423C4C4-F2F7-409F-8489-CEB2040A3128}"/>
+                <a16:creationId xmlns:a16="http://schemas.microsoft.com/office/drawing/2014/main" id="{77266C4A-6F5B-4FE9-8ABA-7C4DF9C30960}"/>
               </a:ext>
             </a:extLst>
           </p:cNvPr>
@@ -4288,7 +4288,7 @@
           <p:cNvPr id="7" name="">
             <a:extLst xmlns:a="http://schemas.openxmlformats.org/drawingml/2006/main">
               <a:ext uri="{FF2B5EF4-FFF2-40B4-BE49-F238E27FC236}">
-                <a16:creationId xmlns:a16="http://schemas.microsoft.com/office/drawing/2014/main" id="{C6673226-4DD5-437A-88FE-ECD34FBBD660}"/>
+                <a16:creationId xmlns:a16="http://schemas.microsoft.com/office/drawing/2014/main" id="{E619D404-7F8A-40E9-A226-41EB97FAF8F6}"/>
               </a:ext>
             </a:extLst>
           </p:cNvPr>
@@ -4409,7 +4409,7 @@
           <p:cNvPr id="8" name="">
             <a:extLst xmlns:a="http://schemas.openxmlformats.org/drawingml/2006/main">
               <a:ext uri="{FF2B5EF4-FFF2-40B4-BE49-F238E27FC236}">
-                <a16:creationId xmlns:a16="http://schemas.microsoft.com/office/drawing/2014/main" id="{15A22B29-1358-4A70-AD0F-00A1D87FB1F4}"/>
+                <a16:creationId xmlns:a16="http://schemas.microsoft.com/office/drawing/2014/main" id="{6B0C9D0D-33FD-420D-8316-0E614C64D13A}"/>
               </a:ext>
             </a:extLst>
           </p:cNvPr>
@@ -4528,7 +4528,7 @@
     </p:spTree>
     <p:extLst>
       <p:ext uri="{BB962C8B-B14F-4D97-AF65-F5344CB8AC3E}">
-        <p14:creationId xmlns:p14="http://schemas.microsoft.com/office/powerpoint/2010/main" val="75840376"/>
+        <p14:creationId xmlns:p14="http://schemas.microsoft.com/office/powerpoint/2010/main" val="521475961"/>
       </p:ext>
     </p:extLst>
   </p:cSld>
@@ -4559,7 +4559,7 @@
           <p:cNvPr id="16" name="">
             <a:extLst xmlns:a="http://schemas.openxmlformats.org/drawingml/2006/main">
               <a:ext uri="{FF2B5EF4-FFF2-40B4-BE49-F238E27FC236}">
-                <a16:creationId xmlns:a16="http://schemas.microsoft.com/office/drawing/2014/main" id="{2063979F-95B0-4C42-B9D3-B2CF91300312}"/>
+                <a16:creationId xmlns:a16="http://schemas.microsoft.com/office/drawing/2014/main" id="{C336BE71-CD86-4315-B73B-72C63A3733FE}"/>
               </a:ext>
             </a:extLst>
           </p:cNvPr>
@@ -4680,7 +4680,7 @@
           <p:cNvPr id="2" name="">
             <a:extLst xmlns:a="http://schemas.openxmlformats.org/drawingml/2006/main">
               <a:ext uri="{FF2B5EF4-FFF2-40B4-BE49-F238E27FC236}">
-                <a16:creationId xmlns:a16="http://schemas.microsoft.com/office/drawing/2014/main" id="{BD0E476F-D136-4DEC-A696-DEC62FD5DB16}"/>
+                <a16:creationId xmlns:a16="http://schemas.microsoft.com/office/drawing/2014/main" id="{F56CF40F-C503-4BD4-A56F-72F37AE36865}"/>
               </a:ext>
             </a:extLst>
           </p:cNvPr>
@@ -4801,7 +4801,7 @@
           <p:cNvPr id="3" name="">
             <a:extLst xmlns:a="http://schemas.openxmlformats.org/drawingml/2006/main">
               <a:ext uri="{FF2B5EF4-FFF2-40B4-BE49-F238E27FC236}">
-                <a16:creationId xmlns:a16="http://schemas.microsoft.com/office/drawing/2014/main" id="{9B58EE4D-8AA3-4900-868A-14AAF3008F0E}"/>
+                <a16:creationId xmlns:a16="http://schemas.microsoft.com/office/drawing/2014/main" id="{8AF2C000-ABD5-4BE4-99F5-3D1E47427FF4}"/>
               </a:ext>
             </a:extLst>
           </p:cNvPr>
@@ -4922,7 +4922,7 @@
           <p:cNvPr id="4" name="">
             <a:extLst xmlns:a="http://schemas.openxmlformats.org/drawingml/2006/main">
               <a:ext uri="{FF2B5EF4-FFF2-40B4-BE49-F238E27FC236}">
-                <a16:creationId xmlns:a16="http://schemas.microsoft.com/office/drawing/2014/main" id="{92B16FCB-E966-4788-9D26-83FDDF420585}"/>
+                <a16:creationId xmlns:a16="http://schemas.microsoft.com/office/drawing/2014/main" id="{C013A5B9-30F1-419C-81AE-9540619BD2D7}"/>
               </a:ext>
             </a:extLst>
           </p:cNvPr>
@@ -4953,7 +4953,7 @@
           <p:cNvPr id="5" name="">
             <a:extLst xmlns:a="http://schemas.openxmlformats.org/drawingml/2006/main">
               <a:ext uri="{FF2B5EF4-FFF2-40B4-BE49-F238E27FC236}">
-                <a16:creationId xmlns:a16="http://schemas.microsoft.com/office/drawing/2014/main" id="{E744FE0A-C899-43F4-B239-366D9D28E851}"/>
+                <a16:creationId xmlns:a16="http://schemas.microsoft.com/office/drawing/2014/main" id="{55BBD7D2-11B8-4F9E-B19E-414D4811F57C}"/>
               </a:ext>
             </a:extLst>
           </p:cNvPr>
@@ -5074,7 +5074,7 @@
           <p:cNvPr id="6" name="">
             <a:extLst xmlns:a="http://schemas.openxmlformats.org/drawingml/2006/main">
               <a:ext uri="{FF2B5EF4-FFF2-40B4-BE49-F238E27FC236}">
-                <a16:creationId xmlns:a16="http://schemas.microsoft.com/office/drawing/2014/main" id="{B66FAF47-0CAF-4A8B-AE98-4452A519AD26}"/>
+                <a16:creationId xmlns:a16="http://schemas.microsoft.com/office/drawing/2014/main" id="{B8E0E1BD-6FC9-4BCB-A7C5-E3D4CAF89A9E}"/>
               </a:ext>
             </a:extLst>
           </p:cNvPr>
@@ -5195,7 +5195,7 @@
           <p:cNvPr id="7" name="">
             <a:extLst xmlns:a="http://schemas.openxmlformats.org/drawingml/2006/main">
               <a:ext uri="{FF2B5EF4-FFF2-40B4-BE49-F238E27FC236}">
-                <a16:creationId xmlns:a16="http://schemas.microsoft.com/office/drawing/2014/main" id="{9146BC66-8A8F-4D65-B786-3A5FB9FCBAE7}"/>
+                <a16:creationId xmlns:a16="http://schemas.microsoft.com/office/drawing/2014/main" id="{64FAAA5B-797F-4C53-9D45-77418FE89A11}"/>
               </a:ext>
             </a:extLst>
           </p:cNvPr>
@@ -5226,7 +5226,7 @@
           <p:cNvPr id="8" name="">
             <a:extLst xmlns:a="http://schemas.openxmlformats.org/drawingml/2006/main">
               <a:ext uri="{FF2B5EF4-FFF2-40B4-BE49-F238E27FC236}">
-                <a16:creationId xmlns:a16="http://schemas.microsoft.com/office/drawing/2014/main" id="{44F2AC6A-B6A0-4A5E-83AB-6CEBFF7AFCCB}"/>
+                <a16:creationId xmlns:a16="http://schemas.microsoft.com/office/drawing/2014/main" id="{B16A6AC4-CE86-4C70-830A-8D005B3ED72D}"/>
               </a:ext>
             </a:extLst>
           </p:cNvPr>
@@ -5347,7 +5347,7 @@
           <p:cNvPr id="9" name="">
             <a:extLst xmlns:a="http://schemas.openxmlformats.org/drawingml/2006/main">
               <a:ext uri="{FF2B5EF4-FFF2-40B4-BE49-F238E27FC236}">
-                <a16:creationId xmlns:a16="http://schemas.microsoft.com/office/drawing/2014/main" id="{AB3172C0-C2D9-49D4-9D32-DEA1189003F4}"/>
+                <a16:creationId xmlns:a16="http://schemas.microsoft.com/office/drawing/2014/main" id="{ED61CD33-7BA9-4B7C-AE13-B1E26960BD06}"/>
               </a:ext>
             </a:extLst>
           </p:cNvPr>
@@ -5468,7 +5468,7 @@
           <p:cNvPr id="10" name="">
             <a:extLst xmlns:a="http://schemas.openxmlformats.org/drawingml/2006/main">
               <a:ext uri="{FF2B5EF4-FFF2-40B4-BE49-F238E27FC236}">
-                <a16:creationId xmlns:a16="http://schemas.microsoft.com/office/drawing/2014/main" id="{59D0860C-10E5-4ED2-9DA3-476E7E8ACB9E}"/>
+                <a16:creationId xmlns:a16="http://schemas.microsoft.com/office/drawing/2014/main" id="{5836E952-BD15-4F7B-BFC8-72CC6B1D255D}"/>
               </a:ext>
             </a:extLst>
           </p:cNvPr>
@@ -5499,7 +5499,7 @@
           <p:cNvPr id="11" name="">
             <a:extLst xmlns:a="http://schemas.openxmlformats.org/drawingml/2006/main">
               <a:ext uri="{FF2B5EF4-FFF2-40B4-BE49-F238E27FC236}">
-                <a16:creationId xmlns:a16="http://schemas.microsoft.com/office/drawing/2014/main" id="{91DC5C34-2109-4FE0-9076-DC117104342C}"/>
+                <a16:creationId xmlns:a16="http://schemas.microsoft.com/office/drawing/2014/main" id="{8B9DC1EA-DDC7-4F3B-B11C-BBE42638B12F}"/>
               </a:ext>
             </a:extLst>
           </p:cNvPr>
@@ -5620,7 +5620,7 @@
           <p:cNvPr id="12" name="">
             <a:extLst xmlns:a="http://schemas.openxmlformats.org/drawingml/2006/main">
               <a:ext uri="{FF2B5EF4-FFF2-40B4-BE49-F238E27FC236}">
-                <a16:creationId xmlns:a16="http://schemas.microsoft.com/office/drawing/2014/main" id="{67E216F4-B422-4C00-9F20-16B9C29BA22B}"/>
+                <a16:creationId xmlns:a16="http://schemas.microsoft.com/office/drawing/2014/main" id="{31C37BBF-A6B3-4683-885C-EFCB8D4A69AE}"/>
               </a:ext>
             </a:extLst>
           </p:cNvPr>
@@ -5741,7 +5741,7 @@
           <p:cNvPr id="13" name="">
             <a:extLst xmlns:a="http://schemas.openxmlformats.org/drawingml/2006/main">
               <a:ext uri="{FF2B5EF4-FFF2-40B4-BE49-F238E27FC236}">
-                <a16:creationId xmlns:a16="http://schemas.microsoft.com/office/drawing/2014/main" id="{C59665AB-9C51-45DD-BC0E-DA0C72D2DCBB}"/>
+                <a16:creationId xmlns:a16="http://schemas.microsoft.com/office/drawing/2014/main" id="{FB38CD32-6C40-46C9-990A-C757250AF3B5}"/>
               </a:ext>
             </a:extLst>
           </p:cNvPr>
@@ -5862,7 +5862,7 @@
           <p:cNvPr id="14" name="">
             <a:extLst xmlns:a="http://schemas.openxmlformats.org/drawingml/2006/main">
               <a:ext uri="{FF2B5EF4-FFF2-40B4-BE49-F238E27FC236}">
-                <a16:creationId xmlns:a16="http://schemas.microsoft.com/office/drawing/2014/main" id="{90546646-34B0-43A4-B2F3-FCDB5A66CFDA}"/>
+                <a16:creationId xmlns:a16="http://schemas.microsoft.com/office/drawing/2014/main" id="{67CE58D8-0BE7-49EA-90F8-B75275C27401}"/>
               </a:ext>
             </a:extLst>
           </p:cNvPr>
@@ -5983,7 +5983,7 @@
           <p:cNvPr id="15" name="">
             <a:extLst xmlns:a="http://schemas.openxmlformats.org/drawingml/2006/main">
               <a:ext uri="{FF2B5EF4-FFF2-40B4-BE49-F238E27FC236}">
-                <a16:creationId xmlns:a16="http://schemas.microsoft.com/office/drawing/2014/main" id="{26A4FCAE-4678-4340-920C-E48B911F735A}"/>
+                <a16:creationId xmlns:a16="http://schemas.microsoft.com/office/drawing/2014/main" id="{3AB87795-317C-4400-A173-8FEBD470AD7B}"/>
               </a:ext>
             </a:extLst>
           </p:cNvPr>
@@ -6102,7 +6102,7 @@
     </p:spTree>
     <p:extLst>
       <p:ext uri="{BB962C8B-B14F-4D97-AF65-F5344CB8AC3E}">
-        <p14:creationId xmlns:p14="http://schemas.microsoft.com/office/powerpoint/2010/main" val="28419969"/>
+        <p14:creationId xmlns:p14="http://schemas.microsoft.com/office/powerpoint/2010/main" val="1357394783"/>
       </p:ext>
     </p:extLst>
   </p:cSld>
@@ -6133,7 +6133,7 @@
           <p:cNvPr id="25" name="">
             <a:extLst xmlns:a="http://schemas.openxmlformats.org/drawingml/2006/main">
               <a:ext uri="{FF2B5EF4-FFF2-40B4-BE49-F238E27FC236}">
-                <a16:creationId xmlns:a16="http://schemas.microsoft.com/office/drawing/2014/main" id="{3A1C2A83-88D6-45FB-B5E1-D746E1998E45}"/>
+                <a16:creationId xmlns:a16="http://schemas.microsoft.com/office/drawing/2014/main" id="{2816D630-4491-4A61-A6F2-2E4B694DA0E7}"/>
               </a:ext>
             </a:extLst>
           </p:cNvPr>
@@ -6254,7 +6254,7 @@
           <p:cNvPr id="2" name="">
             <a:extLst xmlns:a="http://schemas.openxmlformats.org/drawingml/2006/main">
               <a:ext uri="{FF2B5EF4-FFF2-40B4-BE49-F238E27FC236}">
-                <a16:creationId xmlns:a16="http://schemas.microsoft.com/office/drawing/2014/main" id="{4BA00353-CB26-496A-BB8B-18690CB80272}"/>
+                <a16:creationId xmlns:a16="http://schemas.microsoft.com/office/drawing/2014/main" id="{75DD37C7-313B-4A4D-B6A3-A58570CC5C34}"/>
               </a:ext>
             </a:extLst>
           </p:cNvPr>
@@ -6375,7 +6375,7 @@
           <p:cNvPr id="3" name="">
             <a:extLst xmlns:a="http://schemas.openxmlformats.org/drawingml/2006/main">
               <a:ext uri="{FF2B5EF4-FFF2-40B4-BE49-F238E27FC236}">
-                <a16:creationId xmlns:a16="http://schemas.microsoft.com/office/drawing/2014/main" id="{266CB630-F76F-4C4D-864A-E87A3EE42BAC}"/>
+                <a16:creationId xmlns:a16="http://schemas.microsoft.com/office/drawing/2014/main" id="{540292E5-7E69-43D4-A28B-FF2829533677}"/>
               </a:ext>
             </a:extLst>
           </p:cNvPr>
@@ -6496,7 +6496,7 @@
           <p:cNvPr id="4" name="">
             <a:extLst xmlns:a="http://schemas.openxmlformats.org/drawingml/2006/main">
               <a:ext uri="{FF2B5EF4-FFF2-40B4-BE49-F238E27FC236}">
-                <a16:creationId xmlns:a16="http://schemas.microsoft.com/office/drawing/2014/main" id="{303B50E6-54BF-4497-909B-7C80B561D5D5}"/>
+                <a16:creationId xmlns:a16="http://schemas.microsoft.com/office/drawing/2014/main" id="{9D4AA4CC-37B2-4599-B7C4-C60B3F6A8C21}"/>
               </a:ext>
             </a:extLst>
           </p:cNvPr>
@@ -6527,7 +6527,7 @@
           <p:cNvPr id="5" name="">
             <a:extLst xmlns:a="http://schemas.openxmlformats.org/drawingml/2006/main">
               <a:ext uri="{FF2B5EF4-FFF2-40B4-BE49-F238E27FC236}">
-                <a16:creationId xmlns:a16="http://schemas.microsoft.com/office/drawing/2014/main" id="{1819D11A-FD19-425C-B454-64B88E88EA0E}"/>
+                <a16:creationId xmlns:a16="http://schemas.microsoft.com/office/drawing/2014/main" id="{C451462D-5F3C-46BB-881E-33D3067D2799}"/>
               </a:ext>
             </a:extLst>
           </p:cNvPr>
@@ -6562,7 +6562,7 @@
           <p:cNvPr id="6" name="">
             <a:extLst xmlns:a="http://schemas.openxmlformats.org/drawingml/2006/main">
               <a:ext uri="{FF2B5EF4-FFF2-40B4-BE49-F238E27FC236}">
-                <a16:creationId xmlns:a16="http://schemas.microsoft.com/office/drawing/2014/main" id="{0C6F0E14-3A10-430E-AA87-314E9AD824D6}"/>
+                <a16:creationId xmlns:a16="http://schemas.microsoft.com/office/drawing/2014/main" id="{6B6F9BBA-8F98-4073-95AE-E2D7AA544DA6}"/>
               </a:ext>
             </a:extLst>
           </p:cNvPr>
@@ -6683,7 +6683,7 @@
           <p:cNvPr id="7" name="">
             <a:extLst xmlns:a="http://schemas.openxmlformats.org/drawingml/2006/main">
               <a:ext uri="{FF2B5EF4-FFF2-40B4-BE49-F238E27FC236}">
-                <a16:creationId xmlns:a16="http://schemas.microsoft.com/office/drawing/2014/main" id="{4068D983-454A-457A-BBE8-B37057EAA286}"/>
+                <a16:creationId xmlns:a16="http://schemas.microsoft.com/office/drawing/2014/main" id="{E9967641-EC0A-4FC9-8E4D-F3D38D5B8372}"/>
               </a:ext>
             </a:extLst>
           </p:cNvPr>
@@ -6821,7 +6821,7 @@
           <p:cNvPr id="8" name="">
             <a:extLst xmlns:a="http://schemas.openxmlformats.org/drawingml/2006/main">
               <a:ext uri="{FF2B5EF4-FFF2-40B4-BE49-F238E27FC236}">
-                <a16:creationId xmlns:a16="http://schemas.microsoft.com/office/drawing/2014/main" id="{088943EE-C7FB-4992-9304-0625FC2ED6D1}"/>
+                <a16:creationId xmlns:a16="http://schemas.microsoft.com/office/drawing/2014/main" id="{CB56EC85-E1F8-4692-A0C1-E25DAF3D0C81}"/>
               </a:ext>
             </a:extLst>
           </p:cNvPr>
@@ -6856,7 +6856,7 @@
           <p:cNvPr id="9" name="">
             <a:extLst xmlns:a="http://schemas.openxmlformats.org/drawingml/2006/main">
               <a:ext uri="{FF2B5EF4-FFF2-40B4-BE49-F238E27FC236}">
-                <a16:creationId xmlns:a16="http://schemas.microsoft.com/office/drawing/2014/main" id="{BD93B8CB-BC62-4DA4-A698-3747E5DEBB4D}"/>
+                <a16:creationId xmlns:a16="http://schemas.microsoft.com/office/drawing/2014/main" id="{D0919592-720B-4A18-B000-645A3C894095}"/>
               </a:ext>
             </a:extLst>
           </p:cNvPr>
@@ -6977,7 +6977,7 @@
           <p:cNvPr id="10" name="">
             <a:extLst xmlns:a="http://schemas.openxmlformats.org/drawingml/2006/main">
               <a:ext uri="{FF2B5EF4-FFF2-40B4-BE49-F238E27FC236}">
-                <a16:creationId xmlns:a16="http://schemas.microsoft.com/office/drawing/2014/main" id="{7016BEA1-311B-4E96-A12E-0C60DF2736A3}"/>
+                <a16:creationId xmlns:a16="http://schemas.microsoft.com/office/drawing/2014/main" id="{DA8BE3FB-3577-4E58-AACA-80787E8DE39C}"/>
               </a:ext>
             </a:extLst>
           </p:cNvPr>
@@ -7115,7 +7115,7 @@
           <p:cNvPr id="11" name="">
             <a:extLst xmlns:a="http://schemas.openxmlformats.org/drawingml/2006/main">
               <a:ext uri="{FF2B5EF4-FFF2-40B4-BE49-F238E27FC236}">
-                <a16:creationId xmlns:a16="http://schemas.microsoft.com/office/drawing/2014/main" id="{777FC3D5-0946-4A8D-986A-475E721F89ED}"/>
+                <a16:creationId xmlns:a16="http://schemas.microsoft.com/office/drawing/2014/main" id="{DC888BB2-49C9-4C9B-8FFA-E4642172B1AB}"/>
               </a:ext>
             </a:extLst>
           </p:cNvPr>
@@ -7150,7 +7150,7 @@
           <p:cNvPr id="12" name="">
             <a:extLst xmlns:a="http://schemas.openxmlformats.org/drawingml/2006/main">
               <a:ext uri="{FF2B5EF4-FFF2-40B4-BE49-F238E27FC236}">
-                <a16:creationId xmlns:a16="http://schemas.microsoft.com/office/drawing/2014/main" id="{356FEC75-C061-49DE-BD1C-70934C6284C8}"/>
+                <a16:creationId xmlns:a16="http://schemas.microsoft.com/office/drawing/2014/main" id="{34B0C24E-3FC3-4A66-958E-3EE94C609AF7}"/>
               </a:ext>
             </a:extLst>
           </p:cNvPr>
@@ -7271,7 +7271,7 @@
           <p:cNvPr id="13" name="">
             <a:extLst xmlns:a="http://schemas.openxmlformats.org/drawingml/2006/main">
               <a:ext uri="{FF2B5EF4-FFF2-40B4-BE49-F238E27FC236}">
-                <a16:creationId xmlns:a16="http://schemas.microsoft.com/office/drawing/2014/main" id="{768793C8-7EC0-49E5-95BF-A5BFC4B1C70C}"/>
+                <a16:creationId xmlns:a16="http://schemas.microsoft.com/office/drawing/2014/main" id="{293AA799-080E-4D05-A3D0-E08AC31274C3}"/>
               </a:ext>
             </a:extLst>
           </p:cNvPr>
@@ -7409,7 +7409,7 @@
           <p:cNvPr id="14" name="">
             <a:extLst xmlns:a="http://schemas.openxmlformats.org/drawingml/2006/main">
               <a:ext uri="{FF2B5EF4-FFF2-40B4-BE49-F238E27FC236}">
-                <a16:creationId xmlns:a16="http://schemas.microsoft.com/office/drawing/2014/main" id="{98F22E56-031C-4EFD-A657-92C1B36F438D}"/>
+                <a16:creationId xmlns:a16="http://schemas.microsoft.com/office/drawing/2014/main" id="{435E9FAA-C0C7-4C9E-A703-A598237B317C}"/>
               </a:ext>
             </a:extLst>
           </p:cNvPr>
@@ -7444,7 +7444,7 @@
           <p:cNvPr id="15" name="">
             <a:extLst xmlns:a="http://schemas.openxmlformats.org/drawingml/2006/main">
               <a:ext uri="{FF2B5EF4-FFF2-40B4-BE49-F238E27FC236}">
-                <a16:creationId xmlns:a16="http://schemas.microsoft.com/office/drawing/2014/main" id="{A7D9EE9F-F79A-4A8E-965B-A23735C7978A}"/>
+                <a16:creationId xmlns:a16="http://schemas.microsoft.com/office/drawing/2014/main" id="{0E9A59A5-405F-4DBF-A8AE-A01D8874AFEF}"/>
               </a:ext>
             </a:extLst>
           </p:cNvPr>
@@ -7565,7 +7565,7 @@
           <p:cNvPr id="16" name="">
             <a:extLst xmlns:a="http://schemas.openxmlformats.org/drawingml/2006/main">
               <a:ext uri="{FF2B5EF4-FFF2-40B4-BE49-F238E27FC236}">
-                <a16:creationId xmlns:a16="http://schemas.microsoft.com/office/drawing/2014/main" id="{3C8806B5-6233-4A20-AB09-FCC94082183A}"/>
+                <a16:creationId xmlns:a16="http://schemas.microsoft.com/office/drawing/2014/main" id="{80E25466-78A0-485A-9D78-F92584EBDDAA}"/>
               </a:ext>
             </a:extLst>
           </p:cNvPr>
@@ -7703,7 +7703,7 @@
           <p:cNvPr id="17" name="">
             <a:extLst xmlns:a="http://schemas.openxmlformats.org/drawingml/2006/main">
               <a:ext uri="{FF2B5EF4-FFF2-40B4-BE49-F238E27FC236}">
-                <a16:creationId xmlns:a16="http://schemas.microsoft.com/office/drawing/2014/main" id="{C6477E6C-1BFB-45C1-87C0-8B3D7874CC26}"/>
+                <a16:creationId xmlns:a16="http://schemas.microsoft.com/office/drawing/2014/main" id="{B4274F52-9ACE-4780-A1C4-C57038E503B6}"/>
               </a:ext>
             </a:extLst>
           </p:cNvPr>
@@ -7734,7 +7734,7 @@
           <p:cNvPr id="18" name="">
             <a:extLst xmlns:a="http://schemas.openxmlformats.org/drawingml/2006/main">
               <a:ext uri="{FF2B5EF4-FFF2-40B4-BE49-F238E27FC236}">
-                <a16:creationId xmlns:a16="http://schemas.microsoft.com/office/drawing/2014/main" id="{6322F139-0DEC-4741-A1B4-4A3C1E67A965}"/>
+                <a16:creationId xmlns:a16="http://schemas.microsoft.com/office/drawing/2014/main" id="{5CB3D1C7-1532-490E-BF12-E428CC393029}"/>
               </a:ext>
             </a:extLst>
           </p:cNvPr>
@@ -7765,7 +7765,7 @@
           <p:cNvPr id="19" name="">
             <a:extLst xmlns:a="http://schemas.openxmlformats.org/drawingml/2006/main">
               <a:ext uri="{FF2B5EF4-FFF2-40B4-BE49-F238E27FC236}">
-                <a16:creationId xmlns:a16="http://schemas.microsoft.com/office/drawing/2014/main" id="{6D99C354-06FE-41C6-92EC-8322120B44BC}"/>
+                <a16:creationId xmlns:a16="http://schemas.microsoft.com/office/drawing/2014/main" id="{C1736609-28D0-4EBA-9328-C83A72B84EC4}"/>
               </a:ext>
             </a:extLst>
           </p:cNvPr>
@@ -7796,7 +7796,7 @@
           <p:cNvPr id="20" name="">
             <a:extLst xmlns:a="http://schemas.openxmlformats.org/drawingml/2006/main">
               <a:ext uri="{FF2B5EF4-FFF2-40B4-BE49-F238E27FC236}">
-                <a16:creationId xmlns:a16="http://schemas.microsoft.com/office/drawing/2014/main" id="{31559C6F-BD4F-487D-AD0B-1B7C9853882B}"/>
+                <a16:creationId xmlns:a16="http://schemas.microsoft.com/office/drawing/2014/main" id="{677D35B2-F6F0-4187-9620-83C250093773}"/>
               </a:ext>
             </a:extLst>
           </p:cNvPr>
@@ -7827,7 +7827,7 @@
           <p:cNvPr id="21" name="">
             <a:extLst xmlns:a="http://schemas.openxmlformats.org/drawingml/2006/main">
               <a:ext uri="{FF2B5EF4-FFF2-40B4-BE49-F238E27FC236}">
-                <a16:creationId xmlns:a16="http://schemas.microsoft.com/office/drawing/2014/main" id="{C556C7AE-3F20-4675-B33A-83B65084D5A5}"/>
+                <a16:creationId xmlns:a16="http://schemas.microsoft.com/office/drawing/2014/main" id="{41A6ACEB-FB95-41D3-8D29-49F8271EFDC3}"/>
               </a:ext>
             </a:extLst>
           </p:cNvPr>
@@ -7948,7 +7948,7 @@
           <p:cNvPr id="22" name="">
             <a:extLst xmlns:a="http://schemas.openxmlformats.org/drawingml/2006/main">
               <a:ext uri="{FF2B5EF4-FFF2-40B4-BE49-F238E27FC236}">
-                <a16:creationId xmlns:a16="http://schemas.microsoft.com/office/drawing/2014/main" id="{90E475F6-A031-4BFB-A369-D3546EAB3BA7}"/>
+                <a16:creationId xmlns:a16="http://schemas.microsoft.com/office/drawing/2014/main" id="{38AE6FF3-61E8-4FF8-9D22-0DC9C3F9880F}"/>
               </a:ext>
             </a:extLst>
           </p:cNvPr>
@@ -8086,7 +8086,7 @@
           <p:cNvPr id="23" name="">
             <a:extLst xmlns:a="http://schemas.openxmlformats.org/drawingml/2006/main">
               <a:ext uri="{FF2B5EF4-FFF2-40B4-BE49-F238E27FC236}">
-                <a16:creationId xmlns:a16="http://schemas.microsoft.com/office/drawing/2014/main" id="{2057E492-EF83-4ED9-9407-0082958D455C}"/>
+                <a16:creationId xmlns:a16="http://schemas.microsoft.com/office/drawing/2014/main" id="{81CAE535-59E8-49CA-89AE-D3E277AB7CBC}"/>
               </a:ext>
             </a:extLst>
           </p:cNvPr>
@@ -8207,7 +8207,7 @@
           <p:cNvPr id="24" name="">
             <a:extLst xmlns:a="http://schemas.openxmlformats.org/drawingml/2006/main">
               <a:ext uri="{FF2B5EF4-FFF2-40B4-BE49-F238E27FC236}">
-                <a16:creationId xmlns:a16="http://schemas.microsoft.com/office/drawing/2014/main" id="{0487CF5F-1589-43C9-B61C-4A6D8C0C4282}"/>
+                <a16:creationId xmlns:a16="http://schemas.microsoft.com/office/drawing/2014/main" id="{E8A164BC-5AB7-4D7A-8570-124AD0C73610}"/>
               </a:ext>
             </a:extLst>
           </p:cNvPr>
@@ -8326,7 +8326,7 @@
     </p:spTree>
     <p:extLst>
       <p:ext uri="{BB962C8B-B14F-4D97-AF65-F5344CB8AC3E}">
-        <p14:creationId xmlns:p14="http://schemas.microsoft.com/office/powerpoint/2010/main" val="1092237959"/>
+        <p14:creationId xmlns:p14="http://schemas.microsoft.com/office/powerpoint/2010/main" val="1692523861"/>
       </p:ext>
     </p:extLst>
   </p:cSld>
@@ -8357,7 +8357,7 @@
           <p:cNvPr id="32" name="">
             <a:extLst xmlns:a="http://schemas.openxmlformats.org/drawingml/2006/main">
               <a:ext uri="{FF2B5EF4-FFF2-40B4-BE49-F238E27FC236}">
-                <a16:creationId xmlns:a16="http://schemas.microsoft.com/office/drawing/2014/main" id="{EC0B3C25-1DF0-4D18-8A64-052960B1E540}"/>
+                <a16:creationId xmlns:a16="http://schemas.microsoft.com/office/drawing/2014/main" id="{655D08C0-FE29-4580-A923-73FDBA13D0C1}"/>
               </a:ext>
             </a:extLst>
           </p:cNvPr>
@@ -8478,7 +8478,7 @@
           <p:cNvPr id="2" name="">
             <a:extLst xmlns:a="http://schemas.openxmlformats.org/drawingml/2006/main">
               <a:ext uri="{FF2B5EF4-FFF2-40B4-BE49-F238E27FC236}">
-                <a16:creationId xmlns:a16="http://schemas.microsoft.com/office/drawing/2014/main" id="{7F599AC6-82E0-4137-8BAB-3D6A2589E7EF}"/>
+                <a16:creationId xmlns:a16="http://schemas.microsoft.com/office/drawing/2014/main" id="{03BC013F-C618-47C2-9B77-13DBEDC9BCF8}"/>
               </a:ext>
             </a:extLst>
           </p:cNvPr>
@@ -8599,7 +8599,7 @@
           <p:cNvPr id="3" name="">
             <a:extLst xmlns:a="http://schemas.openxmlformats.org/drawingml/2006/main">
               <a:ext uri="{FF2B5EF4-FFF2-40B4-BE49-F238E27FC236}">
-                <a16:creationId xmlns:a16="http://schemas.microsoft.com/office/drawing/2014/main" id="{EDB51E96-6C61-4AD3-9A86-A2245CFD2B7E}"/>
+                <a16:creationId xmlns:a16="http://schemas.microsoft.com/office/drawing/2014/main" id="{C7683150-D0B0-4C17-9C46-43C40187811E}"/>
               </a:ext>
             </a:extLst>
           </p:cNvPr>
@@ -8720,7 +8720,7 @@
           <p:cNvPr id="4" name="">
             <a:extLst xmlns:a="http://schemas.openxmlformats.org/drawingml/2006/main">
               <a:ext uri="{FF2B5EF4-FFF2-40B4-BE49-F238E27FC236}">
-                <a16:creationId xmlns:a16="http://schemas.microsoft.com/office/drawing/2014/main" id="{D3474538-1EEE-4E53-A074-7F3FBA0E221C}"/>
+                <a16:creationId xmlns:a16="http://schemas.microsoft.com/office/drawing/2014/main" id="{5978BCF6-3F57-4989-B0A7-0087B6A2085E}"/>
               </a:ext>
             </a:extLst>
           </p:cNvPr>
@@ -8751,7 +8751,7 @@
           <p:cNvPr id="5" name="">
             <a:extLst xmlns:a="http://schemas.openxmlformats.org/drawingml/2006/main">
               <a:ext uri="{FF2B5EF4-FFF2-40B4-BE49-F238E27FC236}">
-                <a16:creationId xmlns:a16="http://schemas.microsoft.com/office/drawing/2014/main" id="{8C82D7D1-635F-4D25-91B2-5467AA718B83}"/>
+                <a16:creationId xmlns:a16="http://schemas.microsoft.com/office/drawing/2014/main" id="{7DED223C-C93D-40C3-BB62-ADD6234F0B57}"/>
               </a:ext>
             </a:extLst>
           </p:cNvPr>
@@ -8872,7 +8872,7 @@
           <p:cNvPr id="6" name="">
             <a:extLst xmlns:a="http://schemas.openxmlformats.org/drawingml/2006/main">
               <a:ext uri="{FF2B5EF4-FFF2-40B4-BE49-F238E27FC236}">
-                <a16:creationId xmlns:a16="http://schemas.microsoft.com/office/drawing/2014/main" id="{41BD26CA-C706-4AF2-9B71-BB4B0F0DFE69}"/>
+                <a16:creationId xmlns:a16="http://schemas.microsoft.com/office/drawing/2014/main" id="{AE23AFF1-E4B4-428F-8329-0AA92DC8B7EB}"/>
               </a:ext>
             </a:extLst>
           </p:cNvPr>
@@ -8993,7 +8993,7 @@
           <p:cNvPr id="7" name="">
             <a:extLst xmlns:a="http://schemas.openxmlformats.org/drawingml/2006/main">
               <a:ext uri="{FF2B5EF4-FFF2-40B4-BE49-F238E27FC236}">
-                <a16:creationId xmlns:a16="http://schemas.microsoft.com/office/drawing/2014/main" id="{48D39CD6-432B-4BF3-AE99-8A037921C1D5}"/>
+                <a16:creationId xmlns:a16="http://schemas.microsoft.com/office/drawing/2014/main" id="{A0A30885-ADD2-4F11-8747-D0D71572DD6D}"/>
               </a:ext>
             </a:extLst>
           </p:cNvPr>
@@ -9024,7 +9024,7 @@
           <p:cNvPr id="8" name="">
             <a:extLst xmlns:a="http://schemas.openxmlformats.org/drawingml/2006/main">
               <a:ext uri="{FF2B5EF4-FFF2-40B4-BE49-F238E27FC236}">
-                <a16:creationId xmlns:a16="http://schemas.microsoft.com/office/drawing/2014/main" id="{DC469E38-4E5E-467D-9D27-962C5492366C}"/>
+                <a16:creationId xmlns:a16="http://schemas.microsoft.com/office/drawing/2014/main" id="{3B8F9C65-7CE6-41B8-B2F9-A345B2C15390}"/>
               </a:ext>
             </a:extLst>
           </p:cNvPr>
@@ -9055,7 +9055,7 @@
           <p:cNvPr id="9" name="">
             <a:extLst xmlns:a="http://schemas.openxmlformats.org/drawingml/2006/main">
               <a:ext uri="{FF2B5EF4-FFF2-40B4-BE49-F238E27FC236}">
-                <a16:creationId xmlns:a16="http://schemas.microsoft.com/office/drawing/2014/main" id="{244EA244-D860-4FB1-8B58-1E629CB3B493}"/>
+                <a16:creationId xmlns:a16="http://schemas.microsoft.com/office/drawing/2014/main" id="{9FA4A3B0-C8CE-4A86-9BC9-57F4696DBF45}"/>
               </a:ext>
             </a:extLst>
           </p:cNvPr>
@@ -9176,7 +9176,7 @@
           <p:cNvPr id="10" name="">
             <a:extLst xmlns:a="http://schemas.openxmlformats.org/drawingml/2006/main">
               <a:ext uri="{FF2B5EF4-FFF2-40B4-BE49-F238E27FC236}">
-                <a16:creationId xmlns:a16="http://schemas.microsoft.com/office/drawing/2014/main" id="{05123596-9205-4FB6-B670-8591CB491A0B}"/>
+                <a16:creationId xmlns:a16="http://schemas.microsoft.com/office/drawing/2014/main" id="{41A80D88-2FBD-44EF-8C3B-10829E508058}"/>
               </a:ext>
             </a:extLst>
           </p:cNvPr>
@@ -9297,7 +9297,7 @@
           <p:cNvPr id="11" name="">
             <a:extLst xmlns:a="http://schemas.openxmlformats.org/drawingml/2006/main">
               <a:ext uri="{FF2B5EF4-FFF2-40B4-BE49-F238E27FC236}">
-                <a16:creationId xmlns:a16="http://schemas.microsoft.com/office/drawing/2014/main" id="{623B6E39-FEC4-4F42-BC48-787B28659C61}"/>
+                <a16:creationId xmlns:a16="http://schemas.microsoft.com/office/drawing/2014/main" id="{D4FDCB22-BD8C-46CF-B4D3-1B6DC7BDEEDD}"/>
               </a:ext>
             </a:extLst>
           </p:cNvPr>
@@ -9328,7 +9328,7 @@
           <p:cNvPr id="12" name="">
             <a:extLst xmlns:a="http://schemas.openxmlformats.org/drawingml/2006/main">
               <a:ext uri="{FF2B5EF4-FFF2-40B4-BE49-F238E27FC236}">
-                <a16:creationId xmlns:a16="http://schemas.microsoft.com/office/drawing/2014/main" id="{C3F22C69-ED26-4115-80E2-B038228F9A56}"/>
+                <a16:creationId xmlns:a16="http://schemas.microsoft.com/office/drawing/2014/main" id="{43C2ABC9-C658-49A7-85F8-8C80E92AB5AC}"/>
               </a:ext>
             </a:extLst>
           </p:cNvPr>
@@ -9359,7 +9359,7 @@
           <p:cNvPr id="13" name="">
             <a:extLst xmlns:a="http://schemas.openxmlformats.org/drawingml/2006/main">
               <a:ext uri="{FF2B5EF4-FFF2-40B4-BE49-F238E27FC236}">
-                <a16:creationId xmlns:a16="http://schemas.microsoft.com/office/drawing/2014/main" id="{1DF80E68-56A6-46C0-8186-2068C4E676CC}"/>
+                <a16:creationId xmlns:a16="http://schemas.microsoft.com/office/drawing/2014/main" id="{C5855CC3-AEDC-4C0F-A97F-B777F4420BA8}"/>
               </a:ext>
             </a:extLst>
           </p:cNvPr>
@@ -9480,7 +9480,7 @@
           <p:cNvPr id="14" name="">
             <a:extLst xmlns:a="http://schemas.openxmlformats.org/drawingml/2006/main">
               <a:ext uri="{FF2B5EF4-FFF2-40B4-BE49-F238E27FC236}">
-                <a16:creationId xmlns:a16="http://schemas.microsoft.com/office/drawing/2014/main" id="{4E9FB1CE-13FB-43CC-9B8F-8567DA016DCD}"/>
+                <a16:creationId xmlns:a16="http://schemas.microsoft.com/office/drawing/2014/main" id="{4B15FCB1-E352-401A-85A6-8915B73226E5}"/>
               </a:ext>
             </a:extLst>
           </p:cNvPr>
@@ -9601,7 +9601,7 @@
           <p:cNvPr id="15" name="">
             <a:extLst xmlns:a="http://schemas.openxmlformats.org/drawingml/2006/main">
               <a:ext uri="{FF2B5EF4-FFF2-40B4-BE49-F238E27FC236}">
-                <a16:creationId xmlns:a16="http://schemas.microsoft.com/office/drawing/2014/main" id="{6F7DA067-CB81-4484-A9DE-87CABC99E873}"/>
+                <a16:creationId xmlns:a16="http://schemas.microsoft.com/office/drawing/2014/main" id="{54290AD5-CE33-4CF3-9B3A-78F351DCDA5B}"/>
               </a:ext>
             </a:extLst>
           </p:cNvPr>
@@ -9632,7 +9632,7 @@
           <p:cNvPr id="16" name="">
             <a:extLst xmlns:a="http://schemas.openxmlformats.org/drawingml/2006/main">
               <a:ext uri="{FF2B5EF4-FFF2-40B4-BE49-F238E27FC236}">
-                <a16:creationId xmlns:a16="http://schemas.microsoft.com/office/drawing/2014/main" id="{79943E0F-DC32-44CC-9265-B810A07045FA}"/>
+                <a16:creationId xmlns:a16="http://schemas.microsoft.com/office/drawing/2014/main" id="{BC2A0A9F-A687-4A50-9D00-F69E5C151E5F}"/>
               </a:ext>
             </a:extLst>
           </p:cNvPr>
@@ -9663,7 +9663,7 @@
           <p:cNvPr id="17" name="">
             <a:extLst xmlns:a="http://schemas.openxmlformats.org/drawingml/2006/main">
               <a:ext uri="{FF2B5EF4-FFF2-40B4-BE49-F238E27FC236}">
-                <a16:creationId xmlns:a16="http://schemas.microsoft.com/office/drawing/2014/main" id="{D6FD4B01-1CC1-45D7-B44B-3096186FE25E}"/>
+                <a16:creationId xmlns:a16="http://schemas.microsoft.com/office/drawing/2014/main" id="{054C6B8F-53E6-4147-BEF8-7C12C2CE4C14}"/>
               </a:ext>
             </a:extLst>
           </p:cNvPr>
@@ -9784,7 +9784,7 @@
           <p:cNvPr id="18" name="">
             <a:extLst xmlns:a="http://schemas.openxmlformats.org/drawingml/2006/main">
               <a:ext uri="{FF2B5EF4-FFF2-40B4-BE49-F238E27FC236}">
-                <a16:creationId xmlns:a16="http://schemas.microsoft.com/office/drawing/2014/main" id="{194CE077-3FCD-43C6-AA55-2073A57BD843}"/>
+                <a16:creationId xmlns:a16="http://schemas.microsoft.com/office/drawing/2014/main" id="{4958B12A-529F-4283-A2CA-8A5400436694}"/>
               </a:ext>
             </a:extLst>
           </p:cNvPr>
@@ -9905,7 +9905,7 @@
           <p:cNvPr id="19" name="">
             <a:extLst xmlns:a="http://schemas.openxmlformats.org/drawingml/2006/main">
               <a:ext uri="{FF2B5EF4-FFF2-40B4-BE49-F238E27FC236}">
-                <a16:creationId xmlns:a16="http://schemas.microsoft.com/office/drawing/2014/main" id="{6785F00E-2BD7-4C1C-917D-6AA0AA044ED4}"/>
+                <a16:creationId xmlns:a16="http://schemas.microsoft.com/office/drawing/2014/main" id="{3F9681E6-F687-4C16-8E24-88DE8271A5CA}"/>
               </a:ext>
             </a:extLst>
           </p:cNvPr>
@@ -9936,7 +9936,7 @@
           <p:cNvPr id="20" name="">
             <a:extLst xmlns:a="http://schemas.openxmlformats.org/drawingml/2006/main">
               <a:ext uri="{FF2B5EF4-FFF2-40B4-BE49-F238E27FC236}">
-                <a16:creationId xmlns:a16="http://schemas.microsoft.com/office/drawing/2014/main" id="{1399E660-AC48-449D-9386-D458AA32BA06}"/>
+                <a16:creationId xmlns:a16="http://schemas.microsoft.com/office/drawing/2014/main" id="{0A66E8A2-18D1-4A60-B5AB-09BAE2564CE7}"/>
               </a:ext>
             </a:extLst>
           </p:cNvPr>
@@ -9967,7 +9967,7 @@
           <p:cNvPr id="21" name="">
             <a:extLst xmlns:a="http://schemas.openxmlformats.org/drawingml/2006/main">
               <a:ext uri="{FF2B5EF4-FFF2-40B4-BE49-F238E27FC236}">
-                <a16:creationId xmlns:a16="http://schemas.microsoft.com/office/drawing/2014/main" id="{702FC7E3-D63B-4271-BF13-45E9F59F2A74}"/>
+                <a16:creationId xmlns:a16="http://schemas.microsoft.com/office/drawing/2014/main" id="{9AF03094-7605-47AE-9F11-F99199F32B62}"/>
               </a:ext>
             </a:extLst>
           </p:cNvPr>
@@ -10088,7 +10088,7 @@
           <p:cNvPr id="22" name="">
             <a:extLst xmlns:a="http://schemas.openxmlformats.org/drawingml/2006/main">
               <a:ext uri="{FF2B5EF4-FFF2-40B4-BE49-F238E27FC236}">
-                <a16:creationId xmlns:a16="http://schemas.microsoft.com/office/drawing/2014/main" id="{6D1E7C90-F9A0-4D84-9669-5065BADF18F0}"/>
+                <a16:creationId xmlns:a16="http://schemas.microsoft.com/office/drawing/2014/main" id="{24A5C5A9-8C15-44D0-BB5A-A29BF0E03DA3}"/>
               </a:ext>
             </a:extLst>
           </p:cNvPr>
@@ -10209,7 +10209,7 @@
           <p:cNvPr id="23" name="">
             <a:extLst xmlns:a="http://schemas.openxmlformats.org/drawingml/2006/main">
               <a:ext uri="{FF2B5EF4-FFF2-40B4-BE49-F238E27FC236}">
-                <a16:creationId xmlns:a16="http://schemas.microsoft.com/office/drawing/2014/main" id="{CC0B71D5-2ECD-434C-8928-78C3D7F41256}"/>
+                <a16:creationId xmlns:a16="http://schemas.microsoft.com/office/drawing/2014/main" id="{E776760E-DE83-4C2D-9357-C17323C21DA4}"/>
               </a:ext>
             </a:extLst>
           </p:cNvPr>
@@ -10240,7 +10240,7 @@
           <p:cNvPr id="24" name="">
             <a:extLst xmlns:a="http://schemas.openxmlformats.org/drawingml/2006/main">
               <a:ext uri="{FF2B5EF4-FFF2-40B4-BE49-F238E27FC236}">
-                <a16:creationId xmlns:a16="http://schemas.microsoft.com/office/drawing/2014/main" id="{37535646-2F39-4B28-A35A-71A184F2E9A1}"/>
+                <a16:creationId xmlns:a16="http://schemas.microsoft.com/office/drawing/2014/main" id="{32201C45-707C-4D58-BE0E-22FD7C07F33B}"/>
               </a:ext>
             </a:extLst>
           </p:cNvPr>
@@ -10271,7 +10271,7 @@
           <p:cNvPr id="25" name="">
             <a:extLst xmlns:a="http://schemas.openxmlformats.org/drawingml/2006/main">
               <a:ext uri="{FF2B5EF4-FFF2-40B4-BE49-F238E27FC236}">
-                <a16:creationId xmlns:a16="http://schemas.microsoft.com/office/drawing/2014/main" id="{EBDC2693-0264-49D7-A68C-3071F0DBB2B0}"/>
+                <a16:creationId xmlns:a16="http://schemas.microsoft.com/office/drawing/2014/main" id="{328E75F7-C801-4E43-BDD1-F052ED3D6B37}"/>
               </a:ext>
             </a:extLst>
           </p:cNvPr>
@@ -10392,7 +10392,7 @@
           <p:cNvPr id="26" name="">
             <a:extLst xmlns:a="http://schemas.openxmlformats.org/drawingml/2006/main">
               <a:ext uri="{FF2B5EF4-FFF2-40B4-BE49-F238E27FC236}">
-                <a16:creationId xmlns:a16="http://schemas.microsoft.com/office/drawing/2014/main" id="{ED3C1A6B-ED93-4CD8-8DF4-BC2F8379A356}"/>
+                <a16:creationId xmlns:a16="http://schemas.microsoft.com/office/drawing/2014/main" id="{E99B1DA1-D329-49BD-9D47-2CAFAF87659F}"/>
               </a:ext>
             </a:extLst>
           </p:cNvPr>
@@ -10423,7 +10423,7 @@
           <p:cNvPr id="27" name="">
             <a:extLst xmlns:a="http://schemas.openxmlformats.org/drawingml/2006/main">
               <a:ext uri="{FF2B5EF4-FFF2-40B4-BE49-F238E27FC236}">
-                <a16:creationId xmlns:a16="http://schemas.microsoft.com/office/drawing/2014/main" id="{5B5A56A9-A396-445A-917E-8DFCC72C9ECA}"/>
+                <a16:creationId xmlns:a16="http://schemas.microsoft.com/office/drawing/2014/main" id="{75208501-B99A-4C5D-9D1D-F5F3551BB685}"/>
               </a:ext>
             </a:extLst>
           </p:cNvPr>
@@ -10544,7 +10544,7 @@
           <p:cNvPr id="28" name="">
             <a:extLst xmlns:a="http://schemas.openxmlformats.org/drawingml/2006/main">
               <a:ext uri="{FF2B5EF4-FFF2-40B4-BE49-F238E27FC236}">
-                <a16:creationId xmlns:a16="http://schemas.microsoft.com/office/drawing/2014/main" id="{946C4B05-8D82-413B-8ADC-267F3A12917A}"/>
+                <a16:creationId xmlns:a16="http://schemas.microsoft.com/office/drawing/2014/main" id="{A2914B92-35A3-4BA6-80BB-5F83A64415A4}"/>
               </a:ext>
             </a:extLst>
           </p:cNvPr>
@@ -10665,7 +10665,7 @@
           <p:cNvPr id="29" name="">
             <a:extLst xmlns:a="http://schemas.openxmlformats.org/drawingml/2006/main">
               <a:ext uri="{FF2B5EF4-FFF2-40B4-BE49-F238E27FC236}">
-                <a16:creationId xmlns:a16="http://schemas.microsoft.com/office/drawing/2014/main" id="{33AA8C8D-E145-45AA-BADB-FA7103D472AE}"/>
+                <a16:creationId xmlns:a16="http://schemas.microsoft.com/office/drawing/2014/main" id="{BD1B91C3-2A0C-41F7-B0D0-CE9E25D23CE9}"/>
               </a:ext>
             </a:extLst>
           </p:cNvPr>
@@ -10786,7 +10786,7 @@
           <p:cNvPr id="30" name="">
             <a:extLst xmlns:a="http://schemas.openxmlformats.org/drawingml/2006/main">
               <a:ext uri="{FF2B5EF4-FFF2-40B4-BE49-F238E27FC236}">
-                <a16:creationId xmlns:a16="http://schemas.microsoft.com/office/drawing/2014/main" id="{5A2F2C9D-D522-4A12-8A3F-5679E976F032}"/>
+                <a16:creationId xmlns:a16="http://schemas.microsoft.com/office/drawing/2014/main" id="{670A3B8F-37FB-4001-9843-6E26739D34D1}"/>
               </a:ext>
             </a:extLst>
           </p:cNvPr>
@@ -10907,7 +10907,7 @@
           <p:cNvPr id="31" name="">
             <a:extLst xmlns:a="http://schemas.openxmlformats.org/drawingml/2006/main">
               <a:ext uri="{FF2B5EF4-FFF2-40B4-BE49-F238E27FC236}">
-                <a16:creationId xmlns:a16="http://schemas.microsoft.com/office/drawing/2014/main" id="{2F9CE13C-716D-425F-A8C6-994D9F9B2E36}"/>
+                <a16:creationId xmlns:a16="http://schemas.microsoft.com/office/drawing/2014/main" id="{C880EC49-B38C-47FE-934F-7CFE8EF586C4}"/>
               </a:ext>
             </a:extLst>
           </p:cNvPr>
@@ -11026,7 +11026,7 @@
     </p:spTree>
     <p:extLst>
       <p:ext uri="{BB962C8B-B14F-4D97-AF65-F5344CB8AC3E}">
-        <p14:creationId xmlns:p14="http://schemas.microsoft.com/office/powerpoint/2010/main" val="121721487"/>
+        <p14:creationId xmlns:p14="http://schemas.microsoft.com/office/powerpoint/2010/main" val="1302874354"/>
       </p:ext>
     </p:extLst>
   </p:cSld>
@@ -11057,7 +11057,7 @@
           <p:cNvPr id="11" name="">
             <a:extLst xmlns:a="http://schemas.openxmlformats.org/drawingml/2006/main">
               <a:ext uri="{FF2B5EF4-FFF2-40B4-BE49-F238E27FC236}">
-                <a16:creationId xmlns:a16="http://schemas.microsoft.com/office/drawing/2014/main" id="{03813BA5-0CF9-4797-8E47-B3C06085B697}"/>
+                <a16:creationId xmlns:a16="http://schemas.microsoft.com/office/drawing/2014/main" id="{89D5555A-DD83-4A4E-B395-D13037D13AEC}"/>
               </a:ext>
             </a:extLst>
           </p:cNvPr>
@@ -11178,7 +11178,7 @@
           <p:cNvPr id="2" name="">
             <a:extLst xmlns:a="http://schemas.openxmlformats.org/drawingml/2006/main">
               <a:ext uri="{FF2B5EF4-FFF2-40B4-BE49-F238E27FC236}">
-                <a16:creationId xmlns:a16="http://schemas.microsoft.com/office/drawing/2014/main" id="{BA67688A-68C6-41C8-B33B-0D0A7AB1F583}"/>
+                <a16:creationId xmlns:a16="http://schemas.microsoft.com/office/drawing/2014/main" id="{FC2E7D86-72BC-4D65-A9E3-861174E34A53}"/>
               </a:ext>
             </a:extLst>
           </p:cNvPr>
@@ -11299,7 +11299,7 @@
           <p:cNvPr id="3" name="">
             <a:extLst xmlns:a="http://schemas.openxmlformats.org/drawingml/2006/main">
               <a:ext uri="{FF2B5EF4-FFF2-40B4-BE49-F238E27FC236}">
-                <a16:creationId xmlns:a16="http://schemas.microsoft.com/office/drawing/2014/main" id="{2DB8EDFC-B12F-48B8-AAFB-ED9F68D30430}"/>
+                <a16:creationId xmlns:a16="http://schemas.microsoft.com/office/drawing/2014/main" id="{47C3A32B-2629-4E55-A077-4D81149034C8}"/>
               </a:ext>
             </a:extLst>
           </p:cNvPr>
@@ -11330,7 +11330,7 @@
           <p:cNvPr id="4" name="">
             <a:extLst xmlns:a="http://schemas.openxmlformats.org/drawingml/2006/main">
               <a:ext uri="{FF2B5EF4-FFF2-40B4-BE49-F238E27FC236}">
-                <a16:creationId xmlns:a16="http://schemas.microsoft.com/office/drawing/2014/main" id="{BC6AB20A-5D08-4C95-A0D8-37475A9275D6}"/>
+                <a16:creationId xmlns:a16="http://schemas.microsoft.com/office/drawing/2014/main" id="{31049F3D-3DEA-41C0-91AD-FF15D8E7E531}"/>
               </a:ext>
             </a:extLst>
           </p:cNvPr>
@@ -11451,7 +11451,7 @@
           <p:cNvPr id="5" name="">
             <a:extLst xmlns:a="http://schemas.openxmlformats.org/drawingml/2006/main">
               <a:ext uri="{FF2B5EF4-FFF2-40B4-BE49-F238E27FC236}">
-                <a16:creationId xmlns:a16="http://schemas.microsoft.com/office/drawing/2014/main" id="{870EAD1F-A0A9-4B4B-9FB0-B134CE69590F}"/>
+                <a16:creationId xmlns:a16="http://schemas.microsoft.com/office/drawing/2014/main" id="{0B3C1AC4-15F0-48D6-BF53-96B468FA02A7}"/>
               </a:ext>
             </a:extLst>
           </p:cNvPr>
@@ -11640,7 +11640,7 @@
           <p:cNvPr id="6" name="">
             <a:extLst xmlns:a="http://schemas.openxmlformats.org/drawingml/2006/main">
               <a:ext uri="{FF2B5EF4-FFF2-40B4-BE49-F238E27FC236}">
-                <a16:creationId xmlns:a16="http://schemas.microsoft.com/office/drawing/2014/main" id="{65C42A3B-57ED-4D9D-A64E-A677A2012A33}"/>
+                <a16:creationId xmlns:a16="http://schemas.microsoft.com/office/drawing/2014/main" id="{7AFCB73E-5611-4946-9EF4-590B830E67DE}"/>
               </a:ext>
             </a:extLst>
           </p:cNvPr>
@@ -11671,7 +11671,7 @@
           <p:cNvPr id="7" name="">
             <a:extLst xmlns:a="http://schemas.openxmlformats.org/drawingml/2006/main">
               <a:ext uri="{FF2B5EF4-FFF2-40B4-BE49-F238E27FC236}">
-                <a16:creationId xmlns:a16="http://schemas.microsoft.com/office/drawing/2014/main" id="{42102990-BBBE-4BF5-AA9D-FF18BB930CA2}"/>
+                <a16:creationId xmlns:a16="http://schemas.microsoft.com/office/drawing/2014/main" id="{4FE01852-5662-4CBB-84AB-907B80559932}"/>
               </a:ext>
             </a:extLst>
           </p:cNvPr>
@@ -11792,7 +11792,7 @@
           <p:cNvPr id="8" name="">
             <a:extLst xmlns:a="http://schemas.openxmlformats.org/drawingml/2006/main">
               <a:ext uri="{FF2B5EF4-FFF2-40B4-BE49-F238E27FC236}">
-                <a16:creationId xmlns:a16="http://schemas.microsoft.com/office/drawing/2014/main" id="{8573D2EC-BD6B-4A4A-A4E2-D50EB74E89FA}"/>
+                <a16:creationId xmlns:a16="http://schemas.microsoft.com/office/drawing/2014/main" id="{7F25793A-01E2-4F7F-AB04-30130B9E4A5D}"/>
               </a:ext>
             </a:extLst>
           </p:cNvPr>
@@ -11920,7 +11920,7 @@
                   <a:srgbClr val="FFFFFF"/>
                 </a:solidFill>
               </a:rPr>
-              <a:t>Backend tests (pytest unavailable here)</a:t>
+              <a:t>Scoring tests: 8 pass; full suite unverified</a:t>
             </a:r>
           </a:p>
           <a:p xmlns:a="http://schemas.openxmlformats.org/drawingml/2006/main">
@@ -11981,7 +11981,7 @@
           <p:cNvPr id="9" name="">
             <a:extLst xmlns:a="http://schemas.openxmlformats.org/drawingml/2006/main">
               <a:ext uri="{FF2B5EF4-FFF2-40B4-BE49-F238E27FC236}">
-                <a16:creationId xmlns:a16="http://schemas.microsoft.com/office/drawing/2014/main" id="{FCC6276C-E380-45F8-ACDF-63FC881C26E8}"/>
+                <a16:creationId xmlns:a16="http://schemas.microsoft.com/office/drawing/2014/main" id="{127EB970-2BEB-461E-8D66-D44A20C456F7}"/>
               </a:ext>
             </a:extLst>
           </p:cNvPr>
@@ -12102,7 +12102,7 @@
           <p:cNvPr id="10" name="">
             <a:extLst xmlns:a="http://schemas.openxmlformats.org/drawingml/2006/main">
               <a:ext uri="{FF2B5EF4-FFF2-40B4-BE49-F238E27FC236}">
-                <a16:creationId xmlns:a16="http://schemas.microsoft.com/office/drawing/2014/main" id="{DD66AFDB-4FF7-4B85-AED1-D2D425787065}"/>
+                <a16:creationId xmlns:a16="http://schemas.microsoft.com/office/drawing/2014/main" id="{25B1495B-C3B7-403D-AE6F-46CD5A33D9F0}"/>
               </a:ext>
             </a:extLst>
           </p:cNvPr>
@@ -12221,7 +12221,7 @@
     </p:spTree>
     <p:extLst>
       <p:ext uri="{BB962C8B-B14F-4D97-AF65-F5344CB8AC3E}">
-        <p14:creationId xmlns:p14="http://schemas.microsoft.com/office/powerpoint/2010/main" val="280740013"/>
+        <p14:creationId xmlns:p14="http://schemas.microsoft.com/office/powerpoint/2010/main" val="1274687172"/>
       </p:ext>
     </p:extLst>
   </p:cSld>

</xml_diff>

<commit_message>
docs: verify model repo and finalize submission status
</commit_message>
<xml_diff>
--- a/submission/GoWise-GeoAI-Hackathon-2026-Submission.pptx
+++ b/submission/GoWise-GeoAI-Hackathon-2026-Submission.pptx
@@ -2,17 +2,17 @@
 <file path=ppt/presentation.xml><?xml version="1.0" encoding="utf-8"?>
 <p:presentation xmlns:p="http://schemas.openxmlformats.org/presentationml/2006/main">
   <p:sldMasterIdLst>
-    <p:sldMasterId xmlns:r="http://schemas.openxmlformats.org/officeDocument/2006/relationships" id="2147483648" r:id="R3e683f53d35c40b1"/>
+    <p:sldMasterId xmlns:r="http://schemas.openxmlformats.org/officeDocument/2006/relationships" id="2147483648" r:id="R0c65efec166d430a"/>
   </p:sldMasterIdLst>
   <p:notesMasterIdLst>
-    <p:notesMasterId xmlns:r="http://schemas.openxmlformats.org/officeDocument/2006/relationships" r:id="R6e847c3133ad4651"/>
+    <p:notesMasterId xmlns:r="http://schemas.openxmlformats.org/officeDocument/2006/relationships" r:id="R189d3578d66444b4"/>
   </p:notesMasterIdLst>
   <p:sldIdLst>
-    <p:sldId xmlns:r="http://schemas.openxmlformats.org/officeDocument/2006/relationships" id="256" r:id="R41336f0e56de480f"/>
-    <p:sldId xmlns:r="http://schemas.openxmlformats.org/officeDocument/2006/relationships" id="257" r:id="R7c9a4fb3ea754c64"/>
-    <p:sldId xmlns:r="http://schemas.openxmlformats.org/officeDocument/2006/relationships" id="258" r:id="R3748f542d55b467f"/>
-    <p:sldId xmlns:r="http://schemas.openxmlformats.org/officeDocument/2006/relationships" id="259" r:id="R7a5501349b0a467e"/>
-    <p:sldId xmlns:r="http://schemas.openxmlformats.org/officeDocument/2006/relationships" id="260" r:id="R5778a9865a3945c6"/>
+    <p:sldId xmlns:r="http://schemas.openxmlformats.org/officeDocument/2006/relationships" id="256" r:id="Rd68718adde434ff9"/>
+    <p:sldId xmlns:r="http://schemas.openxmlformats.org/officeDocument/2006/relationships" id="257" r:id="R7a25ca6890274a9a"/>
+    <p:sldId xmlns:r="http://schemas.openxmlformats.org/officeDocument/2006/relationships" id="258" r:id="Rf7740c9e8fa144d9"/>
+    <p:sldId xmlns:r="http://schemas.openxmlformats.org/officeDocument/2006/relationships" id="259" r:id="Rbe052cb474244008"/>
+    <p:sldId xmlns:r="http://schemas.openxmlformats.org/officeDocument/2006/relationships" id="260" r:id="Rd9498c91229a4adf"/>
   </p:sldIdLst>
   <p:sldSz cx="12192000" cy="6858000"/>
   <p:notesSz cx="6858000" cy="9144000"/>
@@ -586,7 +586,7 @@
           <a:lstStyle xmlns:a="http://schemas.openxmlformats.org/drawingml/2006/main"/>
           <a:p xmlns:a="http://schemas.openxmlformats.org/drawingml/2006/main">
             <a:r>
-              <a:t>Sources: ARCHITECTURE.md and DATA_SOURCES.md. Implemented providers are Nominatim, Overpass API / OpenStreetMap, Open-Meteo Forecast API, and Open-Meteo Air Quality API. The runtime model is configured through Transformers AutoTokenizer and AutoModelForCausalLM.</a:t>
+              <a:t>Sources: ARCHITECTURE.md and DATA_SOURCES.md. Implemented providers are Nominatim, Overpass API / OpenStreetMap, Open-Meteo Forecast API, and Open-Meteo Air Quality API. The team repository mirrors Qwen2.5-1.5B-Instruct base weights; no project-specific fine-tuning is claimed. The runtime model is configured through Transformers AutoTokenizer and AutoModelForCausalLM.</a:t>
             </a:r>
           </a:p>
         </p:txBody>
@@ -726,7 +726,7 @@
           <a:lstStyle xmlns:a="http://schemas.openxmlformats.org/drawingml/2006/main"/>
           <a:p xmlns:a="http://schemas.openxmlformats.org/drawingml/2006/main">
             <a:r>
-              <a:t>Status as of 24 October 2026. The React production build passed and eight deterministic scoring tests passed. The full pytest suite did not complete in the Windows sandbox because an asyncio/socketpair path hung. The Hugging Face Gradio Space is deployed and exposes a JSON API, but the last inference attempt was blocked by ZeroGPU quota; no provider-backed recommendation is verified. The deployed Space does not expose the exact FastAPI /health and /api/recommendations routes. Verify the team's model repository card, licence, and from_pretrained loading. Competition requirements: https://geosysiot.in/geoai-hackathon/#guidelines.</a:t>
+              <a:t>Status as of 24 October 2026. The React production build passed and eight deterministic scoring tests passed. The full pytest suite did not complete in the Windows sandbox because an asyncio/socketpair path hung. The public team model repo reports Apache-2.0 and contains 1,543,714,304 BF16 parameters with a model card; the running Space displays the team model ID as loaded through Transformers. Its Gradio JSON endpoint is available, but the last inference attempt was blocked by ZeroGPU quota; no provider-backed recommendation is verified. The deployed Space does not expose the exact FastAPI /health and /api/recommendations routes. Competition requirements: https://geosysiot.in/geoai-hackathon/#guidelines.</a:t>
             </a:r>
           </a:p>
         </p:txBody>
@@ -773,7 +773,7 @@
           <p:cNvPr id="3" name="Title">
             <a:extLst xmlns:a="http://schemas.openxmlformats.org/drawingml/2006/main">
               <a:ext uri="{FF2B5EF4-FFF2-40B4-BE49-F238E27FC236}">
-                <a16:creationId xmlns:a16="http://schemas.microsoft.com/office/drawing/2014/main" id="{A3B67EB1-B493-4ACB-9E45-57A587F80C01}"/>
+                <a16:creationId xmlns:a16="http://schemas.microsoft.com/office/drawing/2014/main" id="{33457129-78BE-485B-97DD-3C5568011622}"/>
               </a:ext>
             </a:extLst>
           </p:cNvPr>
@@ -1002,7 +1002,7 @@
           <p:cNvPr id="2" name="Subtitle">
             <a:extLst xmlns:a="http://schemas.openxmlformats.org/drawingml/2006/main">
               <a:ext uri="{FF2B5EF4-FFF2-40B4-BE49-F238E27FC236}">
-                <a16:creationId xmlns:a16="http://schemas.microsoft.com/office/drawing/2014/main" id="{EDF01643-6436-443F-AB9B-F2AD9FA99D23}"/>
+                <a16:creationId xmlns:a16="http://schemas.microsoft.com/office/drawing/2014/main" id="{AE679D9A-6C7D-4465-8F27-EDB8741F65B2}"/>
               </a:ext>
             </a:extLst>
           </p:cNvPr>
@@ -1248,7 +1248,7 @@
           <p:cNvPr id="2" name="Section title">
             <a:extLst xmlns:a="http://schemas.openxmlformats.org/drawingml/2006/main">
               <a:ext uri="{FF2B5EF4-FFF2-40B4-BE49-F238E27FC236}">
-                <a16:creationId xmlns:a16="http://schemas.microsoft.com/office/drawing/2014/main" id="{4340B83A-3CF7-4942-AD0C-DB8DA07CC886}"/>
+                <a16:creationId xmlns:a16="http://schemas.microsoft.com/office/drawing/2014/main" id="{D45B4EA7-08D0-40C2-BDE5-82BB6FC5E28C}"/>
               </a:ext>
             </a:extLst>
           </p:cNvPr>
@@ -1494,7 +1494,7 @@
           <p:cNvPr id="3" name="Title">
             <a:extLst xmlns:a="http://schemas.openxmlformats.org/drawingml/2006/main">
               <a:ext uri="{FF2B5EF4-FFF2-40B4-BE49-F238E27FC236}">
-                <a16:creationId xmlns:a16="http://schemas.microsoft.com/office/drawing/2014/main" id="{736FA4F0-D5B8-4836-B8BD-FC4CBED766E4}"/>
+                <a16:creationId xmlns:a16="http://schemas.microsoft.com/office/drawing/2014/main" id="{206AE38A-D9FF-4735-A1D7-722FD5E86247}"/>
               </a:ext>
             </a:extLst>
           </p:cNvPr>
@@ -1723,7 +1723,7 @@
           <p:cNvPr id="2" name="Body">
             <a:extLst xmlns:a="http://schemas.openxmlformats.org/drawingml/2006/main">
               <a:ext uri="{FF2B5EF4-FFF2-40B4-BE49-F238E27FC236}">
-                <a16:creationId xmlns:a16="http://schemas.microsoft.com/office/drawing/2014/main" id="{88A6253B-46A7-42EB-A613-29F1F22C515F}"/>
+                <a16:creationId xmlns:a16="http://schemas.microsoft.com/office/drawing/2014/main" id="{5B9AFD6B-EE82-42EC-8512-435D0743A3CB}"/>
               </a:ext>
             </a:extLst>
           </p:cNvPr>
@@ -1969,7 +1969,7 @@
           <p:cNvPr id="4" name="Title">
             <a:extLst xmlns:a="http://schemas.openxmlformats.org/drawingml/2006/main">
               <a:ext uri="{FF2B5EF4-FFF2-40B4-BE49-F238E27FC236}">
-                <a16:creationId xmlns:a16="http://schemas.microsoft.com/office/drawing/2014/main" id="{69885D25-B854-4C54-920E-415737684DC2}"/>
+                <a16:creationId xmlns:a16="http://schemas.microsoft.com/office/drawing/2014/main" id="{D0C40906-9327-4BFD-A78E-A9F6BF83E2CA}"/>
               </a:ext>
             </a:extLst>
           </p:cNvPr>
@@ -2198,7 +2198,7 @@
           <p:cNvPr id="2" name="Left column">
             <a:extLst xmlns:a="http://schemas.openxmlformats.org/drawingml/2006/main">
               <a:ext uri="{FF2B5EF4-FFF2-40B4-BE49-F238E27FC236}">
-                <a16:creationId xmlns:a16="http://schemas.microsoft.com/office/drawing/2014/main" id="{B860E214-5DE6-4D7E-9011-C094748AB2BA}"/>
+                <a16:creationId xmlns:a16="http://schemas.microsoft.com/office/drawing/2014/main" id="{5F150234-B238-4B17-9356-2FD561DFE5FA}"/>
               </a:ext>
             </a:extLst>
           </p:cNvPr>
@@ -2427,7 +2427,7 @@
           <p:cNvPr id="3" name="Right column">
             <a:extLst xmlns:a="http://schemas.openxmlformats.org/drawingml/2006/main">
               <a:ext uri="{FF2B5EF4-FFF2-40B4-BE49-F238E27FC236}">
-                <a16:creationId xmlns:a16="http://schemas.microsoft.com/office/drawing/2014/main" id="{020E594B-9944-4615-AA7D-578038005E8E}"/>
+                <a16:creationId xmlns:a16="http://schemas.microsoft.com/office/drawing/2014/main" id="{30BABE66-2275-45A9-AA74-B1BB5FE409E3}"/>
               </a:ext>
             </a:extLst>
           </p:cNvPr>
@@ -2673,7 +2673,7 @@
           <p:cNvPr id="3" name="Title">
             <a:extLst xmlns:a="http://schemas.openxmlformats.org/drawingml/2006/main">
               <a:ext uri="{FF2B5EF4-FFF2-40B4-BE49-F238E27FC236}">
-                <a16:creationId xmlns:a16="http://schemas.microsoft.com/office/drawing/2014/main" id="{12E25E72-9BFA-4B9E-B2DA-8F8CDD6C334E}"/>
+                <a16:creationId xmlns:a16="http://schemas.microsoft.com/office/drawing/2014/main" id="{0177919B-DB5D-4E4F-A5E5-AF32F2762DD4}"/>
               </a:ext>
             </a:extLst>
           </p:cNvPr>
@@ -2902,7 +2902,7 @@
           <p:cNvPr id="2" name="Left column">
             <a:extLst xmlns:a="http://schemas.openxmlformats.org/drawingml/2006/main">
               <a:ext uri="{FF2B5EF4-FFF2-40B4-BE49-F238E27FC236}">
-                <a16:creationId xmlns:a16="http://schemas.microsoft.com/office/drawing/2014/main" id="{C9DB738E-64D3-429F-8C4E-38C6E709470A}"/>
+                <a16:creationId xmlns:a16="http://schemas.microsoft.com/office/drawing/2014/main" id="{C16E6094-105C-484A-99F8-4D2B5BF07E5C}"/>
               </a:ext>
             </a:extLst>
           </p:cNvPr>
@@ -3169,12 +3169,12 @@
   </p:cSld>
   <p:clrMap bg1="lt1" tx1="dk1" bg2="lt2" tx2="dk2" accent1="accent1" accent2="accent2" accent3="accent3" accent4="accent4" accent5="accent5" accent6="accent6" hlink="hlink" folHlink="folHlink"/>
   <p:sldLayoutIdLst>
-    <p:sldLayoutId xmlns:r="http://schemas.openxmlformats.org/officeDocument/2006/relationships" id="2147483649" r:id="Re5c59ceaf78349b9"/>
-    <p:sldLayoutId xmlns:r="http://schemas.openxmlformats.org/officeDocument/2006/relationships" id="2147483650" r:id="Rfde5812e99fb4b77"/>
-    <p:sldLayoutId xmlns:r="http://schemas.openxmlformats.org/officeDocument/2006/relationships" id="2147483651" r:id="Rbc1717fa84cc441b"/>
-    <p:sldLayoutId xmlns:r="http://schemas.openxmlformats.org/officeDocument/2006/relationships" id="2147483652" r:id="R91c3cfc37a17400b"/>
-    <p:sldLayoutId xmlns:r="http://schemas.openxmlformats.org/officeDocument/2006/relationships" id="2147483653" r:id="R462b36dff8724de0"/>
-    <p:sldLayoutId xmlns:r="http://schemas.openxmlformats.org/officeDocument/2006/relationships" id="2147483654" r:id="Rda65b22cd62240c2"/>
+    <p:sldLayoutId xmlns:r="http://schemas.openxmlformats.org/officeDocument/2006/relationships" id="2147483649" r:id="Rbd7360586d964925"/>
+    <p:sldLayoutId xmlns:r="http://schemas.openxmlformats.org/officeDocument/2006/relationships" id="2147483650" r:id="R180a2e0ce8cc457c"/>
+    <p:sldLayoutId xmlns:r="http://schemas.openxmlformats.org/officeDocument/2006/relationships" id="2147483651" r:id="Re5ae598f2de14364"/>
+    <p:sldLayoutId xmlns:r="http://schemas.openxmlformats.org/officeDocument/2006/relationships" id="2147483652" r:id="R1aeeac425ae84c67"/>
+    <p:sldLayoutId xmlns:r="http://schemas.openxmlformats.org/officeDocument/2006/relationships" id="2147483653" r:id="R73faf35daca44d2e"/>
+    <p:sldLayoutId xmlns:r="http://schemas.openxmlformats.org/officeDocument/2006/relationships" id="2147483654" r:id="Re1bd6782583a4345"/>
   </p:sldLayoutIdLst>
   <p:txStyles>
     <p:titleStyle>
@@ -3725,7 +3725,7 @@
           <p:cNvPr id="9" name="">
             <a:extLst xmlns:a="http://schemas.openxmlformats.org/drawingml/2006/main">
               <a:ext uri="{FF2B5EF4-FFF2-40B4-BE49-F238E27FC236}">
-                <a16:creationId xmlns:a16="http://schemas.microsoft.com/office/drawing/2014/main" id="{D344AADD-DCCA-45B4-80A7-03AA77BD6F25}"/>
+                <a16:creationId xmlns:a16="http://schemas.microsoft.com/office/drawing/2014/main" id="{039450D7-22E4-4F1D-896B-79BFB1A912A6}"/>
               </a:ext>
             </a:extLst>
           </p:cNvPr>
@@ -3756,7 +3756,7 @@
           <p:cNvPr id="2" name="">
             <a:extLst xmlns:a="http://schemas.openxmlformats.org/drawingml/2006/main">
               <a:ext uri="{FF2B5EF4-FFF2-40B4-BE49-F238E27FC236}">
-                <a16:creationId xmlns:a16="http://schemas.microsoft.com/office/drawing/2014/main" id="{311AC2C0-DC28-42B5-BCBD-5CC1649A118C}"/>
+                <a16:creationId xmlns:a16="http://schemas.microsoft.com/office/drawing/2014/main" id="{6B19E38B-D515-4C8E-B92E-1658F6845BDD}"/>
               </a:ext>
             </a:extLst>
           </p:cNvPr>
@@ -3877,7 +3877,7 @@
           <p:cNvPr id="3" name="">
             <a:extLst xmlns:a="http://schemas.openxmlformats.org/drawingml/2006/main">
               <a:ext uri="{FF2B5EF4-FFF2-40B4-BE49-F238E27FC236}">
-                <a16:creationId xmlns:a16="http://schemas.microsoft.com/office/drawing/2014/main" id="{FA389887-69D2-4F96-9542-D54FB35FBC2A}"/>
+                <a16:creationId xmlns:a16="http://schemas.microsoft.com/office/drawing/2014/main" id="{94FFD4B2-7FAF-4A50-931A-608189AF251F}"/>
               </a:ext>
             </a:extLst>
           </p:cNvPr>
@@ -4015,7 +4015,7 @@
           <p:cNvPr id="4" name="">
             <a:extLst xmlns:a="http://schemas.openxmlformats.org/drawingml/2006/main">
               <a:ext uri="{FF2B5EF4-FFF2-40B4-BE49-F238E27FC236}">
-                <a16:creationId xmlns:a16="http://schemas.microsoft.com/office/drawing/2014/main" id="{9BF80E47-E979-46B4-9B07-838948263083}"/>
+                <a16:creationId xmlns:a16="http://schemas.microsoft.com/office/drawing/2014/main" id="{E12F750C-E519-454A-844A-333BF3DAAC64}"/>
               </a:ext>
             </a:extLst>
           </p:cNvPr>
@@ -4136,7 +4136,7 @@
           <p:cNvPr id="5" name="">
             <a:extLst xmlns:a="http://schemas.openxmlformats.org/drawingml/2006/main">
               <a:ext uri="{FF2B5EF4-FFF2-40B4-BE49-F238E27FC236}">
-                <a16:creationId xmlns:a16="http://schemas.microsoft.com/office/drawing/2014/main" id="{9E592687-E481-48A1-BAD5-046AB1BE1292}"/>
+                <a16:creationId xmlns:a16="http://schemas.microsoft.com/office/drawing/2014/main" id="{BAB00ED1-902D-4176-A92A-FDFCA8370E1A}"/>
               </a:ext>
             </a:extLst>
           </p:cNvPr>
@@ -4167,7 +4167,7 @@
           <p:cNvPr id="6" name="">
             <a:extLst xmlns:a="http://schemas.openxmlformats.org/drawingml/2006/main">
               <a:ext uri="{FF2B5EF4-FFF2-40B4-BE49-F238E27FC236}">
-                <a16:creationId xmlns:a16="http://schemas.microsoft.com/office/drawing/2014/main" id="{77266C4A-6F5B-4FE9-8ABA-7C4DF9C30960}"/>
+                <a16:creationId xmlns:a16="http://schemas.microsoft.com/office/drawing/2014/main" id="{48AD7428-CED3-447D-960B-74F87D087AC7}"/>
               </a:ext>
             </a:extLst>
           </p:cNvPr>
@@ -4288,7 +4288,7 @@
           <p:cNvPr id="7" name="">
             <a:extLst xmlns:a="http://schemas.openxmlformats.org/drawingml/2006/main">
               <a:ext uri="{FF2B5EF4-FFF2-40B4-BE49-F238E27FC236}">
-                <a16:creationId xmlns:a16="http://schemas.microsoft.com/office/drawing/2014/main" id="{E619D404-7F8A-40E9-A226-41EB97FAF8F6}"/>
+                <a16:creationId xmlns:a16="http://schemas.microsoft.com/office/drawing/2014/main" id="{D25589DC-9F95-4B3A-B964-52FF476DEFA4}"/>
               </a:ext>
             </a:extLst>
           </p:cNvPr>
@@ -4409,7 +4409,7 @@
           <p:cNvPr id="8" name="">
             <a:extLst xmlns:a="http://schemas.openxmlformats.org/drawingml/2006/main">
               <a:ext uri="{FF2B5EF4-FFF2-40B4-BE49-F238E27FC236}">
-                <a16:creationId xmlns:a16="http://schemas.microsoft.com/office/drawing/2014/main" id="{6B0C9D0D-33FD-420D-8316-0E614C64D13A}"/>
+                <a16:creationId xmlns:a16="http://schemas.microsoft.com/office/drawing/2014/main" id="{B6DA03F8-77E6-4622-9DA1-7CFF5CB19450}"/>
               </a:ext>
             </a:extLst>
           </p:cNvPr>
@@ -4528,7 +4528,7 @@
     </p:spTree>
     <p:extLst>
       <p:ext uri="{BB962C8B-B14F-4D97-AF65-F5344CB8AC3E}">
-        <p14:creationId xmlns:p14="http://schemas.microsoft.com/office/powerpoint/2010/main" val="521475961"/>
+        <p14:creationId xmlns:p14="http://schemas.microsoft.com/office/powerpoint/2010/main" val="252787042"/>
       </p:ext>
     </p:extLst>
   </p:cSld>
@@ -4559,7 +4559,7 @@
           <p:cNvPr id="16" name="">
             <a:extLst xmlns:a="http://schemas.openxmlformats.org/drawingml/2006/main">
               <a:ext uri="{FF2B5EF4-FFF2-40B4-BE49-F238E27FC236}">
-                <a16:creationId xmlns:a16="http://schemas.microsoft.com/office/drawing/2014/main" id="{C336BE71-CD86-4315-B73B-72C63A3733FE}"/>
+                <a16:creationId xmlns:a16="http://schemas.microsoft.com/office/drawing/2014/main" id="{250A7152-6B93-47BF-8CC5-7575A1052554}"/>
               </a:ext>
             </a:extLst>
           </p:cNvPr>
@@ -4680,7 +4680,7 @@
           <p:cNvPr id="2" name="">
             <a:extLst xmlns:a="http://schemas.openxmlformats.org/drawingml/2006/main">
               <a:ext uri="{FF2B5EF4-FFF2-40B4-BE49-F238E27FC236}">
-                <a16:creationId xmlns:a16="http://schemas.microsoft.com/office/drawing/2014/main" id="{F56CF40F-C503-4BD4-A56F-72F37AE36865}"/>
+                <a16:creationId xmlns:a16="http://schemas.microsoft.com/office/drawing/2014/main" id="{17C6E3D7-2A8A-460E-9FC0-08BCAF7A5F72}"/>
               </a:ext>
             </a:extLst>
           </p:cNvPr>
@@ -4801,7 +4801,7 @@
           <p:cNvPr id="3" name="">
             <a:extLst xmlns:a="http://schemas.openxmlformats.org/drawingml/2006/main">
               <a:ext uri="{FF2B5EF4-FFF2-40B4-BE49-F238E27FC236}">
-                <a16:creationId xmlns:a16="http://schemas.microsoft.com/office/drawing/2014/main" id="{8AF2C000-ABD5-4BE4-99F5-3D1E47427FF4}"/>
+                <a16:creationId xmlns:a16="http://schemas.microsoft.com/office/drawing/2014/main" id="{7936D4E7-1539-4941-8556-246C66EEE788}"/>
               </a:ext>
             </a:extLst>
           </p:cNvPr>
@@ -4922,7 +4922,7 @@
           <p:cNvPr id="4" name="">
             <a:extLst xmlns:a="http://schemas.openxmlformats.org/drawingml/2006/main">
               <a:ext uri="{FF2B5EF4-FFF2-40B4-BE49-F238E27FC236}">
-                <a16:creationId xmlns:a16="http://schemas.microsoft.com/office/drawing/2014/main" id="{C013A5B9-30F1-419C-81AE-9540619BD2D7}"/>
+                <a16:creationId xmlns:a16="http://schemas.microsoft.com/office/drawing/2014/main" id="{99EDC790-A576-4C4B-AA4E-62CB0B3AEE4C}"/>
               </a:ext>
             </a:extLst>
           </p:cNvPr>
@@ -4953,7 +4953,7 @@
           <p:cNvPr id="5" name="">
             <a:extLst xmlns:a="http://schemas.openxmlformats.org/drawingml/2006/main">
               <a:ext uri="{FF2B5EF4-FFF2-40B4-BE49-F238E27FC236}">
-                <a16:creationId xmlns:a16="http://schemas.microsoft.com/office/drawing/2014/main" id="{55BBD7D2-11B8-4F9E-B19E-414D4811F57C}"/>
+                <a16:creationId xmlns:a16="http://schemas.microsoft.com/office/drawing/2014/main" id="{157FB09F-E135-4738-AA16-96FFAC5D41FD}"/>
               </a:ext>
             </a:extLst>
           </p:cNvPr>
@@ -5074,7 +5074,7 @@
           <p:cNvPr id="6" name="">
             <a:extLst xmlns:a="http://schemas.openxmlformats.org/drawingml/2006/main">
               <a:ext uri="{FF2B5EF4-FFF2-40B4-BE49-F238E27FC236}">
-                <a16:creationId xmlns:a16="http://schemas.microsoft.com/office/drawing/2014/main" id="{B8E0E1BD-6FC9-4BCB-A7C5-E3D4CAF89A9E}"/>
+                <a16:creationId xmlns:a16="http://schemas.microsoft.com/office/drawing/2014/main" id="{0F08D3FA-227D-421B-9CC2-80FDB1414C52}"/>
               </a:ext>
             </a:extLst>
           </p:cNvPr>
@@ -5195,7 +5195,7 @@
           <p:cNvPr id="7" name="">
             <a:extLst xmlns:a="http://schemas.openxmlformats.org/drawingml/2006/main">
               <a:ext uri="{FF2B5EF4-FFF2-40B4-BE49-F238E27FC236}">
-                <a16:creationId xmlns:a16="http://schemas.microsoft.com/office/drawing/2014/main" id="{64FAAA5B-797F-4C53-9D45-77418FE89A11}"/>
+                <a16:creationId xmlns:a16="http://schemas.microsoft.com/office/drawing/2014/main" id="{0EFBE938-FFAB-4E44-8874-DE62CE2A7193}"/>
               </a:ext>
             </a:extLst>
           </p:cNvPr>
@@ -5226,7 +5226,7 @@
           <p:cNvPr id="8" name="">
             <a:extLst xmlns:a="http://schemas.openxmlformats.org/drawingml/2006/main">
               <a:ext uri="{FF2B5EF4-FFF2-40B4-BE49-F238E27FC236}">
-                <a16:creationId xmlns:a16="http://schemas.microsoft.com/office/drawing/2014/main" id="{B16A6AC4-CE86-4C70-830A-8D005B3ED72D}"/>
+                <a16:creationId xmlns:a16="http://schemas.microsoft.com/office/drawing/2014/main" id="{08A7E191-A83E-44CD-B532-31B8886D8369}"/>
               </a:ext>
             </a:extLst>
           </p:cNvPr>
@@ -5347,7 +5347,7 @@
           <p:cNvPr id="9" name="">
             <a:extLst xmlns:a="http://schemas.openxmlformats.org/drawingml/2006/main">
               <a:ext uri="{FF2B5EF4-FFF2-40B4-BE49-F238E27FC236}">
-                <a16:creationId xmlns:a16="http://schemas.microsoft.com/office/drawing/2014/main" id="{ED61CD33-7BA9-4B7C-AE13-B1E26960BD06}"/>
+                <a16:creationId xmlns:a16="http://schemas.microsoft.com/office/drawing/2014/main" id="{CA7AE563-C7CC-452C-9B00-375886163044}"/>
               </a:ext>
             </a:extLst>
           </p:cNvPr>
@@ -5468,7 +5468,7 @@
           <p:cNvPr id="10" name="">
             <a:extLst xmlns:a="http://schemas.openxmlformats.org/drawingml/2006/main">
               <a:ext uri="{FF2B5EF4-FFF2-40B4-BE49-F238E27FC236}">
-                <a16:creationId xmlns:a16="http://schemas.microsoft.com/office/drawing/2014/main" id="{5836E952-BD15-4F7B-BFC8-72CC6B1D255D}"/>
+                <a16:creationId xmlns:a16="http://schemas.microsoft.com/office/drawing/2014/main" id="{4BEFD44E-31B6-4AF9-918E-39BCFEA45983}"/>
               </a:ext>
             </a:extLst>
           </p:cNvPr>
@@ -5499,7 +5499,7 @@
           <p:cNvPr id="11" name="">
             <a:extLst xmlns:a="http://schemas.openxmlformats.org/drawingml/2006/main">
               <a:ext uri="{FF2B5EF4-FFF2-40B4-BE49-F238E27FC236}">
-                <a16:creationId xmlns:a16="http://schemas.microsoft.com/office/drawing/2014/main" id="{8B9DC1EA-DDC7-4F3B-B11C-BBE42638B12F}"/>
+                <a16:creationId xmlns:a16="http://schemas.microsoft.com/office/drawing/2014/main" id="{D407E8CE-6EFD-479B-9CA7-758515E1990A}"/>
               </a:ext>
             </a:extLst>
           </p:cNvPr>
@@ -5620,7 +5620,7 @@
           <p:cNvPr id="12" name="">
             <a:extLst xmlns:a="http://schemas.openxmlformats.org/drawingml/2006/main">
               <a:ext uri="{FF2B5EF4-FFF2-40B4-BE49-F238E27FC236}">
-                <a16:creationId xmlns:a16="http://schemas.microsoft.com/office/drawing/2014/main" id="{31C37BBF-A6B3-4683-885C-EFCB8D4A69AE}"/>
+                <a16:creationId xmlns:a16="http://schemas.microsoft.com/office/drawing/2014/main" id="{57CB6F5C-91F5-4EDC-8A27-533F73A9CC76}"/>
               </a:ext>
             </a:extLst>
           </p:cNvPr>
@@ -5741,7 +5741,7 @@
           <p:cNvPr id="13" name="">
             <a:extLst xmlns:a="http://schemas.openxmlformats.org/drawingml/2006/main">
               <a:ext uri="{FF2B5EF4-FFF2-40B4-BE49-F238E27FC236}">
-                <a16:creationId xmlns:a16="http://schemas.microsoft.com/office/drawing/2014/main" id="{FB38CD32-6C40-46C9-990A-C757250AF3B5}"/>
+                <a16:creationId xmlns:a16="http://schemas.microsoft.com/office/drawing/2014/main" id="{F7818D9B-3192-4B13-B3CC-8CAF3B003A29}"/>
               </a:ext>
             </a:extLst>
           </p:cNvPr>
@@ -5862,7 +5862,7 @@
           <p:cNvPr id="14" name="">
             <a:extLst xmlns:a="http://schemas.openxmlformats.org/drawingml/2006/main">
               <a:ext uri="{FF2B5EF4-FFF2-40B4-BE49-F238E27FC236}">
-                <a16:creationId xmlns:a16="http://schemas.microsoft.com/office/drawing/2014/main" id="{67CE58D8-0BE7-49EA-90F8-B75275C27401}"/>
+                <a16:creationId xmlns:a16="http://schemas.microsoft.com/office/drawing/2014/main" id="{69B5466E-D7FD-4EE5-8B50-A92826EE6302}"/>
               </a:ext>
             </a:extLst>
           </p:cNvPr>
@@ -5983,7 +5983,7 @@
           <p:cNvPr id="15" name="">
             <a:extLst xmlns:a="http://schemas.openxmlformats.org/drawingml/2006/main">
               <a:ext uri="{FF2B5EF4-FFF2-40B4-BE49-F238E27FC236}">
-                <a16:creationId xmlns:a16="http://schemas.microsoft.com/office/drawing/2014/main" id="{3AB87795-317C-4400-A173-8FEBD470AD7B}"/>
+                <a16:creationId xmlns:a16="http://schemas.microsoft.com/office/drawing/2014/main" id="{88870E3A-1101-4E46-99BF-F942A65272A0}"/>
               </a:ext>
             </a:extLst>
           </p:cNvPr>
@@ -6102,7 +6102,7 @@
     </p:spTree>
     <p:extLst>
       <p:ext uri="{BB962C8B-B14F-4D97-AF65-F5344CB8AC3E}">
-        <p14:creationId xmlns:p14="http://schemas.microsoft.com/office/powerpoint/2010/main" val="1357394783"/>
+        <p14:creationId xmlns:p14="http://schemas.microsoft.com/office/powerpoint/2010/main" val="124594647"/>
       </p:ext>
     </p:extLst>
   </p:cSld>
@@ -6133,7 +6133,7 @@
           <p:cNvPr id="25" name="">
             <a:extLst xmlns:a="http://schemas.openxmlformats.org/drawingml/2006/main">
               <a:ext uri="{FF2B5EF4-FFF2-40B4-BE49-F238E27FC236}">
-                <a16:creationId xmlns:a16="http://schemas.microsoft.com/office/drawing/2014/main" id="{2816D630-4491-4A61-A6F2-2E4B694DA0E7}"/>
+                <a16:creationId xmlns:a16="http://schemas.microsoft.com/office/drawing/2014/main" id="{055A1EA5-909F-4194-B9CC-4CF3B39D7993}"/>
               </a:ext>
             </a:extLst>
           </p:cNvPr>
@@ -6254,7 +6254,7 @@
           <p:cNvPr id="2" name="">
             <a:extLst xmlns:a="http://schemas.openxmlformats.org/drawingml/2006/main">
               <a:ext uri="{FF2B5EF4-FFF2-40B4-BE49-F238E27FC236}">
-                <a16:creationId xmlns:a16="http://schemas.microsoft.com/office/drawing/2014/main" id="{75DD37C7-313B-4A4D-B6A3-A58570CC5C34}"/>
+                <a16:creationId xmlns:a16="http://schemas.microsoft.com/office/drawing/2014/main" id="{2F15F5BB-ABFE-4B71-99C2-4B82E21EC8B5}"/>
               </a:ext>
             </a:extLst>
           </p:cNvPr>
@@ -6375,7 +6375,7 @@
           <p:cNvPr id="3" name="">
             <a:extLst xmlns:a="http://schemas.openxmlformats.org/drawingml/2006/main">
               <a:ext uri="{FF2B5EF4-FFF2-40B4-BE49-F238E27FC236}">
-                <a16:creationId xmlns:a16="http://schemas.microsoft.com/office/drawing/2014/main" id="{540292E5-7E69-43D4-A28B-FF2829533677}"/>
+                <a16:creationId xmlns:a16="http://schemas.microsoft.com/office/drawing/2014/main" id="{216ED678-CD60-4452-B311-B5FB96CBC586}"/>
               </a:ext>
             </a:extLst>
           </p:cNvPr>
@@ -6496,7 +6496,7 @@
           <p:cNvPr id="4" name="">
             <a:extLst xmlns:a="http://schemas.openxmlformats.org/drawingml/2006/main">
               <a:ext uri="{FF2B5EF4-FFF2-40B4-BE49-F238E27FC236}">
-                <a16:creationId xmlns:a16="http://schemas.microsoft.com/office/drawing/2014/main" id="{9D4AA4CC-37B2-4599-B7C4-C60B3F6A8C21}"/>
+                <a16:creationId xmlns:a16="http://schemas.microsoft.com/office/drawing/2014/main" id="{17AD5446-3BA1-4BF9-AD85-057F2839B587}"/>
               </a:ext>
             </a:extLst>
           </p:cNvPr>
@@ -6527,7 +6527,7 @@
           <p:cNvPr id="5" name="">
             <a:extLst xmlns:a="http://schemas.openxmlformats.org/drawingml/2006/main">
               <a:ext uri="{FF2B5EF4-FFF2-40B4-BE49-F238E27FC236}">
-                <a16:creationId xmlns:a16="http://schemas.microsoft.com/office/drawing/2014/main" id="{C451462D-5F3C-46BB-881E-33D3067D2799}"/>
+                <a16:creationId xmlns:a16="http://schemas.microsoft.com/office/drawing/2014/main" id="{1C97C303-A446-497F-A1A5-655BF9D753EA}"/>
               </a:ext>
             </a:extLst>
           </p:cNvPr>
@@ -6562,7 +6562,7 @@
           <p:cNvPr id="6" name="">
             <a:extLst xmlns:a="http://schemas.openxmlformats.org/drawingml/2006/main">
               <a:ext uri="{FF2B5EF4-FFF2-40B4-BE49-F238E27FC236}">
-                <a16:creationId xmlns:a16="http://schemas.microsoft.com/office/drawing/2014/main" id="{6B6F9BBA-8F98-4073-95AE-E2D7AA544DA6}"/>
+                <a16:creationId xmlns:a16="http://schemas.microsoft.com/office/drawing/2014/main" id="{6048B332-3167-4C97-8CDC-EFE573162957}"/>
               </a:ext>
             </a:extLst>
           </p:cNvPr>
@@ -6683,7 +6683,7 @@
           <p:cNvPr id="7" name="">
             <a:extLst xmlns:a="http://schemas.openxmlformats.org/drawingml/2006/main">
               <a:ext uri="{FF2B5EF4-FFF2-40B4-BE49-F238E27FC236}">
-                <a16:creationId xmlns:a16="http://schemas.microsoft.com/office/drawing/2014/main" id="{E9967641-EC0A-4FC9-8E4D-F3D38D5B8372}"/>
+                <a16:creationId xmlns:a16="http://schemas.microsoft.com/office/drawing/2014/main" id="{4B6AB21B-0C51-4940-852E-4779C326F481}"/>
               </a:ext>
             </a:extLst>
           </p:cNvPr>
@@ -6821,7 +6821,7 @@
           <p:cNvPr id="8" name="">
             <a:extLst xmlns:a="http://schemas.openxmlformats.org/drawingml/2006/main">
               <a:ext uri="{FF2B5EF4-FFF2-40B4-BE49-F238E27FC236}">
-                <a16:creationId xmlns:a16="http://schemas.microsoft.com/office/drawing/2014/main" id="{CB56EC85-E1F8-4692-A0C1-E25DAF3D0C81}"/>
+                <a16:creationId xmlns:a16="http://schemas.microsoft.com/office/drawing/2014/main" id="{1F508C16-5AF8-4A0F-8F85-B5C642E85060}"/>
               </a:ext>
             </a:extLst>
           </p:cNvPr>
@@ -6856,7 +6856,7 @@
           <p:cNvPr id="9" name="">
             <a:extLst xmlns:a="http://schemas.openxmlformats.org/drawingml/2006/main">
               <a:ext uri="{FF2B5EF4-FFF2-40B4-BE49-F238E27FC236}">
-                <a16:creationId xmlns:a16="http://schemas.microsoft.com/office/drawing/2014/main" id="{D0919592-720B-4A18-B000-645A3C894095}"/>
+                <a16:creationId xmlns:a16="http://schemas.microsoft.com/office/drawing/2014/main" id="{F3CA054D-C494-4A66-B90D-7D1F0F04F9DB}"/>
               </a:ext>
             </a:extLst>
           </p:cNvPr>
@@ -6977,7 +6977,7 @@
           <p:cNvPr id="10" name="">
             <a:extLst xmlns:a="http://schemas.openxmlformats.org/drawingml/2006/main">
               <a:ext uri="{FF2B5EF4-FFF2-40B4-BE49-F238E27FC236}">
-                <a16:creationId xmlns:a16="http://schemas.microsoft.com/office/drawing/2014/main" id="{DA8BE3FB-3577-4E58-AACA-80787E8DE39C}"/>
+                <a16:creationId xmlns:a16="http://schemas.microsoft.com/office/drawing/2014/main" id="{4FF4FBEA-120C-44F0-B230-4EF2C39A6BDA}"/>
               </a:ext>
             </a:extLst>
           </p:cNvPr>
@@ -7088,7 +7088,7 @@
                   <a:srgbClr val="20392D"/>
                 </a:solidFill>
               </a:rPr>
-              <a:t>Qwen 2.5 1.5B</a:t>
+              <a:t>Qwen2.5 1.5B</a:t>
             </a:r>
           </a:p>
           <a:p xmlns:a="http://schemas.openxmlformats.org/drawingml/2006/main">
@@ -7105,7 +7105,7 @@
                   <a:srgbClr val="20392D"/>
                 </a:solidFill>
               </a:rPr>
-              <a:t>field extraction</a:t>
+              <a:t>base weights; no fine-tuning</a:t>
             </a:r>
           </a:p>
         </p:txBody>
@@ -7115,7 +7115,7 @@
           <p:cNvPr id="11" name="">
             <a:extLst xmlns:a="http://schemas.openxmlformats.org/drawingml/2006/main">
               <a:ext uri="{FF2B5EF4-FFF2-40B4-BE49-F238E27FC236}">
-                <a16:creationId xmlns:a16="http://schemas.microsoft.com/office/drawing/2014/main" id="{DC888BB2-49C9-4C9B-8FFA-E4642172B1AB}"/>
+                <a16:creationId xmlns:a16="http://schemas.microsoft.com/office/drawing/2014/main" id="{5D667D24-4B02-4C75-8864-880C083B6C61}"/>
               </a:ext>
             </a:extLst>
           </p:cNvPr>
@@ -7150,7 +7150,7 @@
           <p:cNvPr id="12" name="">
             <a:extLst xmlns:a="http://schemas.openxmlformats.org/drawingml/2006/main">
               <a:ext uri="{FF2B5EF4-FFF2-40B4-BE49-F238E27FC236}">
-                <a16:creationId xmlns:a16="http://schemas.microsoft.com/office/drawing/2014/main" id="{34B0C24E-3FC3-4A66-958E-3EE94C609AF7}"/>
+                <a16:creationId xmlns:a16="http://schemas.microsoft.com/office/drawing/2014/main" id="{33AF1022-7469-4DCE-8433-AD2940F242B7}"/>
               </a:ext>
             </a:extLst>
           </p:cNvPr>
@@ -7271,7 +7271,7 @@
           <p:cNvPr id="13" name="">
             <a:extLst xmlns:a="http://schemas.openxmlformats.org/drawingml/2006/main">
               <a:ext uri="{FF2B5EF4-FFF2-40B4-BE49-F238E27FC236}">
-                <a16:creationId xmlns:a16="http://schemas.microsoft.com/office/drawing/2014/main" id="{293AA799-080E-4D05-A3D0-E08AC31274C3}"/>
+                <a16:creationId xmlns:a16="http://schemas.microsoft.com/office/drawing/2014/main" id="{96D6E5BE-914C-4C8F-91F0-7013DE148EC0}"/>
               </a:ext>
             </a:extLst>
           </p:cNvPr>
@@ -7409,7 +7409,7 @@
           <p:cNvPr id="14" name="">
             <a:extLst xmlns:a="http://schemas.openxmlformats.org/drawingml/2006/main">
               <a:ext uri="{FF2B5EF4-FFF2-40B4-BE49-F238E27FC236}">
-                <a16:creationId xmlns:a16="http://schemas.microsoft.com/office/drawing/2014/main" id="{435E9FAA-C0C7-4C9E-A703-A598237B317C}"/>
+                <a16:creationId xmlns:a16="http://schemas.microsoft.com/office/drawing/2014/main" id="{C9C956B3-FEA6-4867-87C4-A1698C017B31}"/>
               </a:ext>
             </a:extLst>
           </p:cNvPr>
@@ -7444,7 +7444,7 @@
           <p:cNvPr id="15" name="">
             <a:extLst xmlns:a="http://schemas.openxmlformats.org/drawingml/2006/main">
               <a:ext uri="{FF2B5EF4-FFF2-40B4-BE49-F238E27FC236}">
-                <a16:creationId xmlns:a16="http://schemas.microsoft.com/office/drawing/2014/main" id="{0E9A59A5-405F-4DBF-A8AE-A01D8874AFEF}"/>
+                <a16:creationId xmlns:a16="http://schemas.microsoft.com/office/drawing/2014/main" id="{24D64DD1-F9F7-4EC5-827D-FAACA2554946}"/>
               </a:ext>
             </a:extLst>
           </p:cNvPr>
@@ -7565,7 +7565,7 @@
           <p:cNvPr id="16" name="">
             <a:extLst xmlns:a="http://schemas.openxmlformats.org/drawingml/2006/main">
               <a:ext uri="{FF2B5EF4-FFF2-40B4-BE49-F238E27FC236}">
-                <a16:creationId xmlns:a16="http://schemas.microsoft.com/office/drawing/2014/main" id="{80E25466-78A0-485A-9D78-F92584EBDDAA}"/>
+                <a16:creationId xmlns:a16="http://schemas.microsoft.com/office/drawing/2014/main" id="{21AD73C2-921B-421A-BF88-BF1468A9113C}"/>
               </a:ext>
             </a:extLst>
           </p:cNvPr>
@@ -7703,7 +7703,7 @@
           <p:cNvPr id="17" name="">
             <a:extLst xmlns:a="http://schemas.openxmlformats.org/drawingml/2006/main">
               <a:ext uri="{FF2B5EF4-FFF2-40B4-BE49-F238E27FC236}">
-                <a16:creationId xmlns:a16="http://schemas.microsoft.com/office/drawing/2014/main" id="{B4274F52-9ACE-4780-A1C4-C57038E503B6}"/>
+                <a16:creationId xmlns:a16="http://schemas.microsoft.com/office/drawing/2014/main" id="{979F8FA3-C68B-4D8A-B243-DA55DA34ED2C}"/>
               </a:ext>
             </a:extLst>
           </p:cNvPr>
@@ -7734,7 +7734,7 @@
           <p:cNvPr id="18" name="">
             <a:extLst xmlns:a="http://schemas.openxmlformats.org/drawingml/2006/main">
               <a:ext uri="{FF2B5EF4-FFF2-40B4-BE49-F238E27FC236}">
-                <a16:creationId xmlns:a16="http://schemas.microsoft.com/office/drawing/2014/main" id="{5CB3D1C7-1532-490E-BF12-E428CC393029}"/>
+                <a16:creationId xmlns:a16="http://schemas.microsoft.com/office/drawing/2014/main" id="{8508F799-7D1F-46BC-BF52-446E2684AFC7}"/>
               </a:ext>
             </a:extLst>
           </p:cNvPr>
@@ -7765,7 +7765,7 @@
           <p:cNvPr id="19" name="">
             <a:extLst xmlns:a="http://schemas.openxmlformats.org/drawingml/2006/main">
               <a:ext uri="{FF2B5EF4-FFF2-40B4-BE49-F238E27FC236}">
-                <a16:creationId xmlns:a16="http://schemas.microsoft.com/office/drawing/2014/main" id="{C1736609-28D0-4EBA-9328-C83A72B84EC4}"/>
+                <a16:creationId xmlns:a16="http://schemas.microsoft.com/office/drawing/2014/main" id="{5F829E89-86C6-497A-976D-524FCF5AF00A}"/>
               </a:ext>
             </a:extLst>
           </p:cNvPr>
@@ -7796,7 +7796,7 @@
           <p:cNvPr id="20" name="">
             <a:extLst xmlns:a="http://schemas.openxmlformats.org/drawingml/2006/main">
               <a:ext uri="{FF2B5EF4-FFF2-40B4-BE49-F238E27FC236}">
-                <a16:creationId xmlns:a16="http://schemas.microsoft.com/office/drawing/2014/main" id="{677D35B2-F6F0-4187-9620-83C250093773}"/>
+                <a16:creationId xmlns:a16="http://schemas.microsoft.com/office/drawing/2014/main" id="{22EAC340-B076-43F9-873A-4DC70385BC5F}"/>
               </a:ext>
             </a:extLst>
           </p:cNvPr>
@@ -7827,7 +7827,7 @@
           <p:cNvPr id="21" name="">
             <a:extLst xmlns:a="http://schemas.openxmlformats.org/drawingml/2006/main">
               <a:ext uri="{FF2B5EF4-FFF2-40B4-BE49-F238E27FC236}">
-                <a16:creationId xmlns:a16="http://schemas.microsoft.com/office/drawing/2014/main" id="{41A6ACEB-FB95-41D3-8D29-49F8271EFDC3}"/>
+                <a16:creationId xmlns:a16="http://schemas.microsoft.com/office/drawing/2014/main" id="{E0804F40-D49F-456C-B4D9-5FBE62F0E702}"/>
               </a:ext>
             </a:extLst>
           </p:cNvPr>
@@ -7948,7 +7948,7 @@
           <p:cNvPr id="22" name="">
             <a:extLst xmlns:a="http://schemas.openxmlformats.org/drawingml/2006/main">
               <a:ext uri="{FF2B5EF4-FFF2-40B4-BE49-F238E27FC236}">
-                <a16:creationId xmlns:a16="http://schemas.microsoft.com/office/drawing/2014/main" id="{38AE6FF3-61E8-4FF8-9D22-0DC9C3F9880F}"/>
+                <a16:creationId xmlns:a16="http://schemas.microsoft.com/office/drawing/2014/main" id="{3EC081F8-9431-45CE-9442-7C7CF33578E2}"/>
               </a:ext>
             </a:extLst>
           </p:cNvPr>
@@ -8086,7 +8086,7 @@
           <p:cNvPr id="23" name="">
             <a:extLst xmlns:a="http://schemas.openxmlformats.org/drawingml/2006/main">
               <a:ext uri="{FF2B5EF4-FFF2-40B4-BE49-F238E27FC236}">
-                <a16:creationId xmlns:a16="http://schemas.microsoft.com/office/drawing/2014/main" id="{81CAE535-59E8-49CA-89AE-D3E277AB7CBC}"/>
+                <a16:creationId xmlns:a16="http://schemas.microsoft.com/office/drawing/2014/main" id="{ABB859DB-CB91-4F92-BA69-C5A537B41E5D}"/>
               </a:ext>
             </a:extLst>
           </p:cNvPr>
@@ -8207,7 +8207,7 @@
           <p:cNvPr id="24" name="">
             <a:extLst xmlns:a="http://schemas.openxmlformats.org/drawingml/2006/main">
               <a:ext uri="{FF2B5EF4-FFF2-40B4-BE49-F238E27FC236}">
-                <a16:creationId xmlns:a16="http://schemas.microsoft.com/office/drawing/2014/main" id="{E8A164BC-5AB7-4D7A-8570-124AD0C73610}"/>
+                <a16:creationId xmlns:a16="http://schemas.microsoft.com/office/drawing/2014/main" id="{040BC6B2-5DCE-4573-8537-2760642990D9}"/>
               </a:ext>
             </a:extLst>
           </p:cNvPr>
@@ -8326,7 +8326,7 @@
     </p:spTree>
     <p:extLst>
       <p:ext uri="{BB962C8B-B14F-4D97-AF65-F5344CB8AC3E}">
-        <p14:creationId xmlns:p14="http://schemas.microsoft.com/office/powerpoint/2010/main" val="1692523861"/>
+        <p14:creationId xmlns:p14="http://schemas.microsoft.com/office/powerpoint/2010/main" val="419334688"/>
       </p:ext>
     </p:extLst>
   </p:cSld>
@@ -8357,7 +8357,7 @@
           <p:cNvPr id="32" name="">
             <a:extLst xmlns:a="http://schemas.openxmlformats.org/drawingml/2006/main">
               <a:ext uri="{FF2B5EF4-FFF2-40B4-BE49-F238E27FC236}">
-                <a16:creationId xmlns:a16="http://schemas.microsoft.com/office/drawing/2014/main" id="{655D08C0-FE29-4580-A923-73FDBA13D0C1}"/>
+                <a16:creationId xmlns:a16="http://schemas.microsoft.com/office/drawing/2014/main" id="{073255EC-682A-40A7-84D5-B261393360D9}"/>
               </a:ext>
             </a:extLst>
           </p:cNvPr>
@@ -8478,7 +8478,7 @@
           <p:cNvPr id="2" name="">
             <a:extLst xmlns:a="http://schemas.openxmlformats.org/drawingml/2006/main">
               <a:ext uri="{FF2B5EF4-FFF2-40B4-BE49-F238E27FC236}">
-                <a16:creationId xmlns:a16="http://schemas.microsoft.com/office/drawing/2014/main" id="{03BC013F-C618-47C2-9B77-13DBEDC9BCF8}"/>
+                <a16:creationId xmlns:a16="http://schemas.microsoft.com/office/drawing/2014/main" id="{3249CDBF-9813-4027-8D49-3AE92210E68F}"/>
               </a:ext>
             </a:extLst>
           </p:cNvPr>
@@ -8599,7 +8599,7 @@
           <p:cNvPr id="3" name="">
             <a:extLst xmlns:a="http://schemas.openxmlformats.org/drawingml/2006/main">
               <a:ext uri="{FF2B5EF4-FFF2-40B4-BE49-F238E27FC236}">
-                <a16:creationId xmlns:a16="http://schemas.microsoft.com/office/drawing/2014/main" id="{C7683150-D0B0-4C17-9C46-43C40187811E}"/>
+                <a16:creationId xmlns:a16="http://schemas.microsoft.com/office/drawing/2014/main" id="{F214B652-BB81-4D0B-A044-31ED83EAC679}"/>
               </a:ext>
             </a:extLst>
           </p:cNvPr>
@@ -8720,7 +8720,7 @@
           <p:cNvPr id="4" name="">
             <a:extLst xmlns:a="http://schemas.openxmlformats.org/drawingml/2006/main">
               <a:ext uri="{FF2B5EF4-FFF2-40B4-BE49-F238E27FC236}">
-                <a16:creationId xmlns:a16="http://schemas.microsoft.com/office/drawing/2014/main" id="{5978BCF6-3F57-4989-B0A7-0087B6A2085E}"/>
+                <a16:creationId xmlns:a16="http://schemas.microsoft.com/office/drawing/2014/main" id="{A1B47A71-DFC2-49ED-87A0-EB62C2DA8E28}"/>
               </a:ext>
             </a:extLst>
           </p:cNvPr>
@@ -8751,7 +8751,7 @@
           <p:cNvPr id="5" name="">
             <a:extLst xmlns:a="http://schemas.openxmlformats.org/drawingml/2006/main">
               <a:ext uri="{FF2B5EF4-FFF2-40B4-BE49-F238E27FC236}">
-                <a16:creationId xmlns:a16="http://schemas.microsoft.com/office/drawing/2014/main" id="{7DED223C-C93D-40C3-BB62-ADD6234F0B57}"/>
+                <a16:creationId xmlns:a16="http://schemas.microsoft.com/office/drawing/2014/main" id="{C2D5478C-C969-4988-A14B-3788E9340DFE}"/>
               </a:ext>
             </a:extLst>
           </p:cNvPr>
@@ -8872,7 +8872,7 @@
           <p:cNvPr id="6" name="">
             <a:extLst xmlns:a="http://schemas.openxmlformats.org/drawingml/2006/main">
               <a:ext uri="{FF2B5EF4-FFF2-40B4-BE49-F238E27FC236}">
-                <a16:creationId xmlns:a16="http://schemas.microsoft.com/office/drawing/2014/main" id="{AE23AFF1-E4B4-428F-8329-0AA92DC8B7EB}"/>
+                <a16:creationId xmlns:a16="http://schemas.microsoft.com/office/drawing/2014/main" id="{95C3EDCC-ADEE-403D-BA01-20E37E51B460}"/>
               </a:ext>
             </a:extLst>
           </p:cNvPr>
@@ -8993,7 +8993,7 @@
           <p:cNvPr id="7" name="">
             <a:extLst xmlns:a="http://schemas.openxmlformats.org/drawingml/2006/main">
               <a:ext uri="{FF2B5EF4-FFF2-40B4-BE49-F238E27FC236}">
-                <a16:creationId xmlns:a16="http://schemas.microsoft.com/office/drawing/2014/main" id="{A0A30885-ADD2-4F11-8747-D0D71572DD6D}"/>
+                <a16:creationId xmlns:a16="http://schemas.microsoft.com/office/drawing/2014/main" id="{B6ED80F1-411B-4021-8B85-ECDE6A553C78}"/>
               </a:ext>
             </a:extLst>
           </p:cNvPr>
@@ -9024,7 +9024,7 @@
           <p:cNvPr id="8" name="">
             <a:extLst xmlns:a="http://schemas.openxmlformats.org/drawingml/2006/main">
               <a:ext uri="{FF2B5EF4-FFF2-40B4-BE49-F238E27FC236}">
-                <a16:creationId xmlns:a16="http://schemas.microsoft.com/office/drawing/2014/main" id="{3B8F9C65-7CE6-41B8-B2F9-A345B2C15390}"/>
+                <a16:creationId xmlns:a16="http://schemas.microsoft.com/office/drawing/2014/main" id="{0DD9C21C-2AED-446E-AEFC-1DCCCD2DE07A}"/>
               </a:ext>
             </a:extLst>
           </p:cNvPr>
@@ -9055,7 +9055,7 @@
           <p:cNvPr id="9" name="">
             <a:extLst xmlns:a="http://schemas.openxmlformats.org/drawingml/2006/main">
               <a:ext uri="{FF2B5EF4-FFF2-40B4-BE49-F238E27FC236}">
-                <a16:creationId xmlns:a16="http://schemas.microsoft.com/office/drawing/2014/main" id="{9FA4A3B0-C8CE-4A86-9BC9-57F4696DBF45}"/>
+                <a16:creationId xmlns:a16="http://schemas.microsoft.com/office/drawing/2014/main" id="{7CD79D19-06BF-4402-8F36-9F06CCDC9F86}"/>
               </a:ext>
             </a:extLst>
           </p:cNvPr>
@@ -9176,7 +9176,7 @@
           <p:cNvPr id="10" name="">
             <a:extLst xmlns:a="http://schemas.openxmlformats.org/drawingml/2006/main">
               <a:ext uri="{FF2B5EF4-FFF2-40B4-BE49-F238E27FC236}">
-                <a16:creationId xmlns:a16="http://schemas.microsoft.com/office/drawing/2014/main" id="{41A80D88-2FBD-44EF-8C3B-10829E508058}"/>
+                <a16:creationId xmlns:a16="http://schemas.microsoft.com/office/drawing/2014/main" id="{7FB21133-368A-4874-8640-B98BCF702738}"/>
               </a:ext>
             </a:extLst>
           </p:cNvPr>
@@ -9297,7 +9297,7 @@
           <p:cNvPr id="11" name="">
             <a:extLst xmlns:a="http://schemas.openxmlformats.org/drawingml/2006/main">
               <a:ext uri="{FF2B5EF4-FFF2-40B4-BE49-F238E27FC236}">
-                <a16:creationId xmlns:a16="http://schemas.microsoft.com/office/drawing/2014/main" id="{D4FDCB22-BD8C-46CF-B4D3-1B6DC7BDEEDD}"/>
+                <a16:creationId xmlns:a16="http://schemas.microsoft.com/office/drawing/2014/main" id="{CB479311-AAB1-41EB-8346-C314CAA4B96E}"/>
               </a:ext>
             </a:extLst>
           </p:cNvPr>
@@ -9328,7 +9328,7 @@
           <p:cNvPr id="12" name="">
             <a:extLst xmlns:a="http://schemas.openxmlformats.org/drawingml/2006/main">
               <a:ext uri="{FF2B5EF4-FFF2-40B4-BE49-F238E27FC236}">
-                <a16:creationId xmlns:a16="http://schemas.microsoft.com/office/drawing/2014/main" id="{43C2ABC9-C658-49A7-85F8-8C80E92AB5AC}"/>
+                <a16:creationId xmlns:a16="http://schemas.microsoft.com/office/drawing/2014/main" id="{1889FCD4-62E6-4378-8FA9-1160528D99A1}"/>
               </a:ext>
             </a:extLst>
           </p:cNvPr>
@@ -9359,7 +9359,7 @@
           <p:cNvPr id="13" name="">
             <a:extLst xmlns:a="http://schemas.openxmlformats.org/drawingml/2006/main">
               <a:ext uri="{FF2B5EF4-FFF2-40B4-BE49-F238E27FC236}">
-                <a16:creationId xmlns:a16="http://schemas.microsoft.com/office/drawing/2014/main" id="{C5855CC3-AEDC-4C0F-A97F-B777F4420BA8}"/>
+                <a16:creationId xmlns:a16="http://schemas.microsoft.com/office/drawing/2014/main" id="{8863AC76-9324-4160-919D-D4152F174C34}"/>
               </a:ext>
             </a:extLst>
           </p:cNvPr>
@@ -9480,7 +9480,7 @@
           <p:cNvPr id="14" name="">
             <a:extLst xmlns:a="http://schemas.openxmlformats.org/drawingml/2006/main">
               <a:ext uri="{FF2B5EF4-FFF2-40B4-BE49-F238E27FC236}">
-                <a16:creationId xmlns:a16="http://schemas.microsoft.com/office/drawing/2014/main" id="{4B15FCB1-E352-401A-85A6-8915B73226E5}"/>
+                <a16:creationId xmlns:a16="http://schemas.microsoft.com/office/drawing/2014/main" id="{F84A094B-40B9-42BF-8B13-B7760A63E0F6}"/>
               </a:ext>
             </a:extLst>
           </p:cNvPr>
@@ -9601,7 +9601,7 @@
           <p:cNvPr id="15" name="">
             <a:extLst xmlns:a="http://schemas.openxmlformats.org/drawingml/2006/main">
               <a:ext uri="{FF2B5EF4-FFF2-40B4-BE49-F238E27FC236}">
-                <a16:creationId xmlns:a16="http://schemas.microsoft.com/office/drawing/2014/main" id="{54290AD5-CE33-4CF3-9B3A-78F351DCDA5B}"/>
+                <a16:creationId xmlns:a16="http://schemas.microsoft.com/office/drawing/2014/main" id="{5501F65B-B0AE-45E5-958A-EDC5BE737E9A}"/>
               </a:ext>
             </a:extLst>
           </p:cNvPr>
@@ -9632,7 +9632,7 @@
           <p:cNvPr id="16" name="">
             <a:extLst xmlns:a="http://schemas.openxmlformats.org/drawingml/2006/main">
               <a:ext uri="{FF2B5EF4-FFF2-40B4-BE49-F238E27FC236}">
-                <a16:creationId xmlns:a16="http://schemas.microsoft.com/office/drawing/2014/main" id="{BC2A0A9F-A687-4A50-9D00-F69E5C151E5F}"/>
+                <a16:creationId xmlns:a16="http://schemas.microsoft.com/office/drawing/2014/main" id="{91737773-F398-4DE0-A14D-B6B3B69B1D43}"/>
               </a:ext>
             </a:extLst>
           </p:cNvPr>
@@ -9663,7 +9663,7 @@
           <p:cNvPr id="17" name="">
             <a:extLst xmlns:a="http://schemas.openxmlformats.org/drawingml/2006/main">
               <a:ext uri="{FF2B5EF4-FFF2-40B4-BE49-F238E27FC236}">
-                <a16:creationId xmlns:a16="http://schemas.microsoft.com/office/drawing/2014/main" id="{054C6B8F-53E6-4147-BEF8-7C12C2CE4C14}"/>
+                <a16:creationId xmlns:a16="http://schemas.microsoft.com/office/drawing/2014/main" id="{96BF96D0-CCD3-463C-B817-9FE5B1EDA581}"/>
               </a:ext>
             </a:extLst>
           </p:cNvPr>
@@ -9784,7 +9784,7 @@
           <p:cNvPr id="18" name="">
             <a:extLst xmlns:a="http://schemas.openxmlformats.org/drawingml/2006/main">
               <a:ext uri="{FF2B5EF4-FFF2-40B4-BE49-F238E27FC236}">
-                <a16:creationId xmlns:a16="http://schemas.microsoft.com/office/drawing/2014/main" id="{4958B12A-529F-4283-A2CA-8A5400436694}"/>
+                <a16:creationId xmlns:a16="http://schemas.microsoft.com/office/drawing/2014/main" id="{9AD87291-27E8-438E-AB8C-AC6ED62B2895}"/>
               </a:ext>
             </a:extLst>
           </p:cNvPr>
@@ -9905,7 +9905,7 @@
           <p:cNvPr id="19" name="">
             <a:extLst xmlns:a="http://schemas.openxmlformats.org/drawingml/2006/main">
               <a:ext uri="{FF2B5EF4-FFF2-40B4-BE49-F238E27FC236}">
-                <a16:creationId xmlns:a16="http://schemas.microsoft.com/office/drawing/2014/main" id="{3F9681E6-F687-4C16-8E24-88DE8271A5CA}"/>
+                <a16:creationId xmlns:a16="http://schemas.microsoft.com/office/drawing/2014/main" id="{C79346E0-CCEF-4990-91DA-C3DAB8F68737}"/>
               </a:ext>
             </a:extLst>
           </p:cNvPr>
@@ -9936,7 +9936,7 @@
           <p:cNvPr id="20" name="">
             <a:extLst xmlns:a="http://schemas.openxmlformats.org/drawingml/2006/main">
               <a:ext uri="{FF2B5EF4-FFF2-40B4-BE49-F238E27FC236}">
-                <a16:creationId xmlns:a16="http://schemas.microsoft.com/office/drawing/2014/main" id="{0A66E8A2-18D1-4A60-B5AB-09BAE2564CE7}"/>
+                <a16:creationId xmlns:a16="http://schemas.microsoft.com/office/drawing/2014/main" id="{AE716A24-7AC6-46F6-BB22-37BC324C621B}"/>
               </a:ext>
             </a:extLst>
           </p:cNvPr>
@@ -9967,7 +9967,7 @@
           <p:cNvPr id="21" name="">
             <a:extLst xmlns:a="http://schemas.openxmlformats.org/drawingml/2006/main">
               <a:ext uri="{FF2B5EF4-FFF2-40B4-BE49-F238E27FC236}">
-                <a16:creationId xmlns:a16="http://schemas.microsoft.com/office/drawing/2014/main" id="{9AF03094-7605-47AE-9F11-F99199F32B62}"/>
+                <a16:creationId xmlns:a16="http://schemas.microsoft.com/office/drawing/2014/main" id="{E54A317C-1079-4418-AF82-30F1094C749B}"/>
               </a:ext>
             </a:extLst>
           </p:cNvPr>
@@ -10088,7 +10088,7 @@
           <p:cNvPr id="22" name="">
             <a:extLst xmlns:a="http://schemas.openxmlformats.org/drawingml/2006/main">
               <a:ext uri="{FF2B5EF4-FFF2-40B4-BE49-F238E27FC236}">
-                <a16:creationId xmlns:a16="http://schemas.microsoft.com/office/drawing/2014/main" id="{24A5C5A9-8C15-44D0-BB5A-A29BF0E03DA3}"/>
+                <a16:creationId xmlns:a16="http://schemas.microsoft.com/office/drawing/2014/main" id="{4D4E8E93-D5EB-4E0B-9D19-ACF6D64C9F2D}"/>
               </a:ext>
             </a:extLst>
           </p:cNvPr>
@@ -10209,7 +10209,7 @@
           <p:cNvPr id="23" name="">
             <a:extLst xmlns:a="http://schemas.openxmlformats.org/drawingml/2006/main">
               <a:ext uri="{FF2B5EF4-FFF2-40B4-BE49-F238E27FC236}">
-                <a16:creationId xmlns:a16="http://schemas.microsoft.com/office/drawing/2014/main" id="{E776760E-DE83-4C2D-9357-C17323C21DA4}"/>
+                <a16:creationId xmlns:a16="http://schemas.microsoft.com/office/drawing/2014/main" id="{AC48B126-178B-4D6A-B165-DA004CF995C8}"/>
               </a:ext>
             </a:extLst>
           </p:cNvPr>
@@ -10240,7 +10240,7 @@
           <p:cNvPr id="24" name="">
             <a:extLst xmlns:a="http://schemas.openxmlformats.org/drawingml/2006/main">
               <a:ext uri="{FF2B5EF4-FFF2-40B4-BE49-F238E27FC236}">
-                <a16:creationId xmlns:a16="http://schemas.microsoft.com/office/drawing/2014/main" id="{32201C45-707C-4D58-BE0E-22FD7C07F33B}"/>
+                <a16:creationId xmlns:a16="http://schemas.microsoft.com/office/drawing/2014/main" id="{DA85791C-1EFB-46BD-B10E-F885E4BADD39}"/>
               </a:ext>
             </a:extLst>
           </p:cNvPr>
@@ -10271,7 +10271,7 @@
           <p:cNvPr id="25" name="">
             <a:extLst xmlns:a="http://schemas.openxmlformats.org/drawingml/2006/main">
               <a:ext uri="{FF2B5EF4-FFF2-40B4-BE49-F238E27FC236}">
-                <a16:creationId xmlns:a16="http://schemas.microsoft.com/office/drawing/2014/main" id="{328E75F7-C801-4E43-BDD1-F052ED3D6B37}"/>
+                <a16:creationId xmlns:a16="http://schemas.microsoft.com/office/drawing/2014/main" id="{936ECCED-787D-4A69-8927-4BE54CB95021}"/>
               </a:ext>
             </a:extLst>
           </p:cNvPr>
@@ -10392,7 +10392,7 @@
           <p:cNvPr id="26" name="">
             <a:extLst xmlns:a="http://schemas.openxmlformats.org/drawingml/2006/main">
               <a:ext uri="{FF2B5EF4-FFF2-40B4-BE49-F238E27FC236}">
-                <a16:creationId xmlns:a16="http://schemas.microsoft.com/office/drawing/2014/main" id="{E99B1DA1-D329-49BD-9D47-2CAFAF87659F}"/>
+                <a16:creationId xmlns:a16="http://schemas.microsoft.com/office/drawing/2014/main" id="{2FAE1A24-0DBA-4549-B938-2758DD607B15}"/>
               </a:ext>
             </a:extLst>
           </p:cNvPr>
@@ -10423,7 +10423,7 @@
           <p:cNvPr id="27" name="">
             <a:extLst xmlns:a="http://schemas.openxmlformats.org/drawingml/2006/main">
               <a:ext uri="{FF2B5EF4-FFF2-40B4-BE49-F238E27FC236}">
-                <a16:creationId xmlns:a16="http://schemas.microsoft.com/office/drawing/2014/main" id="{75208501-B99A-4C5D-9D1D-F5F3551BB685}"/>
+                <a16:creationId xmlns:a16="http://schemas.microsoft.com/office/drawing/2014/main" id="{716A34A4-B588-4AD0-807F-F46319ED94B0}"/>
               </a:ext>
             </a:extLst>
           </p:cNvPr>
@@ -10544,7 +10544,7 @@
           <p:cNvPr id="28" name="">
             <a:extLst xmlns:a="http://schemas.openxmlformats.org/drawingml/2006/main">
               <a:ext uri="{FF2B5EF4-FFF2-40B4-BE49-F238E27FC236}">
-                <a16:creationId xmlns:a16="http://schemas.microsoft.com/office/drawing/2014/main" id="{A2914B92-35A3-4BA6-80BB-5F83A64415A4}"/>
+                <a16:creationId xmlns:a16="http://schemas.microsoft.com/office/drawing/2014/main" id="{8BEFC7A2-064A-4038-B013-2F545EBB5850}"/>
               </a:ext>
             </a:extLst>
           </p:cNvPr>
@@ -10665,7 +10665,7 @@
           <p:cNvPr id="29" name="">
             <a:extLst xmlns:a="http://schemas.openxmlformats.org/drawingml/2006/main">
               <a:ext uri="{FF2B5EF4-FFF2-40B4-BE49-F238E27FC236}">
-                <a16:creationId xmlns:a16="http://schemas.microsoft.com/office/drawing/2014/main" id="{BD1B91C3-2A0C-41F7-B0D0-CE9E25D23CE9}"/>
+                <a16:creationId xmlns:a16="http://schemas.microsoft.com/office/drawing/2014/main" id="{629B4A2A-E6A8-4E47-A97A-3573B106D3A7}"/>
               </a:ext>
             </a:extLst>
           </p:cNvPr>
@@ -10786,7 +10786,7 @@
           <p:cNvPr id="30" name="">
             <a:extLst xmlns:a="http://schemas.openxmlformats.org/drawingml/2006/main">
               <a:ext uri="{FF2B5EF4-FFF2-40B4-BE49-F238E27FC236}">
-                <a16:creationId xmlns:a16="http://schemas.microsoft.com/office/drawing/2014/main" id="{670A3B8F-37FB-4001-9843-6E26739D34D1}"/>
+                <a16:creationId xmlns:a16="http://schemas.microsoft.com/office/drawing/2014/main" id="{F7D9FDBA-9136-4167-AE4A-D92831327D1C}"/>
               </a:ext>
             </a:extLst>
           </p:cNvPr>
@@ -10907,7 +10907,7 @@
           <p:cNvPr id="31" name="">
             <a:extLst xmlns:a="http://schemas.openxmlformats.org/drawingml/2006/main">
               <a:ext uri="{FF2B5EF4-FFF2-40B4-BE49-F238E27FC236}">
-                <a16:creationId xmlns:a16="http://schemas.microsoft.com/office/drawing/2014/main" id="{C880EC49-B38C-47FE-934F-7CFE8EF586C4}"/>
+                <a16:creationId xmlns:a16="http://schemas.microsoft.com/office/drawing/2014/main" id="{F9168985-8F73-438B-A175-21DB8BF8A661}"/>
               </a:ext>
             </a:extLst>
           </p:cNvPr>
@@ -11026,7 +11026,7 @@
     </p:spTree>
     <p:extLst>
       <p:ext uri="{BB962C8B-B14F-4D97-AF65-F5344CB8AC3E}">
-        <p14:creationId xmlns:p14="http://schemas.microsoft.com/office/powerpoint/2010/main" val="1302874354"/>
+        <p14:creationId xmlns:p14="http://schemas.microsoft.com/office/powerpoint/2010/main" val="1450188947"/>
       </p:ext>
     </p:extLst>
   </p:cSld>
@@ -11057,7 +11057,7 @@
           <p:cNvPr id="11" name="">
             <a:extLst xmlns:a="http://schemas.openxmlformats.org/drawingml/2006/main">
               <a:ext uri="{FF2B5EF4-FFF2-40B4-BE49-F238E27FC236}">
-                <a16:creationId xmlns:a16="http://schemas.microsoft.com/office/drawing/2014/main" id="{89D5555A-DD83-4A4E-B395-D13037D13AEC}"/>
+                <a16:creationId xmlns:a16="http://schemas.microsoft.com/office/drawing/2014/main" id="{66EFA8D1-B559-4A9D-841C-847016B9AA85}"/>
               </a:ext>
             </a:extLst>
           </p:cNvPr>
@@ -11178,7 +11178,7 @@
           <p:cNvPr id="2" name="">
             <a:extLst xmlns:a="http://schemas.openxmlformats.org/drawingml/2006/main">
               <a:ext uri="{FF2B5EF4-FFF2-40B4-BE49-F238E27FC236}">
-                <a16:creationId xmlns:a16="http://schemas.microsoft.com/office/drawing/2014/main" id="{FC2E7D86-72BC-4D65-A9E3-861174E34A53}"/>
+                <a16:creationId xmlns:a16="http://schemas.microsoft.com/office/drawing/2014/main" id="{9441F9FC-701C-4EB4-8739-3E133599E5DD}"/>
               </a:ext>
             </a:extLst>
           </p:cNvPr>
@@ -11299,7 +11299,7 @@
           <p:cNvPr id="3" name="">
             <a:extLst xmlns:a="http://schemas.openxmlformats.org/drawingml/2006/main">
               <a:ext uri="{FF2B5EF4-FFF2-40B4-BE49-F238E27FC236}">
-                <a16:creationId xmlns:a16="http://schemas.microsoft.com/office/drawing/2014/main" id="{47C3A32B-2629-4E55-A077-4D81149034C8}"/>
+                <a16:creationId xmlns:a16="http://schemas.microsoft.com/office/drawing/2014/main" id="{39411B8D-F609-42C4-940B-BE56CD451B56}"/>
               </a:ext>
             </a:extLst>
           </p:cNvPr>
@@ -11330,7 +11330,7 @@
           <p:cNvPr id="4" name="">
             <a:extLst xmlns:a="http://schemas.openxmlformats.org/drawingml/2006/main">
               <a:ext uri="{FF2B5EF4-FFF2-40B4-BE49-F238E27FC236}">
-                <a16:creationId xmlns:a16="http://schemas.microsoft.com/office/drawing/2014/main" id="{31049F3D-3DEA-41C0-91AD-FF15D8E7E531}"/>
+                <a16:creationId xmlns:a16="http://schemas.microsoft.com/office/drawing/2014/main" id="{509220C7-CB88-4A5C-919F-EF5DEA9BDB3F}"/>
               </a:ext>
             </a:extLst>
           </p:cNvPr>
@@ -11451,7 +11451,7 @@
           <p:cNvPr id="5" name="">
             <a:extLst xmlns:a="http://schemas.openxmlformats.org/drawingml/2006/main">
               <a:ext uri="{FF2B5EF4-FFF2-40B4-BE49-F238E27FC236}">
-                <a16:creationId xmlns:a16="http://schemas.microsoft.com/office/drawing/2014/main" id="{0B3C1AC4-15F0-48D6-BF53-96B468FA02A7}"/>
+                <a16:creationId xmlns:a16="http://schemas.microsoft.com/office/drawing/2014/main" id="{6AF8EE19-291F-47B3-AE3E-8A735DC8C8C2}"/>
               </a:ext>
             </a:extLst>
           </p:cNvPr>
@@ -11630,7 +11630,7 @@
                   <a:srgbClr val="FFFFFF"/>
                 </a:solidFill>
               </a:rPr>
-              <a:t>Friendly timeout and quota states</a:t>
+              <a:t>Public 1.54B Apache-2.0 model loaded</a:t>
             </a:r>
           </a:p>
         </p:txBody>
@@ -11640,7 +11640,7 @@
           <p:cNvPr id="6" name="">
             <a:extLst xmlns:a="http://schemas.openxmlformats.org/drawingml/2006/main">
               <a:ext uri="{FF2B5EF4-FFF2-40B4-BE49-F238E27FC236}">
-                <a16:creationId xmlns:a16="http://schemas.microsoft.com/office/drawing/2014/main" id="{7AFCB73E-5611-4946-9EF4-590B830E67DE}"/>
+                <a16:creationId xmlns:a16="http://schemas.microsoft.com/office/drawing/2014/main" id="{4B283543-0B57-4D67-A717-F474CAA0F0A5}"/>
               </a:ext>
             </a:extLst>
           </p:cNvPr>
@@ -11671,7 +11671,7 @@
           <p:cNvPr id="7" name="">
             <a:extLst xmlns:a="http://schemas.openxmlformats.org/drawingml/2006/main">
               <a:ext uri="{FF2B5EF4-FFF2-40B4-BE49-F238E27FC236}">
-                <a16:creationId xmlns:a16="http://schemas.microsoft.com/office/drawing/2014/main" id="{4FE01852-5662-4CBB-84AB-907B80559932}"/>
+                <a16:creationId xmlns:a16="http://schemas.microsoft.com/office/drawing/2014/main" id="{68E1346D-322B-482A-80D2-7BA5A08A1EAB}"/>
               </a:ext>
             </a:extLst>
           </p:cNvPr>
@@ -11792,7 +11792,7 @@
           <p:cNvPr id="8" name="">
             <a:extLst xmlns:a="http://schemas.openxmlformats.org/drawingml/2006/main">
               <a:ext uri="{FF2B5EF4-FFF2-40B4-BE49-F238E27FC236}">
-                <a16:creationId xmlns:a16="http://schemas.microsoft.com/office/drawing/2014/main" id="{7F25793A-01E2-4F7F-AB04-30130B9E4A5D}"/>
+                <a16:creationId xmlns:a16="http://schemas.microsoft.com/office/drawing/2014/main" id="{33B5C43D-50FF-4ED8-9162-6AA5C462D058}"/>
               </a:ext>
             </a:extLst>
           </p:cNvPr>
@@ -11903,7 +11903,7 @@
                   <a:srgbClr val="FFFFFF"/>
                 </a:solidFill>
               </a:rPr>
-              <a:t>Successful live provider-backed recommendation</a:t>
+              <a:t>Live provider-backed recommendation after quota</a:t>
             </a:r>
           </a:p>
           <a:p xmlns:a="http://schemas.openxmlformats.org/drawingml/2006/main">
@@ -11954,7 +11954,7 @@
                   <a:srgbClr val="FFFFFF"/>
                 </a:solidFill>
               </a:rPr>
-              <a:t>Team model card, licence, and fresh load</a:t>
+              <a:t>Root Docker image and cold start</a:t>
             </a:r>
           </a:p>
           <a:p xmlns:a="http://schemas.openxmlformats.org/drawingml/2006/main">
@@ -11971,7 +11971,7 @@
                   <a:srgbClr val="FFFFFF"/>
                 </a:solidFill>
               </a:rPr>
-              <a:t>Docker cold start and judging availability</a:t>
+              <a:t>Keep endpoint available for judging</a:t>
             </a:r>
           </a:p>
         </p:txBody>
@@ -11981,7 +11981,7 @@
           <p:cNvPr id="9" name="">
             <a:extLst xmlns:a="http://schemas.openxmlformats.org/drawingml/2006/main">
               <a:ext uri="{FF2B5EF4-FFF2-40B4-BE49-F238E27FC236}">
-                <a16:creationId xmlns:a16="http://schemas.microsoft.com/office/drawing/2014/main" id="{127EB970-2BEB-461E-8D66-D44A20C456F7}"/>
+                <a16:creationId xmlns:a16="http://schemas.microsoft.com/office/drawing/2014/main" id="{F91A0C49-5BB7-4B71-A233-A8EA5A6AD277}"/>
               </a:ext>
             </a:extLst>
           </p:cNvPr>
@@ -12102,7 +12102,7 @@
           <p:cNvPr id="10" name="">
             <a:extLst xmlns:a="http://schemas.openxmlformats.org/drawingml/2006/main">
               <a:ext uri="{FF2B5EF4-FFF2-40B4-BE49-F238E27FC236}">
-                <a16:creationId xmlns:a16="http://schemas.microsoft.com/office/drawing/2014/main" id="{25B1495B-C3B7-403D-AE6F-46CD5A33D9F0}"/>
+                <a16:creationId xmlns:a16="http://schemas.microsoft.com/office/drawing/2014/main" id="{12B7BA4E-36F2-49B0-B7D7-2A6974BD5934}"/>
               </a:ext>
             </a:extLst>
           </p:cNvPr>
@@ -12221,7 +12221,7 @@
     </p:spTree>
     <p:extLst>
       <p:ext uri="{BB962C8B-B14F-4D97-AF65-F5344CB8AC3E}">
-        <p14:creationId xmlns:p14="http://schemas.microsoft.com/office/powerpoint/2010/main" val="1274687172"/>
+        <p14:creationId xmlns:p14="http://schemas.microsoft.com/office/powerpoint/2010/main" val="874333172"/>
       </p:ext>
     </p:extLst>
   </p:cSld>

</xml_diff>

<commit_message>
docs: add verified query example to submission deck
</commit_message>
<xml_diff>
--- a/submission/GoWise-GeoAI-Hackathon-2026-Submission.pptx
+++ b/submission/GoWise-GeoAI-Hackathon-2026-Submission.pptx
@@ -2,17 +2,17 @@
 <file path=ppt/presentation.xml><?xml version="1.0" encoding="utf-8"?>
 <p:presentation xmlns:p="http://schemas.openxmlformats.org/presentationml/2006/main">
   <p:sldMasterIdLst>
-    <p:sldMasterId xmlns:r="http://schemas.openxmlformats.org/officeDocument/2006/relationships" id="2147483648" r:id="R0c65efec166d430a"/>
+    <p:sldMasterId xmlns:r="http://schemas.openxmlformats.org/officeDocument/2006/relationships" id="2147483648" r:id="R463f0feca6784a46"/>
   </p:sldMasterIdLst>
   <p:notesMasterIdLst>
-    <p:notesMasterId xmlns:r="http://schemas.openxmlformats.org/officeDocument/2006/relationships" r:id="R189d3578d66444b4"/>
+    <p:notesMasterId xmlns:r="http://schemas.openxmlformats.org/officeDocument/2006/relationships" r:id="R4d92e985df72460e"/>
   </p:notesMasterIdLst>
   <p:sldIdLst>
-    <p:sldId xmlns:r="http://schemas.openxmlformats.org/officeDocument/2006/relationships" id="256" r:id="Rd68718adde434ff9"/>
-    <p:sldId xmlns:r="http://schemas.openxmlformats.org/officeDocument/2006/relationships" id="257" r:id="R7a25ca6890274a9a"/>
-    <p:sldId xmlns:r="http://schemas.openxmlformats.org/officeDocument/2006/relationships" id="258" r:id="Rf7740c9e8fa144d9"/>
-    <p:sldId xmlns:r="http://schemas.openxmlformats.org/officeDocument/2006/relationships" id="259" r:id="Rbe052cb474244008"/>
-    <p:sldId xmlns:r="http://schemas.openxmlformats.org/officeDocument/2006/relationships" id="260" r:id="Rd9498c91229a4adf"/>
+    <p:sldId xmlns:r="http://schemas.openxmlformats.org/officeDocument/2006/relationships" id="256" r:id="Rbdb401ffbc7c4b5a"/>
+    <p:sldId xmlns:r="http://schemas.openxmlformats.org/officeDocument/2006/relationships" id="257" r:id="R1f59e059d257413b"/>
+    <p:sldId xmlns:r="http://schemas.openxmlformats.org/officeDocument/2006/relationships" id="258" r:id="R9c1f7ce91e7f4bd4"/>
+    <p:sldId xmlns:r="http://schemas.openxmlformats.org/officeDocument/2006/relationships" id="259" r:id="Rfae2606ef63c4d93"/>
+    <p:sldId xmlns:r="http://schemas.openxmlformats.org/officeDocument/2006/relationships" id="260" r:id="R110a88f6de9c44b6"/>
   </p:sldIdLst>
   <p:sldSz cx="12192000" cy="6858000"/>
   <p:notesSz cx="6858000" cy="9144000"/>
@@ -516,7 +516,7 @@
           <a:lstStyle xmlns:a="http://schemas.openxmlformats.org/drawingml/2006/main"/>
           <a:p xmlns:a="http://schemas.openxmlformats.org/drawingml/2006/main">
             <a:r>
-              <a:t>Source: GeoAI Hackathon 2026 rulebook for required outdoor activities. Query behavior reflects backend/app/model/query_extraction.py. Profile details remain request-scoped and are not written to storage.</a:t>
+              <a:t>The example query was submitted to the deployed GoWise Space and its deterministic named-weekday parser resolved Monday evening near Powai to 26 October 2026, 17:00–20:00 IST. The later inference attempt was blocked by ZeroGPU quota; this slide therefore shows only the verified parsed request and no invented live venue or forecast output. The supported activity list comes from backend/app/engine/activities.py.</a:t>
             </a:r>
           </a:p>
         </p:txBody>
@@ -773,7 +773,7 @@
           <p:cNvPr id="3" name="Title">
             <a:extLst xmlns:a="http://schemas.openxmlformats.org/drawingml/2006/main">
               <a:ext uri="{FF2B5EF4-FFF2-40B4-BE49-F238E27FC236}">
-                <a16:creationId xmlns:a16="http://schemas.microsoft.com/office/drawing/2014/main" id="{33457129-78BE-485B-97DD-3C5568011622}"/>
+                <a16:creationId xmlns:a16="http://schemas.microsoft.com/office/drawing/2014/main" id="{FE1FB4AF-0755-4D9C-80B9-465E50435BFB}"/>
               </a:ext>
             </a:extLst>
           </p:cNvPr>
@@ -1002,7 +1002,7 @@
           <p:cNvPr id="2" name="Subtitle">
             <a:extLst xmlns:a="http://schemas.openxmlformats.org/drawingml/2006/main">
               <a:ext uri="{FF2B5EF4-FFF2-40B4-BE49-F238E27FC236}">
-                <a16:creationId xmlns:a16="http://schemas.microsoft.com/office/drawing/2014/main" id="{AE679D9A-6C7D-4465-8F27-EDB8741F65B2}"/>
+                <a16:creationId xmlns:a16="http://schemas.microsoft.com/office/drawing/2014/main" id="{59B19D9F-3775-4703-B29C-CF3DA33DFD3E}"/>
               </a:ext>
             </a:extLst>
           </p:cNvPr>
@@ -1248,7 +1248,7 @@
           <p:cNvPr id="2" name="Section title">
             <a:extLst xmlns:a="http://schemas.openxmlformats.org/drawingml/2006/main">
               <a:ext uri="{FF2B5EF4-FFF2-40B4-BE49-F238E27FC236}">
-                <a16:creationId xmlns:a16="http://schemas.microsoft.com/office/drawing/2014/main" id="{D45B4EA7-08D0-40C2-BDE5-82BB6FC5E28C}"/>
+                <a16:creationId xmlns:a16="http://schemas.microsoft.com/office/drawing/2014/main" id="{73792CB4-A455-4E60-899E-6A7BBEFC6CB1}"/>
               </a:ext>
             </a:extLst>
           </p:cNvPr>
@@ -1494,7 +1494,7 @@
           <p:cNvPr id="3" name="Title">
             <a:extLst xmlns:a="http://schemas.openxmlformats.org/drawingml/2006/main">
               <a:ext uri="{FF2B5EF4-FFF2-40B4-BE49-F238E27FC236}">
-                <a16:creationId xmlns:a16="http://schemas.microsoft.com/office/drawing/2014/main" id="{206AE38A-D9FF-4735-A1D7-722FD5E86247}"/>
+                <a16:creationId xmlns:a16="http://schemas.microsoft.com/office/drawing/2014/main" id="{C8BCC3F9-233C-4AED-938B-61D816C39F47}"/>
               </a:ext>
             </a:extLst>
           </p:cNvPr>
@@ -1723,7 +1723,7 @@
           <p:cNvPr id="2" name="Body">
             <a:extLst xmlns:a="http://schemas.openxmlformats.org/drawingml/2006/main">
               <a:ext uri="{FF2B5EF4-FFF2-40B4-BE49-F238E27FC236}">
-                <a16:creationId xmlns:a16="http://schemas.microsoft.com/office/drawing/2014/main" id="{5B9AFD6B-EE82-42EC-8512-435D0743A3CB}"/>
+                <a16:creationId xmlns:a16="http://schemas.microsoft.com/office/drawing/2014/main" id="{34B78B58-1857-48B9-B1AE-8423A3AA162A}"/>
               </a:ext>
             </a:extLst>
           </p:cNvPr>
@@ -1969,7 +1969,7 @@
           <p:cNvPr id="4" name="Title">
             <a:extLst xmlns:a="http://schemas.openxmlformats.org/drawingml/2006/main">
               <a:ext uri="{FF2B5EF4-FFF2-40B4-BE49-F238E27FC236}">
-                <a16:creationId xmlns:a16="http://schemas.microsoft.com/office/drawing/2014/main" id="{D0C40906-9327-4BFD-A78E-A9F6BF83E2CA}"/>
+                <a16:creationId xmlns:a16="http://schemas.microsoft.com/office/drawing/2014/main" id="{58FFECA7-C8F3-4A0D-BB5C-11B5F92B5DA6}"/>
               </a:ext>
             </a:extLst>
           </p:cNvPr>
@@ -2198,7 +2198,7 @@
           <p:cNvPr id="2" name="Left column">
             <a:extLst xmlns:a="http://schemas.openxmlformats.org/drawingml/2006/main">
               <a:ext uri="{FF2B5EF4-FFF2-40B4-BE49-F238E27FC236}">
-                <a16:creationId xmlns:a16="http://schemas.microsoft.com/office/drawing/2014/main" id="{5F150234-B238-4B17-9356-2FD561DFE5FA}"/>
+                <a16:creationId xmlns:a16="http://schemas.microsoft.com/office/drawing/2014/main" id="{9F27E955-69C2-45AC-957E-914BC627D911}"/>
               </a:ext>
             </a:extLst>
           </p:cNvPr>
@@ -2427,7 +2427,7 @@
           <p:cNvPr id="3" name="Right column">
             <a:extLst xmlns:a="http://schemas.openxmlformats.org/drawingml/2006/main">
               <a:ext uri="{FF2B5EF4-FFF2-40B4-BE49-F238E27FC236}">
-                <a16:creationId xmlns:a16="http://schemas.microsoft.com/office/drawing/2014/main" id="{30BABE66-2275-45A9-AA74-B1BB5FE409E3}"/>
+                <a16:creationId xmlns:a16="http://schemas.microsoft.com/office/drawing/2014/main" id="{9CB2178E-A5A4-4E02-BB0A-3F9D741A7653}"/>
               </a:ext>
             </a:extLst>
           </p:cNvPr>
@@ -2673,7 +2673,7 @@
           <p:cNvPr id="3" name="Title">
             <a:extLst xmlns:a="http://schemas.openxmlformats.org/drawingml/2006/main">
               <a:ext uri="{FF2B5EF4-FFF2-40B4-BE49-F238E27FC236}">
-                <a16:creationId xmlns:a16="http://schemas.microsoft.com/office/drawing/2014/main" id="{0177919B-DB5D-4E4F-A5E5-AF32F2762DD4}"/>
+                <a16:creationId xmlns:a16="http://schemas.microsoft.com/office/drawing/2014/main" id="{8C6C095E-E26F-4DC5-8244-76507182F7F8}"/>
               </a:ext>
             </a:extLst>
           </p:cNvPr>
@@ -2902,7 +2902,7 @@
           <p:cNvPr id="2" name="Left column">
             <a:extLst xmlns:a="http://schemas.openxmlformats.org/drawingml/2006/main">
               <a:ext uri="{FF2B5EF4-FFF2-40B4-BE49-F238E27FC236}">
-                <a16:creationId xmlns:a16="http://schemas.microsoft.com/office/drawing/2014/main" id="{C16E6094-105C-484A-99F8-4D2B5BF07E5C}"/>
+                <a16:creationId xmlns:a16="http://schemas.microsoft.com/office/drawing/2014/main" id="{EDFE6151-11FC-4D98-90FF-886E2EF94432}"/>
               </a:ext>
             </a:extLst>
           </p:cNvPr>
@@ -3169,12 +3169,12 @@
   </p:cSld>
   <p:clrMap bg1="lt1" tx1="dk1" bg2="lt2" tx2="dk2" accent1="accent1" accent2="accent2" accent3="accent3" accent4="accent4" accent5="accent5" accent6="accent6" hlink="hlink" folHlink="folHlink"/>
   <p:sldLayoutIdLst>
-    <p:sldLayoutId xmlns:r="http://schemas.openxmlformats.org/officeDocument/2006/relationships" id="2147483649" r:id="Rbd7360586d964925"/>
-    <p:sldLayoutId xmlns:r="http://schemas.openxmlformats.org/officeDocument/2006/relationships" id="2147483650" r:id="R180a2e0ce8cc457c"/>
-    <p:sldLayoutId xmlns:r="http://schemas.openxmlformats.org/officeDocument/2006/relationships" id="2147483651" r:id="Re5ae598f2de14364"/>
-    <p:sldLayoutId xmlns:r="http://schemas.openxmlformats.org/officeDocument/2006/relationships" id="2147483652" r:id="R1aeeac425ae84c67"/>
-    <p:sldLayoutId xmlns:r="http://schemas.openxmlformats.org/officeDocument/2006/relationships" id="2147483653" r:id="R73faf35daca44d2e"/>
-    <p:sldLayoutId xmlns:r="http://schemas.openxmlformats.org/officeDocument/2006/relationships" id="2147483654" r:id="Re1bd6782583a4345"/>
+    <p:sldLayoutId xmlns:r="http://schemas.openxmlformats.org/officeDocument/2006/relationships" id="2147483649" r:id="R75059d10f9174eba"/>
+    <p:sldLayoutId xmlns:r="http://schemas.openxmlformats.org/officeDocument/2006/relationships" id="2147483650" r:id="R66b0efae59c14e79"/>
+    <p:sldLayoutId xmlns:r="http://schemas.openxmlformats.org/officeDocument/2006/relationships" id="2147483651" r:id="R5e5ba588d79040a4"/>
+    <p:sldLayoutId xmlns:r="http://schemas.openxmlformats.org/officeDocument/2006/relationships" id="2147483652" r:id="R018a2b480d4f4834"/>
+    <p:sldLayoutId xmlns:r="http://schemas.openxmlformats.org/officeDocument/2006/relationships" id="2147483653" r:id="R81e5fdf545d441bc"/>
+    <p:sldLayoutId xmlns:r="http://schemas.openxmlformats.org/officeDocument/2006/relationships" id="2147483654" r:id="R40cf6d1ab4d74ee3"/>
   </p:sldLayoutIdLst>
   <p:txStyles>
     <p:titleStyle>
@@ -3725,7 +3725,7 @@
           <p:cNvPr id="9" name="">
             <a:extLst xmlns:a="http://schemas.openxmlformats.org/drawingml/2006/main">
               <a:ext uri="{FF2B5EF4-FFF2-40B4-BE49-F238E27FC236}">
-                <a16:creationId xmlns:a16="http://schemas.microsoft.com/office/drawing/2014/main" id="{039450D7-22E4-4F1D-896B-79BFB1A912A6}"/>
+                <a16:creationId xmlns:a16="http://schemas.microsoft.com/office/drawing/2014/main" id="{2657349C-E0F6-4C72-B121-E439270A7119}"/>
               </a:ext>
             </a:extLst>
           </p:cNvPr>
@@ -3756,7 +3756,7 @@
           <p:cNvPr id="2" name="">
             <a:extLst xmlns:a="http://schemas.openxmlformats.org/drawingml/2006/main">
               <a:ext uri="{FF2B5EF4-FFF2-40B4-BE49-F238E27FC236}">
-                <a16:creationId xmlns:a16="http://schemas.microsoft.com/office/drawing/2014/main" id="{6B19E38B-D515-4C8E-B92E-1658F6845BDD}"/>
+                <a16:creationId xmlns:a16="http://schemas.microsoft.com/office/drawing/2014/main" id="{531B90BF-06F3-4537-94E2-4E2B136C4550}"/>
               </a:ext>
             </a:extLst>
           </p:cNvPr>
@@ -3877,7 +3877,7 @@
           <p:cNvPr id="3" name="">
             <a:extLst xmlns:a="http://schemas.openxmlformats.org/drawingml/2006/main">
               <a:ext uri="{FF2B5EF4-FFF2-40B4-BE49-F238E27FC236}">
-                <a16:creationId xmlns:a16="http://schemas.microsoft.com/office/drawing/2014/main" id="{94FFD4B2-7FAF-4A50-931A-608189AF251F}"/>
+                <a16:creationId xmlns:a16="http://schemas.microsoft.com/office/drawing/2014/main" id="{04F458A5-1DCD-44E1-89AE-8842DA13FD9F}"/>
               </a:ext>
             </a:extLst>
           </p:cNvPr>
@@ -4015,7 +4015,7 @@
           <p:cNvPr id="4" name="">
             <a:extLst xmlns:a="http://schemas.openxmlformats.org/drawingml/2006/main">
               <a:ext uri="{FF2B5EF4-FFF2-40B4-BE49-F238E27FC236}">
-                <a16:creationId xmlns:a16="http://schemas.microsoft.com/office/drawing/2014/main" id="{E12F750C-E519-454A-844A-333BF3DAAC64}"/>
+                <a16:creationId xmlns:a16="http://schemas.microsoft.com/office/drawing/2014/main" id="{9C38A554-717D-4495-8C0D-F8A3549771E9}"/>
               </a:ext>
             </a:extLst>
           </p:cNvPr>
@@ -4136,7 +4136,7 @@
           <p:cNvPr id="5" name="">
             <a:extLst xmlns:a="http://schemas.openxmlformats.org/drawingml/2006/main">
               <a:ext uri="{FF2B5EF4-FFF2-40B4-BE49-F238E27FC236}">
-                <a16:creationId xmlns:a16="http://schemas.microsoft.com/office/drawing/2014/main" id="{BAB00ED1-902D-4176-A92A-FDFCA8370E1A}"/>
+                <a16:creationId xmlns:a16="http://schemas.microsoft.com/office/drawing/2014/main" id="{EBCE643A-7590-404B-BA7B-E6C1C138E2A4}"/>
               </a:ext>
             </a:extLst>
           </p:cNvPr>
@@ -4167,7 +4167,7 @@
           <p:cNvPr id="6" name="">
             <a:extLst xmlns:a="http://schemas.openxmlformats.org/drawingml/2006/main">
               <a:ext uri="{FF2B5EF4-FFF2-40B4-BE49-F238E27FC236}">
-                <a16:creationId xmlns:a16="http://schemas.microsoft.com/office/drawing/2014/main" id="{48AD7428-CED3-447D-960B-74F87D087AC7}"/>
+                <a16:creationId xmlns:a16="http://schemas.microsoft.com/office/drawing/2014/main" id="{0EC78581-EAD7-4093-88BB-024183C8F634}"/>
               </a:ext>
             </a:extLst>
           </p:cNvPr>
@@ -4288,7 +4288,7 @@
           <p:cNvPr id="7" name="">
             <a:extLst xmlns:a="http://schemas.openxmlformats.org/drawingml/2006/main">
               <a:ext uri="{FF2B5EF4-FFF2-40B4-BE49-F238E27FC236}">
-                <a16:creationId xmlns:a16="http://schemas.microsoft.com/office/drawing/2014/main" id="{D25589DC-9F95-4B3A-B964-52FF476DEFA4}"/>
+                <a16:creationId xmlns:a16="http://schemas.microsoft.com/office/drawing/2014/main" id="{67C7CBF5-DF3B-4D22-9DB7-09A42AAA6EC4}"/>
               </a:ext>
             </a:extLst>
           </p:cNvPr>
@@ -4409,7 +4409,7 @@
           <p:cNvPr id="8" name="">
             <a:extLst xmlns:a="http://schemas.openxmlformats.org/drawingml/2006/main">
               <a:ext uri="{FF2B5EF4-FFF2-40B4-BE49-F238E27FC236}">
-                <a16:creationId xmlns:a16="http://schemas.microsoft.com/office/drawing/2014/main" id="{B6DA03F8-77E6-4622-9DA1-7CFF5CB19450}"/>
+                <a16:creationId xmlns:a16="http://schemas.microsoft.com/office/drawing/2014/main" id="{A58C5B4B-3BEF-4EBF-B84A-8126673E26E7}"/>
               </a:ext>
             </a:extLst>
           </p:cNvPr>
@@ -4528,7 +4528,7 @@
     </p:spTree>
     <p:extLst>
       <p:ext uri="{BB962C8B-B14F-4D97-AF65-F5344CB8AC3E}">
-        <p14:creationId xmlns:p14="http://schemas.microsoft.com/office/powerpoint/2010/main" val="252787042"/>
+        <p14:creationId xmlns:p14="http://schemas.microsoft.com/office/powerpoint/2010/main" val="2009406912"/>
       </p:ext>
     </p:extLst>
   </p:cSld>
@@ -4559,7 +4559,7 @@
           <p:cNvPr id="16" name="">
             <a:extLst xmlns:a="http://schemas.openxmlformats.org/drawingml/2006/main">
               <a:ext uri="{FF2B5EF4-FFF2-40B4-BE49-F238E27FC236}">
-                <a16:creationId xmlns:a16="http://schemas.microsoft.com/office/drawing/2014/main" id="{250A7152-6B93-47BF-8CC5-7575A1052554}"/>
+                <a16:creationId xmlns:a16="http://schemas.microsoft.com/office/drawing/2014/main" id="{02B8965C-0680-4E8D-AAAD-C79BD0CFD294}"/>
               </a:ext>
             </a:extLst>
           </p:cNvPr>
@@ -4680,7 +4680,7 @@
           <p:cNvPr id="2" name="">
             <a:extLst xmlns:a="http://schemas.openxmlformats.org/drawingml/2006/main">
               <a:ext uri="{FF2B5EF4-FFF2-40B4-BE49-F238E27FC236}">
-                <a16:creationId xmlns:a16="http://schemas.microsoft.com/office/drawing/2014/main" id="{17C6E3D7-2A8A-460E-9FC0-08BCAF7A5F72}"/>
+                <a16:creationId xmlns:a16="http://schemas.microsoft.com/office/drawing/2014/main" id="{980E0538-0A6A-4255-96FF-AA580982EE44}"/>
               </a:ext>
             </a:extLst>
           </p:cNvPr>
@@ -4801,7 +4801,7 @@
           <p:cNvPr id="3" name="">
             <a:extLst xmlns:a="http://schemas.openxmlformats.org/drawingml/2006/main">
               <a:ext uri="{FF2B5EF4-FFF2-40B4-BE49-F238E27FC236}">
-                <a16:creationId xmlns:a16="http://schemas.microsoft.com/office/drawing/2014/main" id="{7936D4E7-1539-4941-8556-246C66EEE788}"/>
+                <a16:creationId xmlns:a16="http://schemas.microsoft.com/office/drawing/2014/main" id="{3B221C98-C04E-4D6B-8774-4BD8D450BDCD}"/>
               </a:ext>
             </a:extLst>
           </p:cNvPr>
@@ -4922,7 +4922,7 @@
           <p:cNvPr id="4" name="">
             <a:extLst xmlns:a="http://schemas.openxmlformats.org/drawingml/2006/main">
               <a:ext uri="{FF2B5EF4-FFF2-40B4-BE49-F238E27FC236}">
-                <a16:creationId xmlns:a16="http://schemas.microsoft.com/office/drawing/2014/main" id="{99EDC790-A576-4C4B-AA4E-62CB0B3AEE4C}"/>
+                <a16:creationId xmlns:a16="http://schemas.microsoft.com/office/drawing/2014/main" id="{C99A31B0-935A-4C60-A484-A4A94868CBEE}"/>
               </a:ext>
             </a:extLst>
           </p:cNvPr>
@@ -4953,7 +4953,7 @@
           <p:cNvPr id="5" name="">
             <a:extLst xmlns:a="http://schemas.openxmlformats.org/drawingml/2006/main">
               <a:ext uri="{FF2B5EF4-FFF2-40B4-BE49-F238E27FC236}">
-                <a16:creationId xmlns:a16="http://schemas.microsoft.com/office/drawing/2014/main" id="{157FB09F-E135-4738-AA16-96FFAC5D41FD}"/>
+                <a16:creationId xmlns:a16="http://schemas.microsoft.com/office/drawing/2014/main" id="{2F4A15BA-7704-415B-BD47-146FBBB35214}"/>
               </a:ext>
             </a:extLst>
           </p:cNvPr>
@@ -5074,7 +5074,7 @@
           <p:cNvPr id="6" name="">
             <a:extLst xmlns:a="http://schemas.openxmlformats.org/drawingml/2006/main">
               <a:ext uri="{FF2B5EF4-FFF2-40B4-BE49-F238E27FC236}">
-                <a16:creationId xmlns:a16="http://schemas.microsoft.com/office/drawing/2014/main" id="{0F08D3FA-227D-421B-9CC2-80FDB1414C52}"/>
+                <a16:creationId xmlns:a16="http://schemas.microsoft.com/office/drawing/2014/main" id="{4B111A94-C653-48AE-9D61-AEB32EB14317}"/>
               </a:ext>
             </a:extLst>
           </p:cNvPr>
@@ -5185,7 +5185,7 @@
                   <a:srgbClr val="20392D"/>
                 </a:solidFill>
               </a:rPr>
-              <a:t>“Where can I run tomorrow morning near Powai?”</a:t>
+              <a:t>“Find cycling on Monday evening near Powai.”</a:t>
             </a:r>
           </a:p>
         </p:txBody>
@@ -5195,7 +5195,7 @@
           <p:cNvPr id="7" name="">
             <a:extLst xmlns:a="http://schemas.openxmlformats.org/drawingml/2006/main">
               <a:ext uri="{FF2B5EF4-FFF2-40B4-BE49-F238E27FC236}">
-                <a16:creationId xmlns:a16="http://schemas.microsoft.com/office/drawing/2014/main" id="{0EFBE938-FFAB-4E44-8874-DE62CE2A7193}"/>
+                <a16:creationId xmlns:a16="http://schemas.microsoft.com/office/drawing/2014/main" id="{AF1FA7AF-1771-4175-AE95-5BE4145DF127}"/>
               </a:ext>
             </a:extLst>
           </p:cNvPr>
@@ -5226,7 +5226,7 @@
           <p:cNvPr id="8" name="">
             <a:extLst xmlns:a="http://schemas.openxmlformats.org/drawingml/2006/main">
               <a:ext uri="{FF2B5EF4-FFF2-40B4-BE49-F238E27FC236}">
-                <a16:creationId xmlns:a16="http://schemas.microsoft.com/office/drawing/2014/main" id="{08A7E191-A83E-44CD-B532-31B8886D8369}"/>
+                <a16:creationId xmlns:a16="http://schemas.microsoft.com/office/drawing/2014/main" id="{4B34B3D2-65A4-4B5E-947E-95C81B104C17}"/>
               </a:ext>
             </a:extLst>
           </p:cNvPr>
@@ -5347,7 +5347,7 @@
           <p:cNvPr id="9" name="">
             <a:extLst xmlns:a="http://schemas.openxmlformats.org/drawingml/2006/main">
               <a:ext uri="{FF2B5EF4-FFF2-40B4-BE49-F238E27FC236}">
-                <a16:creationId xmlns:a16="http://schemas.microsoft.com/office/drawing/2014/main" id="{CA7AE563-C7CC-452C-9B00-375886163044}"/>
+                <a16:creationId xmlns:a16="http://schemas.microsoft.com/office/drawing/2014/main" id="{2BE69359-4DE4-420C-A8C5-F032AC7CC7BE}"/>
               </a:ext>
             </a:extLst>
           </p:cNvPr>
@@ -5458,7 +5458,7 @@
                   <a:srgbClr val="20392D"/>
                 </a:solidFill>
               </a:rPr>
-              <a:t>Activity · typed area · radius · time window · optional context</a:t>
+              <a:t>Cycling · Powai · Mon 26 Oct, 17:00–20:00 IST</a:t>
             </a:r>
           </a:p>
         </p:txBody>
@@ -5468,7 +5468,7 @@
           <p:cNvPr id="10" name="">
             <a:extLst xmlns:a="http://schemas.openxmlformats.org/drawingml/2006/main">
               <a:ext uri="{FF2B5EF4-FFF2-40B4-BE49-F238E27FC236}">
-                <a16:creationId xmlns:a16="http://schemas.microsoft.com/office/drawing/2014/main" id="{4BEFD44E-31B6-4AF9-918E-39BCFEA45983}"/>
+                <a16:creationId xmlns:a16="http://schemas.microsoft.com/office/drawing/2014/main" id="{16CE2BE6-290C-4AFC-9B1E-07AF158629E5}"/>
               </a:ext>
             </a:extLst>
           </p:cNvPr>
@@ -5499,7 +5499,7 @@
           <p:cNvPr id="11" name="">
             <a:extLst xmlns:a="http://schemas.openxmlformats.org/drawingml/2006/main">
               <a:ext uri="{FF2B5EF4-FFF2-40B4-BE49-F238E27FC236}">
-                <a16:creationId xmlns:a16="http://schemas.microsoft.com/office/drawing/2014/main" id="{D407E8CE-6EFD-479B-9CA7-758515E1990A}"/>
+                <a16:creationId xmlns:a16="http://schemas.microsoft.com/office/drawing/2014/main" id="{05206C04-8A97-4765-807F-8550CFB71B82}"/>
               </a:ext>
             </a:extLst>
           </p:cNvPr>
@@ -5620,7 +5620,7 @@
           <p:cNvPr id="12" name="">
             <a:extLst xmlns:a="http://schemas.openxmlformats.org/drawingml/2006/main">
               <a:ext uri="{FF2B5EF4-FFF2-40B4-BE49-F238E27FC236}">
-                <a16:creationId xmlns:a16="http://schemas.microsoft.com/office/drawing/2014/main" id="{57CB6F5C-91F5-4EDC-8A27-533F73A9CC76}"/>
+                <a16:creationId xmlns:a16="http://schemas.microsoft.com/office/drawing/2014/main" id="{500274DB-294A-4272-A3E3-765CE2546346}"/>
               </a:ext>
             </a:extLst>
           </p:cNvPr>
@@ -5741,7 +5741,7 @@
           <p:cNvPr id="13" name="">
             <a:extLst xmlns:a="http://schemas.openxmlformats.org/drawingml/2006/main">
               <a:ext uri="{FF2B5EF4-FFF2-40B4-BE49-F238E27FC236}">
-                <a16:creationId xmlns:a16="http://schemas.microsoft.com/office/drawing/2014/main" id="{F7818D9B-3192-4B13-B3CC-8CAF3B003A29}"/>
+                <a16:creationId xmlns:a16="http://schemas.microsoft.com/office/drawing/2014/main" id="{6B7DDF78-00B0-4AE8-895E-81814C6A5A89}"/>
               </a:ext>
             </a:extLst>
           </p:cNvPr>
@@ -5862,7 +5862,7 @@
           <p:cNvPr id="14" name="">
             <a:extLst xmlns:a="http://schemas.openxmlformats.org/drawingml/2006/main">
               <a:ext uri="{FF2B5EF4-FFF2-40B4-BE49-F238E27FC236}">
-                <a16:creationId xmlns:a16="http://schemas.microsoft.com/office/drawing/2014/main" id="{69B5466E-D7FD-4EE5-8B50-A92826EE6302}"/>
+                <a16:creationId xmlns:a16="http://schemas.microsoft.com/office/drawing/2014/main" id="{B3CD37A8-0EEF-4372-A7C8-425BCE7CF33E}"/>
               </a:ext>
             </a:extLst>
           </p:cNvPr>
@@ -5973,7 +5973,7 @@
                   <a:srgbClr val="64756A"/>
                 </a:solidFill>
               </a:rPr>
-              <a:t>Sensitive details stay in the request and are not persisted. Precautions remain general planning information.</a:t>
+              <a:t>Verified parse example; quota blocked the live place and forecast result, so none is shown.</a:t>
             </a:r>
           </a:p>
         </p:txBody>
@@ -5983,7 +5983,7 @@
           <p:cNvPr id="15" name="">
             <a:extLst xmlns:a="http://schemas.openxmlformats.org/drawingml/2006/main">
               <a:ext uri="{FF2B5EF4-FFF2-40B4-BE49-F238E27FC236}">
-                <a16:creationId xmlns:a16="http://schemas.microsoft.com/office/drawing/2014/main" id="{88870E3A-1101-4E46-99BF-F942A65272A0}"/>
+                <a16:creationId xmlns:a16="http://schemas.microsoft.com/office/drawing/2014/main" id="{3851EE63-F011-4ECD-9FE4-06835C55C343}"/>
               </a:ext>
             </a:extLst>
           </p:cNvPr>
@@ -6102,7 +6102,7 @@
     </p:spTree>
     <p:extLst>
       <p:ext uri="{BB962C8B-B14F-4D97-AF65-F5344CB8AC3E}">
-        <p14:creationId xmlns:p14="http://schemas.microsoft.com/office/powerpoint/2010/main" val="124594647"/>
+        <p14:creationId xmlns:p14="http://schemas.microsoft.com/office/powerpoint/2010/main" val="1733132623"/>
       </p:ext>
     </p:extLst>
   </p:cSld>
@@ -6133,7 +6133,7 @@
           <p:cNvPr id="25" name="">
             <a:extLst xmlns:a="http://schemas.openxmlformats.org/drawingml/2006/main">
               <a:ext uri="{FF2B5EF4-FFF2-40B4-BE49-F238E27FC236}">
-                <a16:creationId xmlns:a16="http://schemas.microsoft.com/office/drawing/2014/main" id="{055A1EA5-909F-4194-B9CC-4CF3B39D7993}"/>
+                <a16:creationId xmlns:a16="http://schemas.microsoft.com/office/drawing/2014/main" id="{D8141A5C-46D3-4360-9755-E6297BD44400}"/>
               </a:ext>
             </a:extLst>
           </p:cNvPr>
@@ -6254,7 +6254,7 @@
           <p:cNvPr id="2" name="">
             <a:extLst xmlns:a="http://schemas.openxmlformats.org/drawingml/2006/main">
               <a:ext uri="{FF2B5EF4-FFF2-40B4-BE49-F238E27FC236}">
-                <a16:creationId xmlns:a16="http://schemas.microsoft.com/office/drawing/2014/main" id="{2F15F5BB-ABFE-4B71-99C2-4B82E21EC8B5}"/>
+                <a16:creationId xmlns:a16="http://schemas.microsoft.com/office/drawing/2014/main" id="{E99E21B9-BB90-424D-AB65-240CC2D92C12}"/>
               </a:ext>
             </a:extLst>
           </p:cNvPr>
@@ -6375,7 +6375,7 @@
           <p:cNvPr id="3" name="">
             <a:extLst xmlns:a="http://schemas.openxmlformats.org/drawingml/2006/main">
               <a:ext uri="{FF2B5EF4-FFF2-40B4-BE49-F238E27FC236}">
-                <a16:creationId xmlns:a16="http://schemas.microsoft.com/office/drawing/2014/main" id="{216ED678-CD60-4452-B311-B5FB96CBC586}"/>
+                <a16:creationId xmlns:a16="http://schemas.microsoft.com/office/drawing/2014/main" id="{F42D8883-3020-44CD-BC81-345C69A148B1}"/>
               </a:ext>
             </a:extLst>
           </p:cNvPr>
@@ -6496,7 +6496,7 @@
           <p:cNvPr id="4" name="">
             <a:extLst xmlns:a="http://schemas.openxmlformats.org/drawingml/2006/main">
               <a:ext uri="{FF2B5EF4-FFF2-40B4-BE49-F238E27FC236}">
-                <a16:creationId xmlns:a16="http://schemas.microsoft.com/office/drawing/2014/main" id="{17AD5446-3BA1-4BF9-AD85-057F2839B587}"/>
+                <a16:creationId xmlns:a16="http://schemas.microsoft.com/office/drawing/2014/main" id="{971C6085-8D27-4684-B758-CC290004C466}"/>
               </a:ext>
             </a:extLst>
           </p:cNvPr>
@@ -6527,7 +6527,7 @@
           <p:cNvPr id="5" name="">
             <a:extLst xmlns:a="http://schemas.openxmlformats.org/drawingml/2006/main">
               <a:ext uri="{FF2B5EF4-FFF2-40B4-BE49-F238E27FC236}">
-                <a16:creationId xmlns:a16="http://schemas.microsoft.com/office/drawing/2014/main" id="{1C97C303-A446-497F-A1A5-655BF9D753EA}"/>
+                <a16:creationId xmlns:a16="http://schemas.microsoft.com/office/drawing/2014/main" id="{FFAE0785-33BF-4014-A314-6A61A835A0C1}"/>
               </a:ext>
             </a:extLst>
           </p:cNvPr>
@@ -6562,7 +6562,7 @@
           <p:cNvPr id="6" name="">
             <a:extLst xmlns:a="http://schemas.openxmlformats.org/drawingml/2006/main">
               <a:ext uri="{FF2B5EF4-FFF2-40B4-BE49-F238E27FC236}">
-                <a16:creationId xmlns:a16="http://schemas.microsoft.com/office/drawing/2014/main" id="{6048B332-3167-4C97-8CDC-EFE573162957}"/>
+                <a16:creationId xmlns:a16="http://schemas.microsoft.com/office/drawing/2014/main" id="{F8C792C4-010B-441E-931F-8D76169CF8C5}"/>
               </a:ext>
             </a:extLst>
           </p:cNvPr>
@@ -6683,7 +6683,7 @@
           <p:cNvPr id="7" name="">
             <a:extLst xmlns:a="http://schemas.openxmlformats.org/drawingml/2006/main">
               <a:ext uri="{FF2B5EF4-FFF2-40B4-BE49-F238E27FC236}">
-                <a16:creationId xmlns:a16="http://schemas.microsoft.com/office/drawing/2014/main" id="{4B6AB21B-0C51-4940-852E-4779C326F481}"/>
+                <a16:creationId xmlns:a16="http://schemas.microsoft.com/office/drawing/2014/main" id="{9EE7E20E-D50A-416A-86A3-ECD7AE080690}"/>
               </a:ext>
             </a:extLst>
           </p:cNvPr>
@@ -6821,7 +6821,7 @@
           <p:cNvPr id="8" name="">
             <a:extLst xmlns:a="http://schemas.openxmlformats.org/drawingml/2006/main">
               <a:ext uri="{FF2B5EF4-FFF2-40B4-BE49-F238E27FC236}">
-                <a16:creationId xmlns:a16="http://schemas.microsoft.com/office/drawing/2014/main" id="{1F508C16-5AF8-4A0F-8F85-B5C642E85060}"/>
+                <a16:creationId xmlns:a16="http://schemas.microsoft.com/office/drawing/2014/main" id="{0DC126B2-2908-4611-A9DF-289C5F6EA61C}"/>
               </a:ext>
             </a:extLst>
           </p:cNvPr>
@@ -6856,7 +6856,7 @@
           <p:cNvPr id="9" name="">
             <a:extLst xmlns:a="http://schemas.openxmlformats.org/drawingml/2006/main">
               <a:ext uri="{FF2B5EF4-FFF2-40B4-BE49-F238E27FC236}">
-                <a16:creationId xmlns:a16="http://schemas.microsoft.com/office/drawing/2014/main" id="{F3CA054D-C494-4A66-B90D-7D1F0F04F9DB}"/>
+                <a16:creationId xmlns:a16="http://schemas.microsoft.com/office/drawing/2014/main" id="{A3F2302C-3CC6-4D51-89BE-ABA0F574B740}"/>
               </a:ext>
             </a:extLst>
           </p:cNvPr>
@@ -6977,7 +6977,7 @@
           <p:cNvPr id="10" name="">
             <a:extLst xmlns:a="http://schemas.openxmlformats.org/drawingml/2006/main">
               <a:ext uri="{FF2B5EF4-FFF2-40B4-BE49-F238E27FC236}">
-                <a16:creationId xmlns:a16="http://schemas.microsoft.com/office/drawing/2014/main" id="{4FF4FBEA-120C-44F0-B230-4EF2C39A6BDA}"/>
+                <a16:creationId xmlns:a16="http://schemas.microsoft.com/office/drawing/2014/main" id="{3F414E94-D4F9-4D72-9313-349786EAA762}"/>
               </a:ext>
             </a:extLst>
           </p:cNvPr>
@@ -7115,7 +7115,7 @@
           <p:cNvPr id="11" name="">
             <a:extLst xmlns:a="http://schemas.openxmlformats.org/drawingml/2006/main">
               <a:ext uri="{FF2B5EF4-FFF2-40B4-BE49-F238E27FC236}">
-                <a16:creationId xmlns:a16="http://schemas.microsoft.com/office/drawing/2014/main" id="{5D667D24-4B02-4C75-8864-880C083B6C61}"/>
+                <a16:creationId xmlns:a16="http://schemas.microsoft.com/office/drawing/2014/main" id="{0EF1F533-50C9-4502-9FDB-B7F80BC0B417}"/>
               </a:ext>
             </a:extLst>
           </p:cNvPr>
@@ -7150,7 +7150,7 @@
           <p:cNvPr id="12" name="">
             <a:extLst xmlns:a="http://schemas.openxmlformats.org/drawingml/2006/main">
               <a:ext uri="{FF2B5EF4-FFF2-40B4-BE49-F238E27FC236}">
-                <a16:creationId xmlns:a16="http://schemas.microsoft.com/office/drawing/2014/main" id="{33AF1022-7469-4DCE-8433-AD2940F242B7}"/>
+                <a16:creationId xmlns:a16="http://schemas.microsoft.com/office/drawing/2014/main" id="{0E9C56DC-A98E-40A9-8259-0C527A8B315B}"/>
               </a:ext>
             </a:extLst>
           </p:cNvPr>
@@ -7271,7 +7271,7 @@
           <p:cNvPr id="13" name="">
             <a:extLst xmlns:a="http://schemas.openxmlformats.org/drawingml/2006/main">
               <a:ext uri="{FF2B5EF4-FFF2-40B4-BE49-F238E27FC236}">
-                <a16:creationId xmlns:a16="http://schemas.microsoft.com/office/drawing/2014/main" id="{96D6E5BE-914C-4C8F-91F0-7013DE148EC0}"/>
+                <a16:creationId xmlns:a16="http://schemas.microsoft.com/office/drawing/2014/main" id="{9A89A34E-32B1-40CC-B037-DF442DD905A4}"/>
               </a:ext>
             </a:extLst>
           </p:cNvPr>
@@ -7409,7 +7409,7 @@
           <p:cNvPr id="14" name="">
             <a:extLst xmlns:a="http://schemas.openxmlformats.org/drawingml/2006/main">
               <a:ext uri="{FF2B5EF4-FFF2-40B4-BE49-F238E27FC236}">
-                <a16:creationId xmlns:a16="http://schemas.microsoft.com/office/drawing/2014/main" id="{C9C956B3-FEA6-4867-87C4-A1698C017B31}"/>
+                <a16:creationId xmlns:a16="http://schemas.microsoft.com/office/drawing/2014/main" id="{00814070-9F7B-46AD-847D-8C2C1BDC62A9}"/>
               </a:ext>
             </a:extLst>
           </p:cNvPr>
@@ -7444,7 +7444,7 @@
           <p:cNvPr id="15" name="">
             <a:extLst xmlns:a="http://schemas.openxmlformats.org/drawingml/2006/main">
               <a:ext uri="{FF2B5EF4-FFF2-40B4-BE49-F238E27FC236}">
-                <a16:creationId xmlns:a16="http://schemas.microsoft.com/office/drawing/2014/main" id="{24D64DD1-F9F7-4EC5-827D-FAACA2554946}"/>
+                <a16:creationId xmlns:a16="http://schemas.microsoft.com/office/drawing/2014/main" id="{40C8129C-17E1-4706-AD22-92C6DD3C7019}"/>
               </a:ext>
             </a:extLst>
           </p:cNvPr>
@@ -7565,7 +7565,7 @@
           <p:cNvPr id="16" name="">
             <a:extLst xmlns:a="http://schemas.openxmlformats.org/drawingml/2006/main">
               <a:ext uri="{FF2B5EF4-FFF2-40B4-BE49-F238E27FC236}">
-                <a16:creationId xmlns:a16="http://schemas.microsoft.com/office/drawing/2014/main" id="{21AD73C2-921B-421A-BF88-BF1468A9113C}"/>
+                <a16:creationId xmlns:a16="http://schemas.microsoft.com/office/drawing/2014/main" id="{825D76A7-EB92-4125-A691-68DE7770041D}"/>
               </a:ext>
             </a:extLst>
           </p:cNvPr>
@@ -7703,7 +7703,7 @@
           <p:cNvPr id="17" name="">
             <a:extLst xmlns:a="http://schemas.openxmlformats.org/drawingml/2006/main">
               <a:ext uri="{FF2B5EF4-FFF2-40B4-BE49-F238E27FC236}">
-                <a16:creationId xmlns:a16="http://schemas.microsoft.com/office/drawing/2014/main" id="{979F8FA3-C68B-4D8A-B243-DA55DA34ED2C}"/>
+                <a16:creationId xmlns:a16="http://schemas.microsoft.com/office/drawing/2014/main" id="{D82850DC-4128-470E-B6A0-818F858F1D2A}"/>
               </a:ext>
             </a:extLst>
           </p:cNvPr>
@@ -7734,7 +7734,7 @@
           <p:cNvPr id="18" name="">
             <a:extLst xmlns:a="http://schemas.openxmlformats.org/drawingml/2006/main">
               <a:ext uri="{FF2B5EF4-FFF2-40B4-BE49-F238E27FC236}">
-                <a16:creationId xmlns:a16="http://schemas.microsoft.com/office/drawing/2014/main" id="{8508F799-7D1F-46BC-BF52-446E2684AFC7}"/>
+                <a16:creationId xmlns:a16="http://schemas.microsoft.com/office/drawing/2014/main" id="{9C4631A0-ABAC-46F7-A640-B647BFA7F2E7}"/>
               </a:ext>
             </a:extLst>
           </p:cNvPr>
@@ -7765,7 +7765,7 @@
           <p:cNvPr id="19" name="">
             <a:extLst xmlns:a="http://schemas.openxmlformats.org/drawingml/2006/main">
               <a:ext uri="{FF2B5EF4-FFF2-40B4-BE49-F238E27FC236}">
-                <a16:creationId xmlns:a16="http://schemas.microsoft.com/office/drawing/2014/main" id="{5F829E89-86C6-497A-976D-524FCF5AF00A}"/>
+                <a16:creationId xmlns:a16="http://schemas.microsoft.com/office/drawing/2014/main" id="{360114F5-8701-4651-9F40-6E96179E27CE}"/>
               </a:ext>
             </a:extLst>
           </p:cNvPr>
@@ -7796,7 +7796,7 @@
           <p:cNvPr id="20" name="">
             <a:extLst xmlns:a="http://schemas.openxmlformats.org/drawingml/2006/main">
               <a:ext uri="{FF2B5EF4-FFF2-40B4-BE49-F238E27FC236}">
-                <a16:creationId xmlns:a16="http://schemas.microsoft.com/office/drawing/2014/main" id="{22EAC340-B076-43F9-873A-4DC70385BC5F}"/>
+                <a16:creationId xmlns:a16="http://schemas.microsoft.com/office/drawing/2014/main" id="{82284633-AAF7-4F1D-90B9-92550D56CCAB}"/>
               </a:ext>
             </a:extLst>
           </p:cNvPr>
@@ -7827,7 +7827,7 @@
           <p:cNvPr id="21" name="">
             <a:extLst xmlns:a="http://schemas.openxmlformats.org/drawingml/2006/main">
               <a:ext uri="{FF2B5EF4-FFF2-40B4-BE49-F238E27FC236}">
-                <a16:creationId xmlns:a16="http://schemas.microsoft.com/office/drawing/2014/main" id="{E0804F40-D49F-456C-B4D9-5FBE62F0E702}"/>
+                <a16:creationId xmlns:a16="http://schemas.microsoft.com/office/drawing/2014/main" id="{AEEE4382-65E3-446F-AE0B-9CFF496FCBCF}"/>
               </a:ext>
             </a:extLst>
           </p:cNvPr>
@@ -7948,7 +7948,7 @@
           <p:cNvPr id="22" name="">
             <a:extLst xmlns:a="http://schemas.openxmlformats.org/drawingml/2006/main">
               <a:ext uri="{FF2B5EF4-FFF2-40B4-BE49-F238E27FC236}">
-                <a16:creationId xmlns:a16="http://schemas.microsoft.com/office/drawing/2014/main" id="{3EC081F8-9431-45CE-9442-7C7CF33578E2}"/>
+                <a16:creationId xmlns:a16="http://schemas.microsoft.com/office/drawing/2014/main" id="{92D78097-15FC-4526-A19B-2813D4E8683F}"/>
               </a:ext>
             </a:extLst>
           </p:cNvPr>
@@ -8086,7 +8086,7 @@
           <p:cNvPr id="23" name="">
             <a:extLst xmlns:a="http://schemas.openxmlformats.org/drawingml/2006/main">
               <a:ext uri="{FF2B5EF4-FFF2-40B4-BE49-F238E27FC236}">
-                <a16:creationId xmlns:a16="http://schemas.microsoft.com/office/drawing/2014/main" id="{ABB859DB-CB91-4F92-BA69-C5A537B41E5D}"/>
+                <a16:creationId xmlns:a16="http://schemas.microsoft.com/office/drawing/2014/main" id="{A5B76CB7-697C-420B-BD7A-650FB425D04B}"/>
               </a:ext>
             </a:extLst>
           </p:cNvPr>
@@ -8207,7 +8207,7 @@
           <p:cNvPr id="24" name="">
             <a:extLst xmlns:a="http://schemas.openxmlformats.org/drawingml/2006/main">
               <a:ext uri="{FF2B5EF4-FFF2-40B4-BE49-F238E27FC236}">
-                <a16:creationId xmlns:a16="http://schemas.microsoft.com/office/drawing/2014/main" id="{040BC6B2-5DCE-4573-8537-2760642990D9}"/>
+                <a16:creationId xmlns:a16="http://schemas.microsoft.com/office/drawing/2014/main" id="{1E1ED870-F86E-44EC-9155-A1221CED3AE4}"/>
               </a:ext>
             </a:extLst>
           </p:cNvPr>
@@ -8326,7 +8326,7 @@
     </p:spTree>
     <p:extLst>
       <p:ext uri="{BB962C8B-B14F-4D97-AF65-F5344CB8AC3E}">
-        <p14:creationId xmlns:p14="http://schemas.microsoft.com/office/powerpoint/2010/main" val="419334688"/>
+        <p14:creationId xmlns:p14="http://schemas.microsoft.com/office/powerpoint/2010/main" val="105949997"/>
       </p:ext>
     </p:extLst>
   </p:cSld>
@@ -8357,7 +8357,7 @@
           <p:cNvPr id="32" name="">
             <a:extLst xmlns:a="http://schemas.openxmlformats.org/drawingml/2006/main">
               <a:ext uri="{FF2B5EF4-FFF2-40B4-BE49-F238E27FC236}">
-                <a16:creationId xmlns:a16="http://schemas.microsoft.com/office/drawing/2014/main" id="{073255EC-682A-40A7-84D5-B261393360D9}"/>
+                <a16:creationId xmlns:a16="http://schemas.microsoft.com/office/drawing/2014/main" id="{57DD1E21-3907-445F-9829-3BF19DEDBC0E}"/>
               </a:ext>
             </a:extLst>
           </p:cNvPr>
@@ -8478,7 +8478,7 @@
           <p:cNvPr id="2" name="">
             <a:extLst xmlns:a="http://schemas.openxmlformats.org/drawingml/2006/main">
               <a:ext uri="{FF2B5EF4-FFF2-40B4-BE49-F238E27FC236}">
-                <a16:creationId xmlns:a16="http://schemas.microsoft.com/office/drawing/2014/main" id="{3249CDBF-9813-4027-8D49-3AE92210E68F}"/>
+                <a16:creationId xmlns:a16="http://schemas.microsoft.com/office/drawing/2014/main" id="{8CF60FA6-8048-41E0-B6B0-C86861E09030}"/>
               </a:ext>
             </a:extLst>
           </p:cNvPr>
@@ -8599,7 +8599,7 @@
           <p:cNvPr id="3" name="">
             <a:extLst xmlns:a="http://schemas.openxmlformats.org/drawingml/2006/main">
               <a:ext uri="{FF2B5EF4-FFF2-40B4-BE49-F238E27FC236}">
-                <a16:creationId xmlns:a16="http://schemas.microsoft.com/office/drawing/2014/main" id="{F214B652-BB81-4D0B-A044-31ED83EAC679}"/>
+                <a16:creationId xmlns:a16="http://schemas.microsoft.com/office/drawing/2014/main" id="{FD03605B-3983-4775-81BD-4FE96B4E4121}"/>
               </a:ext>
             </a:extLst>
           </p:cNvPr>
@@ -8720,7 +8720,7 @@
           <p:cNvPr id="4" name="">
             <a:extLst xmlns:a="http://schemas.openxmlformats.org/drawingml/2006/main">
               <a:ext uri="{FF2B5EF4-FFF2-40B4-BE49-F238E27FC236}">
-                <a16:creationId xmlns:a16="http://schemas.microsoft.com/office/drawing/2014/main" id="{A1B47A71-DFC2-49ED-87A0-EB62C2DA8E28}"/>
+                <a16:creationId xmlns:a16="http://schemas.microsoft.com/office/drawing/2014/main" id="{20919432-743A-440E-A347-6E7463E47EFF}"/>
               </a:ext>
             </a:extLst>
           </p:cNvPr>
@@ -8751,7 +8751,7 @@
           <p:cNvPr id="5" name="">
             <a:extLst xmlns:a="http://schemas.openxmlformats.org/drawingml/2006/main">
               <a:ext uri="{FF2B5EF4-FFF2-40B4-BE49-F238E27FC236}">
-                <a16:creationId xmlns:a16="http://schemas.microsoft.com/office/drawing/2014/main" id="{C2D5478C-C969-4988-A14B-3788E9340DFE}"/>
+                <a16:creationId xmlns:a16="http://schemas.microsoft.com/office/drawing/2014/main" id="{751E156B-C0D9-4424-B3BC-AD6542D4DBE6}"/>
               </a:ext>
             </a:extLst>
           </p:cNvPr>
@@ -8872,7 +8872,7 @@
           <p:cNvPr id="6" name="">
             <a:extLst xmlns:a="http://schemas.openxmlformats.org/drawingml/2006/main">
               <a:ext uri="{FF2B5EF4-FFF2-40B4-BE49-F238E27FC236}">
-                <a16:creationId xmlns:a16="http://schemas.microsoft.com/office/drawing/2014/main" id="{95C3EDCC-ADEE-403D-BA01-20E37E51B460}"/>
+                <a16:creationId xmlns:a16="http://schemas.microsoft.com/office/drawing/2014/main" id="{9C8DF6C2-4785-4C35-ABC0-E3865C50AB6B}"/>
               </a:ext>
             </a:extLst>
           </p:cNvPr>
@@ -8993,7 +8993,7 @@
           <p:cNvPr id="7" name="">
             <a:extLst xmlns:a="http://schemas.openxmlformats.org/drawingml/2006/main">
               <a:ext uri="{FF2B5EF4-FFF2-40B4-BE49-F238E27FC236}">
-                <a16:creationId xmlns:a16="http://schemas.microsoft.com/office/drawing/2014/main" id="{B6ED80F1-411B-4021-8B85-ECDE6A553C78}"/>
+                <a16:creationId xmlns:a16="http://schemas.microsoft.com/office/drawing/2014/main" id="{B0AFB330-6315-43C8-A5DE-5C718BE9ACAF}"/>
               </a:ext>
             </a:extLst>
           </p:cNvPr>
@@ -9024,7 +9024,7 @@
           <p:cNvPr id="8" name="">
             <a:extLst xmlns:a="http://schemas.openxmlformats.org/drawingml/2006/main">
               <a:ext uri="{FF2B5EF4-FFF2-40B4-BE49-F238E27FC236}">
-                <a16:creationId xmlns:a16="http://schemas.microsoft.com/office/drawing/2014/main" id="{0DD9C21C-2AED-446E-AEFC-1DCCCD2DE07A}"/>
+                <a16:creationId xmlns:a16="http://schemas.microsoft.com/office/drawing/2014/main" id="{9FECF414-3454-445E-B6FA-070406628F7F}"/>
               </a:ext>
             </a:extLst>
           </p:cNvPr>
@@ -9055,7 +9055,7 @@
           <p:cNvPr id="9" name="">
             <a:extLst xmlns:a="http://schemas.openxmlformats.org/drawingml/2006/main">
               <a:ext uri="{FF2B5EF4-FFF2-40B4-BE49-F238E27FC236}">
-                <a16:creationId xmlns:a16="http://schemas.microsoft.com/office/drawing/2014/main" id="{7CD79D19-06BF-4402-8F36-9F06CCDC9F86}"/>
+                <a16:creationId xmlns:a16="http://schemas.microsoft.com/office/drawing/2014/main" id="{ACE13634-9864-443B-AEC3-411EB879FE15}"/>
               </a:ext>
             </a:extLst>
           </p:cNvPr>
@@ -9176,7 +9176,7 @@
           <p:cNvPr id="10" name="">
             <a:extLst xmlns:a="http://schemas.openxmlformats.org/drawingml/2006/main">
               <a:ext uri="{FF2B5EF4-FFF2-40B4-BE49-F238E27FC236}">
-                <a16:creationId xmlns:a16="http://schemas.microsoft.com/office/drawing/2014/main" id="{7FB21133-368A-4874-8640-B98BCF702738}"/>
+                <a16:creationId xmlns:a16="http://schemas.microsoft.com/office/drawing/2014/main" id="{3DB055BA-E61F-412B-B7DE-AE44548F04CE}"/>
               </a:ext>
             </a:extLst>
           </p:cNvPr>
@@ -9297,7 +9297,7 @@
           <p:cNvPr id="11" name="">
             <a:extLst xmlns:a="http://schemas.openxmlformats.org/drawingml/2006/main">
               <a:ext uri="{FF2B5EF4-FFF2-40B4-BE49-F238E27FC236}">
-                <a16:creationId xmlns:a16="http://schemas.microsoft.com/office/drawing/2014/main" id="{CB479311-AAB1-41EB-8346-C314CAA4B96E}"/>
+                <a16:creationId xmlns:a16="http://schemas.microsoft.com/office/drawing/2014/main" id="{850F7331-EEBA-459B-B1C6-A19DC42CCB4B}"/>
               </a:ext>
             </a:extLst>
           </p:cNvPr>
@@ -9328,7 +9328,7 @@
           <p:cNvPr id="12" name="">
             <a:extLst xmlns:a="http://schemas.openxmlformats.org/drawingml/2006/main">
               <a:ext uri="{FF2B5EF4-FFF2-40B4-BE49-F238E27FC236}">
-                <a16:creationId xmlns:a16="http://schemas.microsoft.com/office/drawing/2014/main" id="{1889FCD4-62E6-4378-8FA9-1160528D99A1}"/>
+                <a16:creationId xmlns:a16="http://schemas.microsoft.com/office/drawing/2014/main" id="{A48A14E7-3F56-48BC-AEF7-91D31F2336A5}"/>
               </a:ext>
             </a:extLst>
           </p:cNvPr>
@@ -9359,7 +9359,7 @@
           <p:cNvPr id="13" name="">
             <a:extLst xmlns:a="http://schemas.openxmlformats.org/drawingml/2006/main">
               <a:ext uri="{FF2B5EF4-FFF2-40B4-BE49-F238E27FC236}">
-                <a16:creationId xmlns:a16="http://schemas.microsoft.com/office/drawing/2014/main" id="{8863AC76-9324-4160-919D-D4152F174C34}"/>
+                <a16:creationId xmlns:a16="http://schemas.microsoft.com/office/drawing/2014/main" id="{2561A17D-6472-4EE6-98D0-FFDC0910E39D}"/>
               </a:ext>
             </a:extLst>
           </p:cNvPr>
@@ -9480,7 +9480,7 @@
           <p:cNvPr id="14" name="">
             <a:extLst xmlns:a="http://schemas.openxmlformats.org/drawingml/2006/main">
               <a:ext uri="{FF2B5EF4-FFF2-40B4-BE49-F238E27FC236}">
-                <a16:creationId xmlns:a16="http://schemas.microsoft.com/office/drawing/2014/main" id="{F84A094B-40B9-42BF-8B13-B7760A63E0F6}"/>
+                <a16:creationId xmlns:a16="http://schemas.microsoft.com/office/drawing/2014/main" id="{85781A83-DF75-448F-954B-75FCA53F74A5}"/>
               </a:ext>
             </a:extLst>
           </p:cNvPr>
@@ -9601,7 +9601,7 @@
           <p:cNvPr id="15" name="">
             <a:extLst xmlns:a="http://schemas.openxmlformats.org/drawingml/2006/main">
               <a:ext uri="{FF2B5EF4-FFF2-40B4-BE49-F238E27FC236}">
-                <a16:creationId xmlns:a16="http://schemas.microsoft.com/office/drawing/2014/main" id="{5501F65B-B0AE-45E5-958A-EDC5BE737E9A}"/>
+                <a16:creationId xmlns:a16="http://schemas.microsoft.com/office/drawing/2014/main" id="{32294779-BCA6-4B3A-8310-C8369D5F0058}"/>
               </a:ext>
             </a:extLst>
           </p:cNvPr>
@@ -9632,7 +9632,7 @@
           <p:cNvPr id="16" name="">
             <a:extLst xmlns:a="http://schemas.openxmlformats.org/drawingml/2006/main">
               <a:ext uri="{FF2B5EF4-FFF2-40B4-BE49-F238E27FC236}">
-                <a16:creationId xmlns:a16="http://schemas.microsoft.com/office/drawing/2014/main" id="{91737773-F398-4DE0-A14D-B6B3B69B1D43}"/>
+                <a16:creationId xmlns:a16="http://schemas.microsoft.com/office/drawing/2014/main" id="{FE04D990-125E-4DA9-85C2-8C93198478D0}"/>
               </a:ext>
             </a:extLst>
           </p:cNvPr>
@@ -9663,7 +9663,7 @@
           <p:cNvPr id="17" name="">
             <a:extLst xmlns:a="http://schemas.openxmlformats.org/drawingml/2006/main">
               <a:ext uri="{FF2B5EF4-FFF2-40B4-BE49-F238E27FC236}">
-                <a16:creationId xmlns:a16="http://schemas.microsoft.com/office/drawing/2014/main" id="{96BF96D0-CCD3-463C-B817-9FE5B1EDA581}"/>
+                <a16:creationId xmlns:a16="http://schemas.microsoft.com/office/drawing/2014/main" id="{1AC62841-7116-4315-834B-975DA5774C00}"/>
               </a:ext>
             </a:extLst>
           </p:cNvPr>
@@ -9784,7 +9784,7 @@
           <p:cNvPr id="18" name="">
             <a:extLst xmlns:a="http://schemas.openxmlformats.org/drawingml/2006/main">
               <a:ext uri="{FF2B5EF4-FFF2-40B4-BE49-F238E27FC236}">
-                <a16:creationId xmlns:a16="http://schemas.microsoft.com/office/drawing/2014/main" id="{9AD87291-27E8-438E-AB8C-AC6ED62B2895}"/>
+                <a16:creationId xmlns:a16="http://schemas.microsoft.com/office/drawing/2014/main" id="{C2320198-0452-4CBE-8F15-462409EAA86F}"/>
               </a:ext>
             </a:extLst>
           </p:cNvPr>
@@ -9905,7 +9905,7 @@
           <p:cNvPr id="19" name="">
             <a:extLst xmlns:a="http://schemas.openxmlformats.org/drawingml/2006/main">
               <a:ext uri="{FF2B5EF4-FFF2-40B4-BE49-F238E27FC236}">
-                <a16:creationId xmlns:a16="http://schemas.microsoft.com/office/drawing/2014/main" id="{C79346E0-CCEF-4990-91DA-C3DAB8F68737}"/>
+                <a16:creationId xmlns:a16="http://schemas.microsoft.com/office/drawing/2014/main" id="{1EEAB447-BB00-476D-8C92-92D51F611C6B}"/>
               </a:ext>
             </a:extLst>
           </p:cNvPr>
@@ -9936,7 +9936,7 @@
           <p:cNvPr id="20" name="">
             <a:extLst xmlns:a="http://schemas.openxmlformats.org/drawingml/2006/main">
               <a:ext uri="{FF2B5EF4-FFF2-40B4-BE49-F238E27FC236}">
-                <a16:creationId xmlns:a16="http://schemas.microsoft.com/office/drawing/2014/main" id="{AE716A24-7AC6-46F6-BB22-37BC324C621B}"/>
+                <a16:creationId xmlns:a16="http://schemas.microsoft.com/office/drawing/2014/main" id="{E542F4F5-6A71-40A7-9869-F4B7C0C72503}"/>
               </a:ext>
             </a:extLst>
           </p:cNvPr>
@@ -9967,7 +9967,7 @@
           <p:cNvPr id="21" name="">
             <a:extLst xmlns:a="http://schemas.openxmlformats.org/drawingml/2006/main">
               <a:ext uri="{FF2B5EF4-FFF2-40B4-BE49-F238E27FC236}">
-                <a16:creationId xmlns:a16="http://schemas.microsoft.com/office/drawing/2014/main" id="{E54A317C-1079-4418-AF82-30F1094C749B}"/>
+                <a16:creationId xmlns:a16="http://schemas.microsoft.com/office/drawing/2014/main" id="{02B3ABB8-5C41-467B-B689-46CEED4AAE1C}"/>
               </a:ext>
             </a:extLst>
           </p:cNvPr>
@@ -10088,7 +10088,7 @@
           <p:cNvPr id="22" name="">
             <a:extLst xmlns:a="http://schemas.openxmlformats.org/drawingml/2006/main">
               <a:ext uri="{FF2B5EF4-FFF2-40B4-BE49-F238E27FC236}">
-                <a16:creationId xmlns:a16="http://schemas.microsoft.com/office/drawing/2014/main" id="{4D4E8E93-D5EB-4E0B-9D19-ACF6D64C9F2D}"/>
+                <a16:creationId xmlns:a16="http://schemas.microsoft.com/office/drawing/2014/main" id="{CEA0D362-6704-4D45-8349-3E742F140C4D}"/>
               </a:ext>
             </a:extLst>
           </p:cNvPr>
@@ -10209,7 +10209,7 @@
           <p:cNvPr id="23" name="">
             <a:extLst xmlns:a="http://schemas.openxmlformats.org/drawingml/2006/main">
               <a:ext uri="{FF2B5EF4-FFF2-40B4-BE49-F238E27FC236}">
-                <a16:creationId xmlns:a16="http://schemas.microsoft.com/office/drawing/2014/main" id="{AC48B126-178B-4D6A-B165-DA004CF995C8}"/>
+                <a16:creationId xmlns:a16="http://schemas.microsoft.com/office/drawing/2014/main" id="{78F38A8C-72EB-42C5-80BF-1A0E12EFB895}"/>
               </a:ext>
             </a:extLst>
           </p:cNvPr>
@@ -10240,7 +10240,7 @@
           <p:cNvPr id="24" name="">
             <a:extLst xmlns:a="http://schemas.openxmlformats.org/drawingml/2006/main">
               <a:ext uri="{FF2B5EF4-FFF2-40B4-BE49-F238E27FC236}">
-                <a16:creationId xmlns:a16="http://schemas.microsoft.com/office/drawing/2014/main" id="{DA85791C-1EFB-46BD-B10E-F885E4BADD39}"/>
+                <a16:creationId xmlns:a16="http://schemas.microsoft.com/office/drawing/2014/main" id="{CF6B8446-C887-40BE-A1F4-2032FDFFC03B}"/>
               </a:ext>
             </a:extLst>
           </p:cNvPr>
@@ -10271,7 +10271,7 @@
           <p:cNvPr id="25" name="">
             <a:extLst xmlns:a="http://schemas.openxmlformats.org/drawingml/2006/main">
               <a:ext uri="{FF2B5EF4-FFF2-40B4-BE49-F238E27FC236}">
-                <a16:creationId xmlns:a16="http://schemas.microsoft.com/office/drawing/2014/main" id="{936ECCED-787D-4A69-8927-4BE54CB95021}"/>
+                <a16:creationId xmlns:a16="http://schemas.microsoft.com/office/drawing/2014/main" id="{598C15D7-29C0-4E7A-B8F6-0E6A217DFE48}"/>
               </a:ext>
             </a:extLst>
           </p:cNvPr>
@@ -10392,7 +10392,7 @@
           <p:cNvPr id="26" name="">
             <a:extLst xmlns:a="http://schemas.openxmlformats.org/drawingml/2006/main">
               <a:ext uri="{FF2B5EF4-FFF2-40B4-BE49-F238E27FC236}">
-                <a16:creationId xmlns:a16="http://schemas.microsoft.com/office/drawing/2014/main" id="{2FAE1A24-0DBA-4549-B938-2758DD607B15}"/>
+                <a16:creationId xmlns:a16="http://schemas.microsoft.com/office/drawing/2014/main" id="{ABBE508D-70DC-46E4-A310-914E1BAEDEA9}"/>
               </a:ext>
             </a:extLst>
           </p:cNvPr>
@@ -10423,7 +10423,7 @@
           <p:cNvPr id="27" name="">
             <a:extLst xmlns:a="http://schemas.openxmlformats.org/drawingml/2006/main">
               <a:ext uri="{FF2B5EF4-FFF2-40B4-BE49-F238E27FC236}">
-                <a16:creationId xmlns:a16="http://schemas.microsoft.com/office/drawing/2014/main" id="{716A34A4-B588-4AD0-807F-F46319ED94B0}"/>
+                <a16:creationId xmlns:a16="http://schemas.microsoft.com/office/drawing/2014/main" id="{2DB9469C-1959-4F70-BE63-768A1D47079A}"/>
               </a:ext>
             </a:extLst>
           </p:cNvPr>
@@ -10544,7 +10544,7 @@
           <p:cNvPr id="28" name="">
             <a:extLst xmlns:a="http://schemas.openxmlformats.org/drawingml/2006/main">
               <a:ext uri="{FF2B5EF4-FFF2-40B4-BE49-F238E27FC236}">
-                <a16:creationId xmlns:a16="http://schemas.microsoft.com/office/drawing/2014/main" id="{8BEFC7A2-064A-4038-B013-2F545EBB5850}"/>
+                <a16:creationId xmlns:a16="http://schemas.microsoft.com/office/drawing/2014/main" id="{95F21725-F93F-4646-85CB-47B176386786}"/>
               </a:ext>
             </a:extLst>
           </p:cNvPr>
@@ -10665,7 +10665,7 @@
           <p:cNvPr id="29" name="">
             <a:extLst xmlns:a="http://schemas.openxmlformats.org/drawingml/2006/main">
               <a:ext uri="{FF2B5EF4-FFF2-40B4-BE49-F238E27FC236}">
-                <a16:creationId xmlns:a16="http://schemas.microsoft.com/office/drawing/2014/main" id="{629B4A2A-E6A8-4E47-A97A-3573B106D3A7}"/>
+                <a16:creationId xmlns:a16="http://schemas.microsoft.com/office/drawing/2014/main" id="{392AB510-2F4B-48CB-9984-45125F910355}"/>
               </a:ext>
             </a:extLst>
           </p:cNvPr>
@@ -10786,7 +10786,7 @@
           <p:cNvPr id="30" name="">
             <a:extLst xmlns:a="http://schemas.openxmlformats.org/drawingml/2006/main">
               <a:ext uri="{FF2B5EF4-FFF2-40B4-BE49-F238E27FC236}">
-                <a16:creationId xmlns:a16="http://schemas.microsoft.com/office/drawing/2014/main" id="{F7D9FDBA-9136-4167-AE4A-D92831327D1C}"/>
+                <a16:creationId xmlns:a16="http://schemas.microsoft.com/office/drawing/2014/main" id="{A49FB99E-0F6C-4654-B8D1-C509AB92B7C5}"/>
               </a:ext>
             </a:extLst>
           </p:cNvPr>
@@ -10907,7 +10907,7 @@
           <p:cNvPr id="31" name="">
             <a:extLst xmlns:a="http://schemas.openxmlformats.org/drawingml/2006/main">
               <a:ext uri="{FF2B5EF4-FFF2-40B4-BE49-F238E27FC236}">
-                <a16:creationId xmlns:a16="http://schemas.microsoft.com/office/drawing/2014/main" id="{F9168985-8F73-438B-A175-21DB8BF8A661}"/>
+                <a16:creationId xmlns:a16="http://schemas.microsoft.com/office/drawing/2014/main" id="{3F2E561F-C0B9-4EFA-986D-6597E923B624}"/>
               </a:ext>
             </a:extLst>
           </p:cNvPr>
@@ -11026,7 +11026,7 @@
     </p:spTree>
     <p:extLst>
       <p:ext uri="{BB962C8B-B14F-4D97-AF65-F5344CB8AC3E}">
-        <p14:creationId xmlns:p14="http://schemas.microsoft.com/office/powerpoint/2010/main" val="1450188947"/>
+        <p14:creationId xmlns:p14="http://schemas.microsoft.com/office/powerpoint/2010/main" val="167123921"/>
       </p:ext>
     </p:extLst>
   </p:cSld>
@@ -11057,7 +11057,7 @@
           <p:cNvPr id="11" name="">
             <a:extLst xmlns:a="http://schemas.openxmlformats.org/drawingml/2006/main">
               <a:ext uri="{FF2B5EF4-FFF2-40B4-BE49-F238E27FC236}">
-                <a16:creationId xmlns:a16="http://schemas.microsoft.com/office/drawing/2014/main" id="{66EFA8D1-B559-4A9D-841C-847016B9AA85}"/>
+                <a16:creationId xmlns:a16="http://schemas.microsoft.com/office/drawing/2014/main" id="{5FED3027-7545-48B9-B908-66E873C2F8A2}"/>
               </a:ext>
             </a:extLst>
           </p:cNvPr>
@@ -11178,7 +11178,7 @@
           <p:cNvPr id="2" name="">
             <a:extLst xmlns:a="http://schemas.openxmlformats.org/drawingml/2006/main">
               <a:ext uri="{FF2B5EF4-FFF2-40B4-BE49-F238E27FC236}">
-                <a16:creationId xmlns:a16="http://schemas.microsoft.com/office/drawing/2014/main" id="{9441F9FC-701C-4EB4-8739-3E133599E5DD}"/>
+                <a16:creationId xmlns:a16="http://schemas.microsoft.com/office/drawing/2014/main" id="{93323019-F024-4526-AE1A-418E149CA7F5}"/>
               </a:ext>
             </a:extLst>
           </p:cNvPr>
@@ -11299,7 +11299,7 @@
           <p:cNvPr id="3" name="">
             <a:extLst xmlns:a="http://schemas.openxmlformats.org/drawingml/2006/main">
               <a:ext uri="{FF2B5EF4-FFF2-40B4-BE49-F238E27FC236}">
-                <a16:creationId xmlns:a16="http://schemas.microsoft.com/office/drawing/2014/main" id="{39411B8D-F609-42C4-940B-BE56CD451B56}"/>
+                <a16:creationId xmlns:a16="http://schemas.microsoft.com/office/drawing/2014/main" id="{2ADAF9FC-DC97-4863-B3C9-10D19945762B}"/>
               </a:ext>
             </a:extLst>
           </p:cNvPr>
@@ -11330,7 +11330,7 @@
           <p:cNvPr id="4" name="">
             <a:extLst xmlns:a="http://schemas.openxmlformats.org/drawingml/2006/main">
               <a:ext uri="{FF2B5EF4-FFF2-40B4-BE49-F238E27FC236}">
-                <a16:creationId xmlns:a16="http://schemas.microsoft.com/office/drawing/2014/main" id="{509220C7-CB88-4A5C-919F-EF5DEA9BDB3F}"/>
+                <a16:creationId xmlns:a16="http://schemas.microsoft.com/office/drawing/2014/main" id="{444D5B97-15C6-42D8-8FFF-1FDFBD2DD196}"/>
               </a:ext>
             </a:extLst>
           </p:cNvPr>
@@ -11451,7 +11451,7 @@
           <p:cNvPr id="5" name="">
             <a:extLst xmlns:a="http://schemas.openxmlformats.org/drawingml/2006/main">
               <a:ext uri="{FF2B5EF4-FFF2-40B4-BE49-F238E27FC236}">
-                <a16:creationId xmlns:a16="http://schemas.microsoft.com/office/drawing/2014/main" id="{6AF8EE19-291F-47B3-AE3E-8A735DC8C8C2}"/>
+                <a16:creationId xmlns:a16="http://schemas.microsoft.com/office/drawing/2014/main" id="{DF9199D1-0A68-4AF4-9A76-D2F5FDC9CAC2}"/>
               </a:ext>
             </a:extLst>
           </p:cNvPr>
@@ -11640,7 +11640,7 @@
           <p:cNvPr id="6" name="">
             <a:extLst xmlns:a="http://schemas.openxmlformats.org/drawingml/2006/main">
               <a:ext uri="{FF2B5EF4-FFF2-40B4-BE49-F238E27FC236}">
-                <a16:creationId xmlns:a16="http://schemas.microsoft.com/office/drawing/2014/main" id="{4B283543-0B57-4D67-A717-F474CAA0F0A5}"/>
+                <a16:creationId xmlns:a16="http://schemas.microsoft.com/office/drawing/2014/main" id="{A9C80F94-D58D-4655-BC17-2D187650A2EC}"/>
               </a:ext>
             </a:extLst>
           </p:cNvPr>
@@ -11671,7 +11671,7 @@
           <p:cNvPr id="7" name="">
             <a:extLst xmlns:a="http://schemas.openxmlformats.org/drawingml/2006/main">
               <a:ext uri="{FF2B5EF4-FFF2-40B4-BE49-F238E27FC236}">
-                <a16:creationId xmlns:a16="http://schemas.microsoft.com/office/drawing/2014/main" id="{68E1346D-322B-482A-80D2-7BA5A08A1EAB}"/>
+                <a16:creationId xmlns:a16="http://schemas.microsoft.com/office/drawing/2014/main" id="{76AAE91D-1F13-4494-B003-04022108ABB5}"/>
               </a:ext>
             </a:extLst>
           </p:cNvPr>
@@ -11792,7 +11792,7 @@
           <p:cNvPr id="8" name="">
             <a:extLst xmlns:a="http://schemas.openxmlformats.org/drawingml/2006/main">
               <a:ext uri="{FF2B5EF4-FFF2-40B4-BE49-F238E27FC236}">
-                <a16:creationId xmlns:a16="http://schemas.microsoft.com/office/drawing/2014/main" id="{33B5C43D-50FF-4ED8-9162-6AA5C462D058}"/>
+                <a16:creationId xmlns:a16="http://schemas.microsoft.com/office/drawing/2014/main" id="{A5801B79-04C3-4518-997D-7E72504904DF}"/>
               </a:ext>
             </a:extLst>
           </p:cNvPr>
@@ -11981,7 +11981,7 @@
           <p:cNvPr id="9" name="">
             <a:extLst xmlns:a="http://schemas.openxmlformats.org/drawingml/2006/main">
               <a:ext uri="{FF2B5EF4-FFF2-40B4-BE49-F238E27FC236}">
-                <a16:creationId xmlns:a16="http://schemas.microsoft.com/office/drawing/2014/main" id="{F91A0C49-5BB7-4B71-A233-A8EA5A6AD277}"/>
+                <a16:creationId xmlns:a16="http://schemas.microsoft.com/office/drawing/2014/main" id="{EC54C871-9DD2-4313-9D8A-24732506C6EF}"/>
               </a:ext>
             </a:extLst>
           </p:cNvPr>
@@ -12102,7 +12102,7 @@
           <p:cNvPr id="10" name="">
             <a:extLst xmlns:a="http://schemas.openxmlformats.org/drawingml/2006/main">
               <a:ext uri="{FF2B5EF4-FFF2-40B4-BE49-F238E27FC236}">
-                <a16:creationId xmlns:a16="http://schemas.microsoft.com/office/drawing/2014/main" id="{12B7BA4E-36F2-49B0-B7D7-2A6974BD5934}"/>
+                <a16:creationId xmlns:a16="http://schemas.microsoft.com/office/drawing/2014/main" id="{0E4F8760-2280-42DE-9C71-A73DE19E52F4}"/>
               </a:ext>
             </a:extLst>
           </p:cNvPr>
@@ -12221,7 +12221,7 @@
     </p:spTree>
     <p:extLst>
       <p:ext uri="{BB962C8B-B14F-4D97-AF65-F5344CB8AC3E}">
-        <p14:creationId xmlns:p14="http://schemas.microsoft.com/office/powerpoint/2010/main" val="874333172"/>
+        <p14:creationId xmlns:p14="http://schemas.microsoft.com/office/powerpoint/2010/main" val="1832772036"/>
       </p:ext>
     </p:extLst>
   </p:cSld>

</xml_diff>